<commit_message>
Tested on real data: Olist's public orders, a Colab notebook, and the results in the slides and on the page
The notebook reads the Brazilian E-Commerce Public Dataset by Olist straight
from GitHub (99,441 orders, 2016 to 2018), builds four numbers for the 383
products ordered at least 30 times (orders, season index, volume, weight),
scales them and runs K-Means. The elbow bends at k = 4 and the clusters read
as fast movers, bulky / heavy, seasonal and regular small items.

Slides 8 to 12 now show the real table, the real elbow curve and the real
clusters. The page has a Tested on real data section with a Colab button, the
dataset link and the cluster table; the interactive demo below it still uses
example data and says so. The walking figure stays a simple model.

The dataset has no handling field, so weight stands in for handling needs.
</commit_message>
<xml_diff>
--- a/slides/kmeans-sku-clustering.pptx
+++ b/slides/kmeans-sku-clustering.pptx
@@ -118,21 +118,21 @@
   <p:extLst>
     <p:ext uri="{521415D9-36F7-43E2-AB2F-B90AF26B5E84}">
       <p14:sectionLst xmlns:p14="http://schemas.microsoft.com/office/powerpoint/2010/main">
-        <p14:section name="Problem" id="{220aa23e-7b3a-2f85-fca2-cc0ae379e0f4}">
+        <p14:section name="Problem" id="{04b5fd4c-d15a-0013-9e89-cd1b8c9f18e1}">
           <p14:sldIdLst>
             <p14:sldId id="256"/>
             <p14:sldId id="257"/>
             <p14:sldId id="258"/>
           </p14:sldIdLst>
         </p14:section>
-        <p14:section name="Choosing the solution" id="{53bbf09a-db3d-dce3-dc08-666114c20a97}">
+        <p14:section name="Choosing the solution" id="{f7ffc76c-05dc-2732-1bb6-eb9780c7d120}">
           <p14:sldIdLst>
             <p14:sldId id="259"/>
             <p14:sldId id="260"/>
             <p14:sldId id="261"/>
           </p14:sldIdLst>
         </p14:section>
-        <p14:section name="Applying K-Means" id="{82ea52dc-de33-c410-82e5-169d5700403c}">
+        <p14:section name="Applying K-Means" id="{da5b0630-31ec-6cc5-5325-7ddc06f37602}">
           <p14:sldIdLst>
             <p14:sldId id="262"/>
             <p14:sldId id="263"/>
@@ -140,7 +140,7 @@
             <p14:sldId id="265"/>
           </p14:sldIdLst>
         </p14:section>
-        <p14:section name="Conclusion" id="{4f77ac48-a01b-9f6d-a905-c622d36b5539}">
+        <p14:section name="Conclusion" id="{658f8e6a-05b0-e5a3-7a84-51a87b2df996}">
           <p14:sldIdLst>
             <p14:sldId id="266"/>
             <p14:sldId id="267"/>
@@ -181,7 +181,7 @@
                 </a:solidFill>
                 <a:latin typeface="+mn-lt"/>
               </a:rPr>
-              <a:t>Example elbow curve (illustrative)</a:t>
+              <a:t>Elbow curve on the real data (383 SKUs)</a:t>
             </a:r>
           </a:p>
         </c:rich>
@@ -304,28 +304,28 @@
                 <c:formatCode>General</c:formatCode>
                 <c:ptCount val="8"/>
                 <c:pt idx="0">
-                  <c:v>100</c:v>
+                  <c:v>1532</c:v>
                 </c:pt>
                 <c:pt idx="1">
-                  <c:v>62</c:v>
+                  <c:v>1025.2</c:v>
                 </c:pt>
                 <c:pt idx="2">
-                  <c:v>38</c:v>
+                  <c:v>772.5</c:v>
                 </c:pt>
                 <c:pt idx="3">
-                  <c:v>24</c:v>
+                  <c:v>600.1</c:v>
                 </c:pt>
                 <c:pt idx="4">
-                  <c:v>20</c:v>
+                  <c:v>511</c:v>
                 </c:pt>
                 <c:pt idx="5">
-                  <c:v>18</c:v>
+                  <c:v>453.9</c:v>
                 </c:pt>
                 <c:pt idx="6">
-                  <c:v>16.5</c:v>
+                  <c:v>410.9</c:v>
                 </c:pt>
                 <c:pt idx="7">
-                  <c:v>15.5</c:v>
+                  <c:v>368.2</c:v>
                 </c:pt>
               </c:numCache>
             </c:numRef>
@@ -1018,7 +1018,7 @@
           <a:p>
             <a:r>
               <a:rPr lang="en-US" dirty="0"/>
-              <a:t>After K-Means runs, each cluster is a group of similar SKUs. The manager gives each cluster a zone. Fast movers go closest to packing. Seasonal items go to a flexible zone. Bulky items stay at ground level near the dock. Fragile items get a protected area. These four clusters are an example.</a:t>
+              <a:t>These are the four clusters K-Means found in the real data. Fast movers: 76 SKUs, ordered about 160 times each, so they go closest to packing. Bulky and heavy: 84 SKUs, about 47 litres and 7.6 kilos, kept at ground level. Seasonal: 25 SKUs whose orders bunch into one month, kept in a flexible zone. Regular small items: 198 SKUs, on the back racks.</a:t>
             </a:r>
             <a:endParaRPr lang="en-US" dirty="0"/>
           </a:p>
@@ -1106,7 +1106,7 @@
           <a:p>
             <a:r>
               <a:rPr lang="en-US" dirty="0"/>
-              <a:t>Link back to the problem statement. The goal was better placement and less travel time. Fast movers near packing means less walking. Similar products together means better placement. And when demand changes with the season, we simply run K-Means again.</a:t>
+              <a:t>Link back to the problem statement. Fast movers sit closest to packing. In our simple one-aisle model the walk per pick falls from about 64 metres to about 47 metres, which is 27 percent less. Say clearly that this is a model, not a measurement. Bulky and heavy products get their own ground-level zone, and seasonal products are one group that is easy to move forward in season.</a:t>
             </a:r>
             <a:endParaRPr lang="en-US" dirty="0"/>
           </a:p>
@@ -1194,7 +1194,7 @@
           <a:p>
             <a:r>
               <a:rPr lang="en-US" dirty="0"/>
-              <a:t>Close with the three points: the problem, the chosen solution and the outcome. Mention the next step, then invite questions.</a:t>
+              <a:t>Close with the three points: the problem, the chosen solution, and the test on real data. Point to the live demo and the Colab code, then invite questions.</a:t>
             </a:r>
             <a:endParaRPr lang="en-US" dirty="0"/>
           </a:p>
@@ -1810,7 +1810,7 @@
           <a:p>
             <a:r>
               <a:rPr lang="en-US" dirty="0"/>
-              <a:t>First we turn every SKU into a row of numbers. The table is made-up example data, only to show the idea. Handling needs become 0 or 1 flags. Then we scale the columns, because K-Means uses distance and a large number like volume would otherwise dominate.</a:t>
+              <a:t>We used real data: the public e-commerce dataset from Olist, with about ninety-nine thousand orders from 2016 to 2018. We kept the 383 products that were ordered at least 30 times. Each SKU becomes a row of four numbers: orders, season index, volume and weight. Weight stands for handling needs, because the dataset has no handling field. Orders, volume and weight are very uneven, so we take their log, and then bring every column to the same scale.</a:t>
             </a:r>
             <a:endParaRPr lang="en-US" dirty="0"/>
           </a:p>
@@ -1898,7 +1898,7 @@
           <a:p>
             <a:r>
               <a:rPr lang="en-US" dirty="0"/>
-              <a:t>K-Means needs k before it starts. We use the elbow method from Unit 3. Run K-Means for many values of k and plot the within-cluster variance. The curve falls fast and then flattens. The bend is the best k. The curve shown is an illustration, where the bend is at k equal to 4.</a:t>
+              <a:t>K-Means needs k before it starts. We used the elbow method from Unit 3 on the real data. We ran K-Means for k from 1 to 8 and plotted the within-cluster variance. The error falls by 33, 25 and 22 percent up to k equal to 4, and then only by 15 percent. So the bend is at 4, and we use 4 clusters.</a:t>
             </a:r>
             <a:endParaRPr lang="en-US" dirty="0"/>
           </a:p>
@@ -3738,8 +3738,8 @@
               <a:tblPr/>
               <a:tblGrid>
                 <a:gridCol w="1508760"/>
-                <a:gridCol w="1737360"/>
-                <a:gridCol w="1874520"/>
+                <a:gridCol w="1783080"/>
+                <a:gridCol w="1828800"/>
               </a:tblGrid>
               <a:tr h="411480">
                 <a:tc>
@@ -3941,7 +3941,7 @@
                             <a:schemeClr val="tx2"/>
                           </a:solidFill>
                         </a:rPr>
-                        <a:t>1  Fast movers</a:t>
+                        <a:t>A  Fast movers</a:t>
                       </a:r>
                       <a:endParaRPr lang="en-US" sz="1400" dirty="0"/>
                     </a:p>
@@ -3999,7 +3999,7 @@
                             <a:schemeClr val="tx1"/>
                           </a:solidFill>
                         </a:rPr>
-                        <a:t>Picked very often, small</a:t>
+                        <a:t>76 SKUs, about 160 orders each</a:t>
                       </a:r>
                       <a:endParaRPr lang="en-US" sz="1400" dirty="0"/>
                     </a:p>
@@ -4117,7 +4117,7 @@
                             <a:schemeClr val="tx2"/>
                           </a:solidFill>
                         </a:rPr>
-                        <a:t>2  Seasonal</a:t>
+                        <a:t>B  Bulky / heavy</a:t>
                       </a:r>
                       <a:endParaRPr lang="en-US" sz="1400" dirty="0"/>
                     </a:p>
@@ -4175,7 +4175,183 @@
                             <a:schemeClr val="tx1"/>
                           </a:solidFill>
                         </a:rPr>
-                        <a:t>Sell fast in some months</a:t>
+                        <a:t>84 SKUs, about 47 L and 7.6 kg</a:t>
+                      </a:r>
+                      <a:endParaRPr lang="en-US" sz="1400" dirty="0"/>
+                    </a:p>
+                  </a:txBody>
+                  <a:tcPr marL="91440" marR="91440" marT="36576" marB="36576" anchor="ctr">
+                    <a:lnL w="9525" cap="flat" cmpd="sng" algn="ctr">
+                      <a:solidFill>
+                        <a:srgbClr val="EAF2F3"/>
+                      </a:solidFill>
+                      <a:prstDash val="solid"/>
+                      <a:round/>
+                      <a:headEnd type="none" w="med" len="med"/>
+                      <a:tailEnd type="none" w="med" len="med"/>
+                    </a:lnL>
+                    <a:lnR w="9525" cap="flat" cmpd="sng" algn="ctr">
+                      <a:solidFill>
+                        <a:srgbClr val="EAF2F3"/>
+                      </a:solidFill>
+                      <a:prstDash val="solid"/>
+                      <a:round/>
+                      <a:headEnd type="none" w="med" len="med"/>
+                      <a:tailEnd type="none" w="med" len="med"/>
+                    </a:lnR>
+                    <a:lnT w="9525" cap="flat" cmpd="sng" algn="ctr">
+                      <a:solidFill>
+                        <a:srgbClr val="EAF2F3"/>
+                      </a:solidFill>
+                      <a:prstDash val="solid"/>
+                      <a:round/>
+                      <a:headEnd type="none" w="med" len="med"/>
+                      <a:tailEnd type="none" w="med" len="med"/>
+                    </a:lnT>
+                    <a:lnB w="9525" cap="flat" cmpd="sng" algn="ctr">
+                      <a:solidFill>
+                        <a:srgbClr val="EAF2F3"/>
+                      </a:solidFill>
+                      <a:prstDash val="solid"/>
+                      <a:round/>
+                      <a:headEnd type="none" w="med" len="med"/>
+                      <a:tailEnd type="none" w="med" len="med"/>
+                    </a:lnB>
+                  </a:tcPr>
+                </a:tc>
+                <a:tc>
+                  <a:txBody>
+                    <a:bodyPr/>
+                    <a:lstStyle/>
+                    <a:p>
+                      <a:pPr indent="0" marL="0">
+                        <a:buNone/>
+                      </a:pPr>
+                      <a:r>
+                        <a:rPr lang="en-US" sz="1400" dirty="0">
+                          <a:solidFill>
+                            <a:schemeClr val="tx1"/>
+                          </a:solidFill>
+                        </a:rPr>
+                        <a:t>Ground level, low racks</a:t>
+                      </a:r>
+                      <a:endParaRPr lang="en-US" sz="1400" dirty="0"/>
+                    </a:p>
+                  </a:txBody>
+                  <a:tcPr marL="91440" marR="91440" marT="36576" marB="36576" anchor="ctr">
+                    <a:lnL w="9525" cap="flat" cmpd="sng" algn="ctr">
+                      <a:solidFill>
+                        <a:srgbClr val="EAF2F3"/>
+                      </a:solidFill>
+                      <a:prstDash val="solid"/>
+                      <a:round/>
+                      <a:headEnd type="none" w="med" len="med"/>
+                      <a:tailEnd type="none" w="med" len="med"/>
+                    </a:lnL>
+                    <a:lnR w="9525" cap="flat" cmpd="sng" algn="ctr">
+                      <a:solidFill>
+                        <a:srgbClr val="EAF2F3"/>
+                      </a:solidFill>
+                      <a:prstDash val="solid"/>
+                      <a:round/>
+                      <a:headEnd type="none" w="med" len="med"/>
+                      <a:tailEnd type="none" w="med" len="med"/>
+                    </a:lnR>
+                    <a:lnT w="9525" cap="flat" cmpd="sng" algn="ctr">
+                      <a:solidFill>
+                        <a:srgbClr val="EAF2F3"/>
+                      </a:solidFill>
+                      <a:prstDash val="solid"/>
+                      <a:round/>
+                      <a:headEnd type="none" w="med" len="med"/>
+                      <a:tailEnd type="none" w="med" len="med"/>
+                    </a:lnT>
+                    <a:lnB w="9525" cap="flat" cmpd="sng" algn="ctr">
+                      <a:solidFill>
+                        <a:srgbClr val="EAF2F3"/>
+                      </a:solidFill>
+                      <a:prstDash val="solid"/>
+                      <a:round/>
+                      <a:headEnd type="none" w="med" len="med"/>
+                      <a:tailEnd type="none" w="med" len="med"/>
+                    </a:lnB>
+                  </a:tcPr>
+                </a:tc>
+              </a:tr>
+              <a:tr h="621792">
+                <a:tc>
+                  <a:txBody>
+                    <a:bodyPr/>
+                    <a:lstStyle/>
+                    <a:p>
+                      <a:pPr indent="0" marL="0">
+                        <a:buNone/>
+                      </a:pPr>
+                      <a:r>
+                        <a:rPr lang="en-US" sz="1400" b="1" dirty="0">
+                          <a:solidFill>
+                            <a:schemeClr val="tx2"/>
+                          </a:solidFill>
+                        </a:rPr>
+                        <a:t>C  Seasonal</a:t>
+                      </a:r>
+                      <a:endParaRPr lang="en-US" sz="1400" dirty="0"/>
+                    </a:p>
+                  </a:txBody>
+                  <a:tcPr marL="91440" marR="91440" marT="36576" marB="36576" anchor="ctr">
+                    <a:lnL w="9525" cap="flat" cmpd="sng" algn="ctr">
+                      <a:solidFill>
+                        <a:srgbClr val="EAF2F3"/>
+                      </a:solidFill>
+                      <a:prstDash val="solid"/>
+                      <a:round/>
+                      <a:headEnd type="none" w="med" len="med"/>
+                      <a:tailEnd type="none" w="med" len="med"/>
+                    </a:lnL>
+                    <a:lnR w="9525" cap="flat" cmpd="sng" algn="ctr">
+                      <a:solidFill>
+                        <a:srgbClr val="EAF2F3"/>
+                      </a:solidFill>
+                      <a:prstDash val="solid"/>
+                      <a:round/>
+                      <a:headEnd type="none" w="med" len="med"/>
+                      <a:tailEnd type="none" w="med" len="med"/>
+                    </a:lnR>
+                    <a:lnT w="9525" cap="flat" cmpd="sng" algn="ctr">
+                      <a:solidFill>
+                        <a:srgbClr val="EAF2F3"/>
+                      </a:solidFill>
+                      <a:prstDash val="solid"/>
+                      <a:round/>
+                      <a:headEnd type="none" w="med" len="med"/>
+                      <a:tailEnd type="none" w="med" len="med"/>
+                    </a:lnT>
+                    <a:lnB w="9525" cap="flat" cmpd="sng" algn="ctr">
+                      <a:solidFill>
+                        <a:srgbClr val="EAF2F3"/>
+                      </a:solidFill>
+                      <a:prstDash val="solid"/>
+                      <a:round/>
+                      <a:headEnd type="none" w="med" len="med"/>
+                      <a:tailEnd type="none" w="med" len="med"/>
+                    </a:lnB>
+                  </a:tcPr>
+                </a:tc>
+                <a:tc>
+                  <a:txBody>
+                    <a:bodyPr/>
+                    <a:lstStyle/>
+                    <a:p>
+                      <a:pPr indent="0" marL="0">
+                        <a:buNone/>
+                      </a:pPr>
+                      <a:r>
+                        <a:rPr lang="en-US" sz="1400" dirty="0">
+                          <a:solidFill>
+                            <a:schemeClr val="tx1"/>
+                          </a:solidFill>
+                        </a:rPr>
+                        <a:t>25 SKUs, season index 7.4</a:t>
                       </a:r>
                       <a:endParaRPr lang="en-US" sz="1400" dirty="0"/>
                     </a:p>
@@ -4293,7 +4469,7 @@
                             <a:schemeClr val="tx2"/>
                           </a:solidFill>
                         </a:rPr>
-                        <a:t>3  Bulky / heavy</a:t>
+                        <a:t>D  Regular small</a:t>
                       </a:r>
                       <a:endParaRPr lang="en-US" sz="1400" dirty="0"/>
                     </a:p>
@@ -4351,7 +4527,7 @@
                             <a:schemeClr val="tx1"/>
                           </a:solidFill>
                         </a:rPr>
-                        <a:t>Large or heavy items</a:t>
+                        <a:t>198 SKUs, about 45 orders each</a:t>
                       </a:r>
                       <a:endParaRPr lang="en-US" sz="1400" dirty="0"/>
                     </a:p>
@@ -4409,183 +4585,7 @@
                             <a:schemeClr val="tx1"/>
                           </a:solidFill>
                         </a:rPr>
-                        <a:t>Ground level, near loading dock</a:t>
-                      </a:r>
-                      <a:endParaRPr lang="en-US" sz="1400" dirty="0"/>
-                    </a:p>
-                  </a:txBody>
-                  <a:tcPr marL="91440" marR="91440" marT="36576" marB="36576" anchor="ctr">
-                    <a:lnL w="9525" cap="flat" cmpd="sng" algn="ctr">
-                      <a:solidFill>
-                        <a:srgbClr val="EAF2F3"/>
-                      </a:solidFill>
-                      <a:prstDash val="solid"/>
-                      <a:round/>
-                      <a:headEnd type="none" w="med" len="med"/>
-                      <a:tailEnd type="none" w="med" len="med"/>
-                    </a:lnL>
-                    <a:lnR w="9525" cap="flat" cmpd="sng" algn="ctr">
-                      <a:solidFill>
-                        <a:srgbClr val="EAF2F3"/>
-                      </a:solidFill>
-                      <a:prstDash val="solid"/>
-                      <a:round/>
-                      <a:headEnd type="none" w="med" len="med"/>
-                      <a:tailEnd type="none" w="med" len="med"/>
-                    </a:lnR>
-                    <a:lnT w="9525" cap="flat" cmpd="sng" algn="ctr">
-                      <a:solidFill>
-                        <a:srgbClr val="EAF2F3"/>
-                      </a:solidFill>
-                      <a:prstDash val="solid"/>
-                      <a:round/>
-                      <a:headEnd type="none" w="med" len="med"/>
-                      <a:tailEnd type="none" w="med" len="med"/>
-                    </a:lnT>
-                    <a:lnB w="9525" cap="flat" cmpd="sng" algn="ctr">
-                      <a:solidFill>
-                        <a:srgbClr val="EAF2F3"/>
-                      </a:solidFill>
-                      <a:prstDash val="solid"/>
-                      <a:round/>
-                      <a:headEnd type="none" w="med" len="med"/>
-                      <a:tailEnd type="none" w="med" len="med"/>
-                    </a:lnB>
-                  </a:tcPr>
-                </a:tc>
-              </a:tr>
-              <a:tr h="621792">
-                <a:tc>
-                  <a:txBody>
-                    <a:bodyPr/>
-                    <a:lstStyle/>
-                    <a:p>
-                      <a:pPr indent="0" marL="0">
-                        <a:buNone/>
-                      </a:pPr>
-                      <a:r>
-                        <a:rPr lang="en-US" sz="1400" b="1" dirty="0">
-                          <a:solidFill>
-                            <a:schemeClr val="tx2"/>
-                          </a:solidFill>
-                        </a:rPr>
-                        <a:t>4  Special care</a:t>
-                      </a:r>
-                      <a:endParaRPr lang="en-US" sz="1400" dirty="0"/>
-                    </a:p>
-                  </a:txBody>
-                  <a:tcPr marL="91440" marR="91440" marT="36576" marB="36576" anchor="ctr">
-                    <a:lnL w="9525" cap="flat" cmpd="sng" algn="ctr">
-                      <a:solidFill>
-                        <a:srgbClr val="EAF2F3"/>
-                      </a:solidFill>
-                      <a:prstDash val="solid"/>
-                      <a:round/>
-                      <a:headEnd type="none" w="med" len="med"/>
-                      <a:tailEnd type="none" w="med" len="med"/>
-                    </a:lnL>
-                    <a:lnR w="9525" cap="flat" cmpd="sng" algn="ctr">
-                      <a:solidFill>
-                        <a:srgbClr val="EAF2F3"/>
-                      </a:solidFill>
-                      <a:prstDash val="solid"/>
-                      <a:round/>
-                      <a:headEnd type="none" w="med" len="med"/>
-                      <a:tailEnd type="none" w="med" len="med"/>
-                    </a:lnR>
-                    <a:lnT w="9525" cap="flat" cmpd="sng" algn="ctr">
-                      <a:solidFill>
-                        <a:srgbClr val="EAF2F3"/>
-                      </a:solidFill>
-                      <a:prstDash val="solid"/>
-                      <a:round/>
-                      <a:headEnd type="none" w="med" len="med"/>
-                      <a:tailEnd type="none" w="med" len="med"/>
-                    </a:lnT>
-                    <a:lnB w="9525" cap="flat" cmpd="sng" algn="ctr">
-                      <a:solidFill>
-                        <a:srgbClr val="EAF2F3"/>
-                      </a:solidFill>
-                      <a:prstDash val="solid"/>
-                      <a:round/>
-                      <a:headEnd type="none" w="med" len="med"/>
-                      <a:tailEnd type="none" w="med" len="med"/>
-                    </a:lnB>
-                  </a:tcPr>
-                </a:tc>
-                <a:tc>
-                  <a:txBody>
-                    <a:bodyPr/>
-                    <a:lstStyle/>
-                    <a:p>
-                      <a:pPr indent="0" marL="0">
-                        <a:buNone/>
-                      </a:pPr>
-                      <a:r>
-                        <a:rPr lang="en-US" sz="1400" dirty="0">
-                          <a:solidFill>
-                            <a:schemeClr val="tx1"/>
-                          </a:solidFill>
-                        </a:rPr>
-                        <a:t>Fragile items</a:t>
-                      </a:r>
-                      <a:endParaRPr lang="en-US" sz="1400" dirty="0"/>
-                    </a:p>
-                  </a:txBody>
-                  <a:tcPr marL="91440" marR="91440" marT="36576" marB="36576" anchor="ctr">
-                    <a:lnL w="9525" cap="flat" cmpd="sng" algn="ctr">
-                      <a:solidFill>
-                        <a:srgbClr val="EAF2F3"/>
-                      </a:solidFill>
-                      <a:prstDash val="solid"/>
-                      <a:round/>
-                      <a:headEnd type="none" w="med" len="med"/>
-                      <a:tailEnd type="none" w="med" len="med"/>
-                    </a:lnL>
-                    <a:lnR w="9525" cap="flat" cmpd="sng" algn="ctr">
-                      <a:solidFill>
-                        <a:srgbClr val="EAF2F3"/>
-                      </a:solidFill>
-                      <a:prstDash val="solid"/>
-                      <a:round/>
-                      <a:headEnd type="none" w="med" len="med"/>
-                      <a:tailEnd type="none" w="med" len="med"/>
-                    </a:lnR>
-                    <a:lnT w="9525" cap="flat" cmpd="sng" algn="ctr">
-                      <a:solidFill>
-                        <a:srgbClr val="EAF2F3"/>
-                      </a:solidFill>
-                      <a:prstDash val="solid"/>
-                      <a:round/>
-                      <a:headEnd type="none" w="med" len="med"/>
-                      <a:tailEnd type="none" w="med" len="med"/>
-                    </a:lnT>
-                    <a:lnB w="9525" cap="flat" cmpd="sng" algn="ctr">
-                      <a:solidFill>
-                        <a:srgbClr val="EAF2F3"/>
-                      </a:solidFill>
-                      <a:prstDash val="solid"/>
-                      <a:round/>
-                      <a:headEnd type="none" w="med" len="med"/>
-                      <a:tailEnd type="none" w="med" len="med"/>
-                    </a:lnB>
-                  </a:tcPr>
-                </a:tc>
-                <a:tc>
-                  <a:txBody>
-                    <a:bodyPr/>
-                    <a:lstStyle/>
-                    <a:p>
-                      <a:pPr indent="0" marL="0">
-                        <a:buNone/>
-                      </a:pPr>
-                      <a:r>
-                        <a:rPr lang="en-US" sz="1400" dirty="0">
-                          <a:solidFill>
-                            <a:schemeClr val="tx1"/>
-                          </a:solidFill>
-                        </a:rPr>
-                        <a:t>Separate protected area</a:t>
+                        <a:t>Back racks</a:t>
                       </a:r>
                       <a:endParaRPr lang="en-US" sz="1400" dirty="0"/>
                     </a:p>
@@ -4664,7 +4664,7 @@
                   <a:schemeClr val="accent5"/>
                 </a:solidFill>
               </a:rPr>
-              <a:t>Example clusters. The real clusters come from the data.</a:t>
+              <a:t>Real clusters: K-Means with k = 4 on 383 Olist SKUs.</a:t>
             </a:r>
             <a:endParaRPr lang="en-US" sz="1100" dirty="0"/>
           </a:p>
@@ -4706,7 +4706,7 @@
         <p:spPr>
           <a:xfrm>
             <a:off x="5989320" y="1261872"/>
-            <a:ext cx="1463040" cy="256032"/>
+            <a:ext cx="2560320" cy="256032"/>
           </a:xfrm>
           <a:prstGeom prst="rect">
             <a:avLst/>
@@ -4727,7 +4727,7 @@
                   <a:schemeClr val="tx2"/>
                 </a:solidFill>
               </a:rPr>
-              <a:t>Example floor plan</a:t>
+              <a:t>Floor plan</a:t>
             </a:r>
             <a:endParaRPr lang="en-US" sz="1100" dirty="0"/>
           </a:p>
@@ -4735,43 +4735,7 @@
       </p:sp>
       <p:sp>
         <p:nvSpPr>
-          <p:cNvPr id="8" name="Text 173"/>
-          <p:cNvSpPr txBox="1"/>
-          <p:nvPr/>
-        </p:nvSpPr>
-        <p:spPr>
-          <a:xfrm>
-            <a:off x="7315200" y="1261872"/>
-            <a:ext cx="1234440" cy="256032"/>
-          </a:xfrm>
-          <a:prstGeom prst="rect">
-            <a:avLst/>
-          </a:prstGeom>
-          <a:noFill/>
-          <a:ln/>
-        </p:spPr>
-        <p:txBody>
-          <a:bodyPr wrap="square" lIns="0" tIns="0" rIns="0" bIns="0" rtlCol="0" anchor="ctr"/>
-          <a:lstStyle/>
-          <a:p>
-            <a:pPr algn="r" indent="0" marL="0">
-              <a:buNone/>
-            </a:pPr>
-            <a:r>
-              <a:rPr lang="en-US" sz="1100" dirty="0">
-                <a:solidFill>
-                  <a:schemeClr val="accent5"/>
-                </a:solidFill>
-              </a:rPr>
-              <a:t>Loading dock</a:t>
-            </a:r>
-            <a:endParaRPr lang="en-US" sz="1100" dirty="0"/>
-          </a:p>
-        </p:txBody>
-      </p:sp>
-      <p:sp>
-        <p:nvSpPr>
-          <p:cNvPr id="9" name="Zone 174"/>
+          <p:cNvPr id="8" name="Zone 173"/>
           <p:cNvSpPr/>
           <p:nvPr/>
         </p:nvSpPr>
@@ -4807,7 +4771,7 @@
                   <a:schemeClr val="tx1"/>
                 </a:solidFill>
               </a:rPr>
-              <a:t>2</a:t>
+              <a:t>C</a:t>
             </a:r>
             <a:endParaRPr lang="en-US" sz="2200" dirty="0"/>
           </a:p>
@@ -4829,7 +4793,7 @@
       </p:sp>
       <p:sp>
         <p:nvSpPr>
-          <p:cNvPr id="10" name="Zone 175"/>
+          <p:cNvPr id="9" name="Zone 174"/>
           <p:cNvSpPr/>
           <p:nvPr/>
         </p:nvSpPr>
@@ -4865,7 +4829,7 @@
                   <a:schemeClr val="bg1"/>
                 </a:solidFill>
               </a:rPr>
-              <a:t>3</a:t>
+              <a:t>D</a:t>
             </a:r>
             <a:endParaRPr lang="en-US" sz="2200" dirty="0"/>
           </a:p>
@@ -4879,7 +4843,7 @@
                   <a:schemeClr val="bg1"/>
                 </a:solidFill>
               </a:rPr>
-              <a:t>Bulky / heavy</a:t>
+              <a:t>Regular small</a:t>
             </a:r>
             <a:endParaRPr lang="en-US" sz="2200" dirty="0"/>
           </a:p>
@@ -4887,7 +4851,7 @@
       </p:sp>
       <p:sp>
         <p:nvSpPr>
-          <p:cNvPr id="11" name="Zone 176"/>
+          <p:cNvPr id="10" name="Zone 175"/>
           <p:cNvSpPr/>
           <p:nvPr/>
         </p:nvSpPr>
@@ -4923,7 +4887,7 @@
                   <a:schemeClr val="tx1"/>
                 </a:solidFill>
               </a:rPr>
-              <a:t>1</a:t>
+              <a:t>A</a:t>
             </a:r>
             <a:endParaRPr lang="en-US" sz="2200" dirty="0"/>
           </a:p>
@@ -4945,7 +4909,7 @@
       </p:sp>
       <p:sp>
         <p:nvSpPr>
-          <p:cNvPr id="12" name="Zone 177"/>
+          <p:cNvPr id="11" name="Zone 176"/>
           <p:cNvSpPr/>
           <p:nvPr/>
         </p:nvSpPr>
@@ -4981,7 +4945,7 @@
                   <a:schemeClr val="bg1"/>
                 </a:solidFill>
               </a:rPr>
-              <a:t>4</a:t>
+              <a:t>B</a:t>
             </a:r>
             <a:endParaRPr lang="en-US" sz="2200" dirty="0"/>
           </a:p>
@@ -4995,7 +4959,7 @@
                   <a:schemeClr val="bg1"/>
                 </a:solidFill>
               </a:rPr>
-              <a:t>Special care</a:t>
+              <a:t>Bulky / heavy</a:t>
             </a:r>
             <a:endParaRPr lang="en-US" sz="2200" dirty="0"/>
           </a:p>
@@ -5003,7 +4967,7 @@
       </p:sp>
       <p:sp>
         <p:nvSpPr>
-          <p:cNvPr id="13" name="Packing 178"/>
+          <p:cNvPr id="12" name="Packing 177"/>
           <p:cNvSpPr/>
           <p:nvPr/>
         </p:nvSpPr>
@@ -5155,7 +5119,7 @@
       </p:sp>
       <p:sp>
         <p:nvSpPr>
-          <p:cNvPr id="4" name="Card 179"/>
+          <p:cNvPr id="4" name="Card 178"/>
           <p:cNvSpPr/>
           <p:nvPr/>
         </p:nvSpPr>
@@ -5182,7 +5146,7 @@
       </p:sp>
       <p:sp>
         <p:nvSpPr>
-          <p:cNvPr id="5" name="Badge 180"/>
+          <p:cNvPr id="5" name="Badge 179"/>
           <p:cNvSpPr/>
           <p:nvPr/>
         </p:nvSpPr>
@@ -5224,7 +5188,7 @@
       </p:sp>
       <p:sp>
         <p:nvSpPr>
-          <p:cNvPr id="6" name="Text 181"/>
+          <p:cNvPr id="6" name="Text 180"/>
           <p:cNvSpPr txBox="1"/>
           <p:nvPr/>
         </p:nvSpPr>
@@ -5260,7 +5224,7 @@
       </p:sp>
       <p:sp>
         <p:nvSpPr>
-          <p:cNvPr id="7" name="Text 182"/>
+          <p:cNvPr id="7" name="Text 181"/>
           <p:cNvSpPr txBox="1"/>
           <p:nvPr/>
         </p:nvSpPr>
@@ -5288,7 +5252,7 @@
                   <a:schemeClr val="tx1"/>
                 </a:solidFill>
               </a:rPr>
-              <a:t>Fast movers sit closest to packing, so pickers travel less for most orders.</a:t>
+              <a:t>Fast movers sit closest to packing. In our simple model, walk per pick falls by 27%.</a:t>
             </a:r>
             <a:endParaRPr lang="en-US" sz="1400" dirty="0"/>
           </a:p>
@@ -5296,7 +5260,7 @@
       </p:sp>
       <p:sp>
         <p:nvSpPr>
-          <p:cNvPr id="8" name="Card 183"/>
+          <p:cNvPr id="8" name="Card 182"/>
           <p:cNvSpPr/>
           <p:nvPr/>
         </p:nvSpPr>
@@ -5323,7 +5287,7 @@
       </p:sp>
       <p:sp>
         <p:nvSpPr>
-          <p:cNvPr id="9" name="Badge 184"/>
+          <p:cNvPr id="9" name="Badge 183"/>
           <p:cNvSpPr/>
           <p:nvPr/>
         </p:nvSpPr>
@@ -5365,7 +5329,7 @@
       </p:sp>
       <p:sp>
         <p:nvSpPr>
-          <p:cNvPr id="10" name="Text 185"/>
+          <p:cNvPr id="10" name="Text 184"/>
           <p:cNvSpPr txBox="1"/>
           <p:nvPr/>
         </p:nvSpPr>
@@ -5401,7 +5365,7 @@
       </p:sp>
       <p:sp>
         <p:nvSpPr>
-          <p:cNvPr id="11" name="Text 186"/>
+          <p:cNvPr id="11" name="Text 185"/>
           <p:cNvSpPr txBox="1"/>
           <p:nvPr/>
         </p:nvSpPr>
@@ -5429,7 +5393,7 @@
                   <a:schemeClr val="tx1"/>
                 </a:solidFill>
               </a:rPr>
-              <a:t>Each zone holds products with similar size and handling needs.</a:t>
+              <a:t>Bulky and heavy products get their own ground-level zone.</a:t>
             </a:r>
             <a:endParaRPr lang="en-US" sz="1400" dirty="0"/>
           </a:p>
@@ -5437,7 +5401,7 @@
       </p:sp>
       <p:sp>
         <p:nvSpPr>
-          <p:cNvPr id="12" name="Card 187"/>
+          <p:cNvPr id="12" name="Card 186"/>
           <p:cNvSpPr/>
           <p:nvPr/>
         </p:nvSpPr>
@@ -5464,7 +5428,7 @@
       </p:sp>
       <p:sp>
         <p:nvSpPr>
-          <p:cNvPr id="13" name="Badge 188"/>
+          <p:cNvPr id="13" name="Badge 187"/>
           <p:cNvSpPr/>
           <p:nvPr/>
         </p:nvSpPr>
@@ -5506,7 +5470,7 @@
       </p:sp>
       <p:sp>
         <p:nvSpPr>
-          <p:cNvPr id="14" name="Text 189"/>
+          <p:cNvPr id="14" name="Text 188"/>
           <p:cNvSpPr txBox="1"/>
           <p:nvPr/>
         </p:nvSpPr>
@@ -5542,7 +5506,7 @@
       </p:sp>
       <p:sp>
         <p:nvSpPr>
-          <p:cNvPr id="15" name="Text 190"/>
+          <p:cNvPr id="15" name="Text 189"/>
           <p:cNvSpPr txBox="1"/>
           <p:nvPr/>
         </p:nvSpPr>
@@ -5570,7 +5534,7 @@
                   <a:schemeClr val="tx1"/>
                 </a:solidFill>
               </a:rPr>
-              <a:t>Re-run K-Means with new sales data and the zones update.</a:t>
+              <a:t>Seasonal products are one group, easy to move forward in season.</a:t>
             </a:r>
             <a:endParaRPr lang="en-US" sz="1400" dirty="0"/>
           </a:p>
@@ -5578,7 +5542,7 @@
       </p:sp>
       <p:sp>
         <p:nvSpPr>
-          <p:cNvPr id="16" name="Card 191"/>
+          <p:cNvPr id="16" name="Card 190"/>
           <p:cNvSpPr/>
           <p:nvPr/>
         </p:nvSpPr>
@@ -5605,7 +5569,7 @@
       </p:sp>
       <p:sp>
         <p:nvSpPr>
-          <p:cNvPr id="17" name="Text 192"/>
+          <p:cNvPr id="17" name="Text 191"/>
           <p:cNvSpPr txBox="1"/>
           <p:nvPr/>
         </p:nvSpPr>
@@ -5644,7 +5608,7 @@
                   <a:schemeClr val="tx1"/>
                 </a:solidFill>
               </a:rPr>
-              <a:t>SKUs inside a cluster should look alike (low within-cluster variance), and each centroid should read like a typical product.</a:t>
+              <a:t>each centroid should read like a typical product. Fast movers: about 160 orders, 9 litres, 1 kg. The walking figure is a model, not a measurement.</a:t>
             </a:r>
             <a:endParaRPr lang="en-US" sz="1400" dirty="0"/>
           </a:p>
@@ -5760,7 +5724,7 @@
       </p:sp>
       <p:sp>
         <p:nvSpPr>
-          <p:cNvPr id="3" name="Badge 193"/>
+          <p:cNvPr id="3" name="Badge 192"/>
           <p:cNvSpPr/>
           <p:nvPr/>
         </p:nvSpPr>
@@ -5802,7 +5766,7 @@
       </p:sp>
       <p:sp>
         <p:nvSpPr>
-          <p:cNvPr id="4" name="Text 194"/>
+          <p:cNvPr id="4" name="Text 193"/>
           <p:cNvSpPr txBox="1"/>
           <p:nvPr/>
         </p:nvSpPr>
@@ -5838,7 +5802,7 @@
       </p:sp>
       <p:sp>
         <p:nvSpPr>
-          <p:cNvPr id="5" name="Badge 195"/>
+          <p:cNvPr id="5" name="Badge 194"/>
           <p:cNvSpPr/>
           <p:nvPr/>
         </p:nvSpPr>
@@ -5880,7 +5844,7 @@
       </p:sp>
       <p:sp>
         <p:nvSpPr>
-          <p:cNvPr id="6" name="Text 196"/>
+          <p:cNvPr id="6" name="Text 195"/>
           <p:cNvSpPr txBox="1"/>
           <p:nvPr/>
         </p:nvSpPr>
@@ -5916,7 +5880,7 @@
       </p:sp>
       <p:sp>
         <p:nvSpPr>
-          <p:cNvPr id="7" name="Badge 197"/>
+          <p:cNvPr id="7" name="Badge 196"/>
           <p:cNvSpPr/>
           <p:nvPr/>
         </p:nvSpPr>
@@ -5958,7 +5922,7 @@
       </p:sp>
       <p:sp>
         <p:nvSpPr>
-          <p:cNvPr id="8" name="Text 198"/>
+          <p:cNvPr id="8" name="Text 197"/>
           <p:cNvSpPr txBox="1"/>
           <p:nvPr/>
         </p:nvSpPr>
@@ -5986,7 +5950,7 @@
                   <a:schemeClr val="bg1"/>
                 </a:solidFill>
               </a:rPr>
-              <a:t>Outcome: clear clusters that map directly to warehouse zones.</a:t>
+              <a:t>Tested on real data: 383 SKUs gave 4 clear clusters that map to zones.</a:t>
             </a:r>
             <a:endParaRPr lang="en-US" sz="1600" dirty="0"/>
           </a:p>
@@ -5994,14 +5958,14 @@
       </p:sp>
       <p:sp>
         <p:nvSpPr>
-          <p:cNvPr id="9" name="Text 199"/>
+          <p:cNvPr id="9" name="Text 198"/>
           <p:cNvSpPr txBox="1"/>
           <p:nvPr/>
         </p:nvSpPr>
         <p:spPr>
           <a:xfrm>
-            <a:off x="548640" y="3931920"/>
-            <a:ext cx="5029200" cy="457200"/>
+            <a:off x="548640" y="3840480"/>
+            <a:ext cx="5029200" cy="548640"/>
           </a:xfrm>
           <a:prstGeom prst="rect">
             <a:avLst/>
@@ -6022,15 +5986,29 @@
                   <a:schemeClr val="bg2"/>
                 </a:solidFill>
               </a:rPr>
-              <a:t>Next step: test with real SKU data and compare different values of k.</a:t>
+              <a:t>Live demo and Colab code:</a:t>
             </a:r>
             <a:endParaRPr lang="en-US" sz="1400" dirty="0"/>
           </a:p>
-        </p:txBody>
-      </p:sp>
-      <p:sp>
-        <p:nvSpPr>
-          <p:cNvPr id="10" name="Card 200"/>
+          <a:p>
+            <a:pPr algn="l" indent="0" marL="0">
+              <a:buNone/>
+            </a:pPr>
+            <a:r>
+              <a:rPr lang="en-US" sz="1400" b="1" dirty="0">
+                <a:solidFill>
+                  <a:schemeClr val="bg2"/>
+                </a:solidFill>
+              </a:rPr>
+              <a:t>zanyanbu.github.io/warehouse-sku-kmeans</a:t>
+            </a:r>
+            <a:endParaRPr lang="en-US" sz="1400" dirty="0"/>
+          </a:p>
+        </p:txBody>
+      </p:sp>
+      <p:sp>
+        <p:nvSpPr>
+          <p:cNvPr id="10" name="Card 199"/>
           <p:cNvSpPr/>
           <p:nvPr/>
         </p:nvSpPr>
@@ -6061,7 +6039,7 @@
       </p:sp>
       <p:sp>
         <p:nvSpPr>
-          <p:cNvPr id="11" name="Text 201"/>
+          <p:cNvPr id="11" name="Text 200"/>
           <p:cNvSpPr txBox="1"/>
           <p:nvPr/>
         </p:nvSpPr>
@@ -6097,7 +6075,7 @@
       </p:sp>
       <p:sp>
         <p:nvSpPr>
-          <p:cNvPr id="12" name="Text 202"/>
+          <p:cNvPr id="12" name="Text 201"/>
           <p:cNvSpPr txBox="1"/>
           <p:nvPr/>
         </p:nvSpPr>
@@ -6133,7 +6111,7 @@
       </p:sp>
       <p:sp>
         <p:nvSpPr>
-          <p:cNvPr id="13" name="Dot 203"/>
+          <p:cNvPr id="13" name="Dot 202"/>
           <p:cNvSpPr/>
           <p:nvPr/>
         </p:nvSpPr>
@@ -6158,7 +6136,7 @@
       </p:sp>
       <p:sp>
         <p:nvSpPr>
-          <p:cNvPr id="14" name="Dot 204"/>
+          <p:cNvPr id="14" name="Dot 203"/>
           <p:cNvSpPr/>
           <p:nvPr/>
         </p:nvSpPr>
@@ -6183,7 +6161,7 @@
       </p:sp>
       <p:sp>
         <p:nvSpPr>
-          <p:cNvPr id="15" name="Dot 205"/>
+          <p:cNvPr id="15" name="Dot 204"/>
           <p:cNvSpPr/>
           <p:nvPr/>
         </p:nvSpPr>
@@ -6208,7 +6186,7 @@
       </p:sp>
       <p:sp>
         <p:nvSpPr>
-          <p:cNvPr id="16" name="Dot 206"/>
+          <p:cNvPr id="16" name="Dot 205"/>
           <p:cNvSpPr/>
           <p:nvPr/>
         </p:nvSpPr>
@@ -6233,7 +6211,7 @@
       </p:sp>
       <p:sp>
         <p:nvSpPr>
-          <p:cNvPr id="17" name="Dot 207"/>
+          <p:cNvPr id="17" name="Dot 206"/>
           <p:cNvSpPr/>
           <p:nvPr/>
         </p:nvSpPr>
@@ -6258,7 +6236,7 @@
       </p:sp>
       <p:sp>
         <p:nvSpPr>
-          <p:cNvPr id="18" name="Dot 208"/>
+          <p:cNvPr id="18" name="Dot 207"/>
           <p:cNvSpPr/>
           <p:nvPr/>
         </p:nvSpPr>
@@ -6283,7 +6261,7 @@
       </p:sp>
       <p:sp>
         <p:nvSpPr>
-          <p:cNvPr id="19" name="Dot 209"/>
+          <p:cNvPr id="19" name="Dot 208"/>
           <p:cNvSpPr/>
           <p:nvPr/>
         </p:nvSpPr>
@@ -6308,7 +6286,7 @@
       </p:sp>
       <p:sp>
         <p:nvSpPr>
-          <p:cNvPr id="20" name="Centroid 210"/>
+          <p:cNvPr id="20" name="Centroid 209"/>
           <p:cNvSpPr/>
           <p:nvPr/>
         </p:nvSpPr>
@@ -6333,7 +6311,7 @@
       </p:sp>
       <p:sp>
         <p:nvSpPr>
-          <p:cNvPr id="21" name="Dot 211"/>
+          <p:cNvPr id="21" name="Dot 210"/>
           <p:cNvSpPr/>
           <p:nvPr/>
         </p:nvSpPr>
@@ -6358,7 +6336,7 @@
       </p:sp>
       <p:sp>
         <p:nvSpPr>
-          <p:cNvPr id="22" name="Dot 212"/>
+          <p:cNvPr id="22" name="Dot 211"/>
           <p:cNvSpPr/>
           <p:nvPr/>
         </p:nvSpPr>
@@ -6383,7 +6361,7 @@
       </p:sp>
       <p:sp>
         <p:nvSpPr>
-          <p:cNvPr id="23" name="Dot 213"/>
+          <p:cNvPr id="23" name="Dot 212"/>
           <p:cNvSpPr/>
           <p:nvPr/>
         </p:nvSpPr>
@@ -6408,7 +6386,7 @@
       </p:sp>
       <p:sp>
         <p:nvSpPr>
-          <p:cNvPr id="24" name="Dot 214"/>
+          <p:cNvPr id="24" name="Dot 213"/>
           <p:cNvSpPr/>
           <p:nvPr/>
         </p:nvSpPr>
@@ -6433,7 +6411,7 @@
       </p:sp>
       <p:sp>
         <p:nvSpPr>
-          <p:cNvPr id="25" name="Dot 215"/>
+          <p:cNvPr id="25" name="Dot 214"/>
           <p:cNvSpPr/>
           <p:nvPr/>
         </p:nvSpPr>
@@ -6458,7 +6436,7 @@
       </p:sp>
       <p:sp>
         <p:nvSpPr>
-          <p:cNvPr id="26" name="Dot 216"/>
+          <p:cNvPr id="26" name="Dot 215"/>
           <p:cNvSpPr/>
           <p:nvPr/>
         </p:nvSpPr>
@@ -6483,7 +6461,7 @@
       </p:sp>
       <p:sp>
         <p:nvSpPr>
-          <p:cNvPr id="27" name="Dot 217"/>
+          <p:cNvPr id="27" name="Dot 216"/>
           <p:cNvSpPr/>
           <p:nvPr/>
         </p:nvSpPr>
@@ -6508,7 +6486,7 @@
       </p:sp>
       <p:sp>
         <p:nvSpPr>
-          <p:cNvPr id="28" name="Centroid 218"/>
+          <p:cNvPr id="28" name="Centroid 217"/>
           <p:cNvSpPr/>
           <p:nvPr/>
         </p:nvSpPr>
@@ -6533,7 +6511,7 @@
       </p:sp>
       <p:sp>
         <p:nvSpPr>
-          <p:cNvPr id="29" name="Dot 219"/>
+          <p:cNvPr id="29" name="Dot 218"/>
           <p:cNvSpPr/>
           <p:nvPr/>
         </p:nvSpPr>
@@ -6558,7 +6536,7 @@
       </p:sp>
       <p:sp>
         <p:nvSpPr>
-          <p:cNvPr id="30" name="Dot 220"/>
+          <p:cNvPr id="30" name="Dot 219"/>
           <p:cNvSpPr/>
           <p:nvPr/>
         </p:nvSpPr>
@@ -6583,7 +6561,7 @@
       </p:sp>
       <p:sp>
         <p:nvSpPr>
-          <p:cNvPr id="31" name="Dot 221"/>
+          <p:cNvPr id="31" name="Dot 220"/>
           <p:cNvSpPr/>
           <p:nvPr/>
         </p:nvSpPr>
@@ -6608,7 +6586,7 @@
       </p:sp>
       <p:sp>
         <p:nvSpPr>
-          <p:cNvPr id="32" name="Dot 222"/>
+          <p:cNvPr id="32" name="Dot 221"/>
           <p:cNvSpPr/>
           <p:nvPr/>
         </p:nvSpPr>
@@ -6633,7 +6611,7 @@
       </p:sp>
       <p:sp>
         <p:nvSpPr>
-          <p:cNvPr id="33" name="Dot 223"/>
+          <p:cNvPr id="33" name="Dot 222"/>
           <p:cNvSpPr/>
           <p:nvPr/>
         </p:nvSpPr>
@@ -6658,7 +6636,7 @@
       </p:sp>
       <p:sp>
         <p:nvSpPr>
-          <p:cNvPr id="34" name="Dot 224"/>
+          <p:cNvPr id="34" name="Dot 223"/>
           <p:cNvSpPr/>
           <p:nvPr/>
         </p:nvSpPr>
@@ -6683,7 +6661,7 @@
       </p:sp>
       <p:sp>
         <p:nvSpPr>
-          <p:cNvPr id="35" name="Dot 225"/>
+          <p:cNvPr id="35" name="Dot 224"/>
           <p:cNvSpPr/>
           <p:nvPr/>
         </p:nvSpPr>
@@ -6708,7 +6686,7 @@
       </p:sp>
       <p:sp>
         <p:nvSpPr>
-          <p:cNvPr id="36" name="Centroid 226"/>
+          <p:cNvPr id="36" name="Centroid 225"/>
           <p:cNvSpPr/>
           <p:nvPr/>
         </p:nvSpPr>
@@ -12359,7 +12337,7 @@
                   <a:schemeClr val="accent5"/>
                 </a:solidFill>
               </a:rPr>
-              <a:t>Example data (made up to show the idea)</a:t>
+              <a:t>Real data: Olist public e-commerce dataset, 99,441 orders (2016 to 2018)</a:t>
             </a:r>
             <a:endParaRPr lang="en-US" sz="1100" dirty="0"/>
           </a:p>
@@ -12367,7 +12345,7 @@
       </p:sp>
       <p:graphicFrame>
         <p:nvGraphicFramePr>
-          <p:cNvPr id="9" name="Example SKU table"/>
+          <p:cNvPr id="9" name="Real SKU table"/>
           <p:cNvGraphicFramePr>
             <a:graphicFrameLocks noGrp="1"/>
           </p:cNvGraphicFramePr>
@@ -12388,11 +12366,11 @@
             <a:tbl>
               <a:tblPr/>
               <a:tblGrid>
-                <a:gridCol w="731520"/>
-                <a:gridCol w="1051560"/>
                 <a:gridCol w="1097280"/>
-                <a:gridCol w="1051560"/>
-                <a:gridCol w="914400"/>
+                <a:gridCol w="822960"/>
+                <a:gridCol w="1005840"/>
+                <a:gridCol w="960120"/>
+                <a:gridCol w="960120"/>
               </a:tblGrid>
               <a:tr h="566928">
                 <a:tc>
@@ -12470,7 +12448,7 @@
                             <a:schemeClr val="bg1"/>
                           </a:solidFill>
                         </a:rPr>
-                        <a:t>Picks / week</a:t>
+                        <a:t>Orders</a:t>
                       </a:r>
                       <a:endParaRPr lang="en-US" sz="1400" dirty="0"/>
                     </a:p>
@@ -12653,7 +12631,7 @@
                             <a:schemeClr val="bg1"/>
                           </a:solidFill>
                         </a:rPr>
-                        <a:t>Fragile</a:t>
+                        <a:t>Weight (kg)</a:t>
                       </a:r>
                       <a:endParaRPr lang="en-US" sz="1400" dirty="0"/>
                     </a:p>
@@ -12716,7 +12694,7 @@
                             <a:schemeClr val="tx1"/>
                           </a:solidFill>
                         </a:rPr>
-                        <a:t>A101</a:t>
+                        <a:t>aca2eb7d</a:t>
                       </a:r>
                       <a:endParaRPr lang="en-US" sz="1400" dirty="0"/>
                     </a:p>
@@ -12774,7 +12752,7 @@
                             <a:schemeClr val="tx1"/>
                           </a:solidFill>
                         </a:rPr>
-                        <a:t>120</a:t>
+                        <a:t>527</a:t>
                       </a:r>
                       <a:endParaRPr lang="en-US" sz="1400" dirty="0"/>
                     </a:p>
@@ -12832,7 +12810,7 @@
                             <a:schemeClr val="tx1"/>
                           </a:solidFill>
                         </a:rPr>
-                        <a:t>1.1</a:t>
+                        <a:t>2.8</a:t>
                       </a:r>
                       <a:endParaRPr lang="en-US" sz="1400" dirty="0"/>
                     </a:p>
@@ -12890,7 +12868,7 @@
                             <a:schemeClr val="tx1"/>
                           </a:solidFill>
                         </a:rPr>
-                        <a:t>2</a:t>
+                        <a:t>15.0</a:t>
                       </a:r>
                       <a:endParaRPr lang="en-US" sz="1400" dirty="0"/>
                     </a:p>
@@ -12948,7 +12926,7 @@
                             <a:schemeClr val="tx1"/>
                           </a:solidFill>
                         </a:rPr>
-                        <a:t>0</a:t>
+                        <a:t>2.6</a:t>
                       </a:r>
                       <a:endParaRPr lang="en-US" sz="1400" dirty="0"/>
                     </a:p>
@@ -13008,7 +12986,7 @@
                             <a:schemeClr val="tx1"/>
                           </a:solidFill>
                         </a:rPr>
-                        <a:t>B205</a:t>
+                        <a:t>42a2c92a</a:t>
                       </a:r>
                       <a:endParaRPr lang="en-US" sz="1400" dirty="0"/>
                     </a:p>
@@ -13066,7 +13044,7 @@
                             <a:schemeClr val="tx1"/>
                           </a:solidFill>
                         </a:rPr>
-                        <a:t>8</a:t>
+                        <a:t>183</a:t>
                       </a:r>
                       <a:endParaRPr lang="en-US" sz="1400" dirty="0"/>
                     </a:p>
@@ -13124,7 +13102,7 @@
                             <a:schemeClr val="tx1"/>
                           </a:solidFill>
                         </a:rPr>
-                        <a:t>3.5</a:t>
+                        <a:t>4.8</a:t>
                       </a:r>
                       <a:endParaRPr lang="en-US" sz="1400" dirty="0"/>
                     </a:p>
@@ -13182,7 +13160,7 @@
                             <a:schemeClr val="tx1"/>
                           </a:solidFill>
                         </a:rPr>
-                        <a:t>15</a:t>
+                        <a:t>33.0</a:t>
                       </a:r>
                       <a:endParaRPr lang="en-US" sz="1400" dirty="0"/>
                     </a:p>
@@ -13240,7 +13218,7 @@
                             <a:schemeClr val="tx1"/>
                           </a:solidFill>
                         </a:rPr>
-                        <a:t>0</a:t>
+                        <a:t>7.0</a:t>
                       </a:r>
                       <a:endParaRPr lang="en-US" sz="1400" dirty="0"/>
                     </a:p>
@@ -13300,7 +13278,7 @@
                             <a:schemeClr val="tx1"/>
                           </a:solidFill>
                         </a:rPr>
-                        <a:t>C310</a:t>
+                        <a:t>54d9ac71</a:t>
                       </a:r>
                       <a:endParaRPr lang="en-US" sz="1400" dirty="0"/>
                     </a:p>
@@ -13358,7 +13336,7 @@
                             <a:schemeClr val="tx1"/>
                           </a:solidFill>
                         </a:rPr>
-                        <a:t>15</a:t>
+                        <a:t>114</a:t>
                       </a:r>
                       <a:endParaRPr lang="en-US" sz="1400" dirty="0"/>
                     </a:p>
@@ -13416,7 +13394,7 @@
                             <a:schemeClr val="tx1"/>
                           </a:solidFill>
                         </a:rPr>
-                        <a:t>1.0</a:t>
+                        <a:t>8.0</a:t>
                       </a:r>
                       <a:endParaRPr lang="en-US" sz="1400" dirty="0"/>
                     </a:p>
@@ -13474,7 +13452,7 @@
                             <a:schemeClr val="tx1"/>
                           </a:solidFill>
                         </a:rPr>
-                        <a:t>180</a:t>
+                        <a:t>7.8</a:t>
                       </a:r>
                       <a:endParaRPr lang="en-US" sz="1400" dirty="0"/>
                     </a:p>
@@ -13532,7 +13510,7 @@
                             <a:schemeClr val="tx1"/>
                           </a:solidFill>
                         </a:rPr>
-                        <a:t>0</a:t>
+                        <a:t>1.9</a:t>
                       </a:r>
                       <a:endParaRPr lang="en-US" sz="1400" dirty="0"/>
                     </a:p>
@@ -13592,7 +13570,7 @@
                             <a:schemeClr val="tx1"/>
                           </a:solidFill>
                         </a:rPr>
-                        <a:t>D412</a:t>
+                        <a:t>dbb67791</a:t>
                       </a:r>
                       <a:endParaRPr lang="en-US" sz="1400" dirty="0"/>
                     </a:p>
@@ -13650,7 +13628,7 @@
                             <a:schemeClr val="tx1"/>
                           </a:solidFill>
                         </a:rPr>
-                        <a:t>60</a:t>
+                        <a:t>88</a:t>
                       </a:r>
                       <a:endParaRPr lang="en-US" sz="1400" dirty="0"/>
                     </a:p>
@@ -13708,7 +13686,7 @@
                             <a:schemeClr val="tx1"/>
                           </a:solidFill>
                         </a:rPr>
-                        <a:t>1.2</a:t>
+                        <a:t>4.5</a:t>
                       </a:r>
                       <a:endParaRPr lang="en-US" sz="1400" dirty="0"/>
                     </a:p>
@@ -13766,7 +13744,7 @@
                             <a:schemeClr val="tx1"/>
                           </a:solidFill>
                         </a:rPr>
-                        <a:t>4</a:t>
+                        <a:t>2.7</a:t>
                       </a:r>
                       <a:endParaRPr lang="en-US" sz="1400" dirty="0"/>
                     </a:p>
@@ -13824,7 +13802,7 @@
                             <a:schemeClr val="tx1"/>
                           </a:solidFill>
                         </a:rPr>
-                        <a:t>1</a:t>
+                        <a:t>0.2</a:t>
                       </a:r>
                       <a:endParaRPr lang="en-US" sz="1400" dirty="0"/>
                     </a:p>
@@ -13941,7 +13919,7 @@
                   <a:schemeClr val="tx1"/>
                 </a:solidFill>
               </a:rPr>
-              <a:t>= peak-season sales divided by average sales</a:t>
+              <a:t>= share of orders in the busiest month x 12</a:t>
             </a:r>
             <a:endParaRPr lang="en-US" sz="1400" dirty="0"/>
           </a:p>
@@ -14019,7 +13997,7 @@
                   <a:schemeClr val="tx2"/>
                 </a:solidFill>
               </a:rPr>
-              <a:t>One row per SKU</a:t>
+              <a:t>383 real SKUs</a:t>
             </a:r>
             <a:endParaRPr lang="en-US" sz="1500" dirty="0"/>
           </a:p>
@@ -14055,7 +14033,7 @@
                   <a:schemeClr val="tx1"/>
                 </a:solidFill>
               </a:rPr>
-              <a:t>Each product becomes a row of numbers (a vector).</a:t>
+              <a:t>Products ordered at least 30 times, out of 32,951.</a:t>
             </a:r>
             <a:endParaRPr lang="en-US" sz="1400" dirty="0"/>
           </a:p>
@@ -14133,7 +14111,7 @@
                   <a:schemeClr val="tx2"/>
                 </a:solidFill>
               </a:rPr>
-              <a:t>Everything as numbers</a:t>
+              <a:t>Four numbers each</a:t>
             </a:r>
             <a:endParaRPr lang="en-US" sz="1500" dirty="0"/>
           </a:p>
@@ -14169,7 +14147,7 @@
                   <a:schemeClr val="tx1"/>
                 </a:solidFill>
               </a:rPr>
-              <a:t>Handling needs become 0 / 1 flags such as fragile or heavy.</a:t>
+              <a:t>Orders, season index, volume, and weight for handling.</a:t>
             </a:r>
             <a:endParaRPr lang="en-US" sz="1400" dirty="0"/>
           </a:p>
@@ -14283,7 +14261,7 @@
                   <a:schemeClr val="tx1"/>
                 </a:solidFill>
               </a:rPr>
-              <a:t>Bring all columns to the same range so big numbers do not dominate.</a:t>
+              <a:t>Log of the uneven columns, then all on the same scale.</a:t>
             </a:r>
             <a:endParaRPr lang="en-US" sz="1400" dirty="0"/>
           </a:p>
@@ -14521,7 +14499,7 @@
                   <a:schemeClr val="tx1"/>
                 </a:solidFill>
               </a:rPr>
-              <a:t>Run K-Means for k = 1, 2, 3 and so on. Note the error each time.</a:t>
+              <a:t>Run K-Means for k = 1 to 8. Note the error each time.</a:t>
             </a:r>
             <a:endParaRPr lang="en-US" sz="1400" dirty="0"/>
           </a:p>
@@ -14749,7 +14727,7 @@
                   <a:schemeClr val="tx1"/>
                 </a:solidFill>
               </a:rPr>
-              <a:t>Pick the k where the curve bends. More clusters after it help very little.</a:t>
+              <a:t>The error falls 22% at k = 4, then only 15% at k = 5.</a:t>
             </a:r>
             <a:endParaRPr lang="en-US" sz="1400" dirty="0"/>
           </a:p>
@@ -14793,7 +14771,7 @@
                   <a:schemeClr val="tx1"/>
                 </a:solidFill>
               </a:rPr>
-              <a:t>In this example: k = 4</a:t>
+              <a:t>On the real data: k = 4</a:t>
             </a:r>
             <a:endParaRPr lang="en-US" sz="1500" dirty="0"/>
           </a:p>

</xml_diff>

<commit_message>
Say where the data comes from, on the slide, the page and in the repo
Slide 8 carries the dataset's address. The page's real-data section names the
source and links to data/SOURCE.md, which lists the files the notebook reads,
what is taken from each and how the four numbers are built. The presentation
script now matches the real-data slides: where the data is from, the real
elbow, the four real clusters, and that the walking figure is a model.
</commit_message>
<xml_diff>
--- a/slides/kmeans-sku-clustering.pptx
+++ b/slides/kmeans-sku-clustering.pptx
@@ -118,21 +118,21 @@
   <p:extLst>
     <p:ext uri="{521415D9-36F7-43E2-AB2F-B90AF26B5E84}">
       <p14:sectionLst xmlns:p14="http://schemas.microsoft.com/office/powerpoint/2010/main">
-        <p14:section name="Problem" id="{04b5fd4c-d15a-0013-9e89-cd1b8c9f18e1}">
+        <p14:section name="Problem" id="{972b2275-318b-cda7-86fb-2958f33539de}">
           <p14:sldIdLst>
             <p14:sldId id="256"/>
             <p14:sldId id="257"/>
             <p14:sldId id="258"/>
           </p14:sldIdLst>
         </p14:section>
-        <p14:section name="Choosing the solution" id="{f7ffc76c-05dc-2732-1bb6-eb9780c7d120}">
+        <p14:section name="Choosing the solution" id="{1073c501-4c5e-6d78-c32c-4d206b7d0dad}">
           <p14:sldIdLst>
             <p14:sldId id="259"/>
             <p14:sldId id="260"/>
             <p14:sldId id="261"/>
           </p14:sldIdLst>
         </p14:section>
-        <p14:section name="Applying K-Means" id="{da5b0630-31ec-6cc5-5325-7ddc06f37602}">
+        <p14:section name="Applying K-Means" id="{ece8b786-5d4f-4b9f-a280-8bf513cabadc}">
           <p14:sldIdLst>
             <p14:sldId id="262"/>
             <p14:sldId id="263"/>
@@ -140,7 +140,7 @@
             <p14:sldId id="265"/>
           </p14:sldIdLst>
         </p14:section>
-        <p14:section name="Conclusion" id="{658f8e6a-05b0-e5a3-7a84-51a87b2df996}">
+        <p14:section name="Conclusion" id="{9cfa82c8-0779-bf8d-bc23-3a152d7bc9c6}">
           <p14:sldIdLst>
             <p14:sldId id="266"/>
             <p14:sldId id="267"/>
@@ -4636,7 +4636,7 @@
       </p:graphicFrame>
       <p:sp>
         <p:nvSpPr>
-          <p:cNvPr id="5" name="Text 170"/>
+          <p:cNvPr id="5" name="Text 171"/>
           <p:cNvSpPr txBox="1"/>
           <p:nvPr/>
         </p:nvSpPr>
@@ -4672,7 +4672,7 @@
       </p:sp>
       <p:sp>
         <p:nvSpPr>
-          <p:cNvPr id="6" name="Card 171"/>
+          <p:cNvPr id="6" name="Card 172"/>
           <p:cNvSpPr/>
           <p:nvPr/>
         </p:nvSpPr>
@@ -4699,7 +4699,7 @@
       </p:sp>
       <p:sp>
         <p:nvSpPr>
-          <p:cNvPr id="7" name="Text 172"/>
+          <p:cNvPr id="7" name="Text 173"/>
           <p:cNvSpPr txBox="1"/>
           <p:nvPr/>
         </p:nvSpPr>
@@ -4735,7 +4735,7 @@
       </p:sp>
       <p:sp>
         <p:nvSpPr>
-          <p:cNvPr id="8" name="Zone 173"/>
+          <p:cNvPr id="8" name="Zone 174"/>
           <p:cNvSpPr/>
           <p:nvPr/>
         </p:nvSpPr>
@@ -4793,7 +4793,7 @@
       </p:sp>
       <p:sp>
         <p:nvSpPr>
-          <p:cNvPr id="9" name="Zone 174"/>
+          <p:cNvPr id="9" name="Zone 175"/>
           <p:cNvSpPr/>
           <p:nvPr/>
         </p:nvSpPr>
@@ -4851,7 +4851,7 @@
       </p:sp>
       <p:sp>
         <p:nvSpPr>
-          <p:cNvPr id="10" name="Zone 175"/>
+          <p:cNvPr id="10" name="Zone 176"/>
           <p:cNvSpPr/>
           <p:nvPr/>
         </p:nvSpPr>
@@ -4909,7 +4909,7 @@
       </p:sp>
       <p:sp>
         <p:nvSpPr>
-          <p:cNvPr id="11" name="Zone 176"/>
+          <p:cNvPr id="11" name="Zone 177"/>
           <p:cNvSpPr/>
           <p:nvPr/>
         </p:nvSpPr>
@@ -4967,7 +4967,7 @@
       </p:sp>
       <p:sp>
         <p:nvSpPr>
-          <p:cNvPr id="12" name="Packing 177"/>
+          <p:cNvPr id="12" name="Packing 178"/>
           <p:cNvSpPr/>
           <p:nvPr/>
         </p:nvSpPr>
@@ -5119,7 +5119,7 @@
       </p:sp>
       <p:sp>
         <p:nvSpPr>
-          <p:cNvPr id="4" name="Card 178"/>
+          <p:cNvPr id="4" name="Card 179"/>
           <p:cNvSpPr/>
           <p:nvPr/>
         </p:nvSpPr>
@@ -5146,7 +5146,7 @@
       </p:sp>
       <p:sp>
         <p:nvSpPr>
-          <p:cNvPr id="5" name="Badge 179"/>
+          <p:cNvPr id="5" name="Badge 180"/>
           <p:cNvSpPr/>
           <p:nvPr/>
         </p:nvSpPr>
@@ -5188,7 +5188,7 @@
       </p:sp>
       <p:sp>
         <p:nvSpPr>
-          <p:cNvPr id="6" name="Text 180"/>
+          <p:cNvPr id="6" name="Text 181"/>
           <p:cNvSpPr txBox="1"/>
           <p:nvPr/>
         </p:nvSpPr>
@@ -5224,7 +5224,7 @@
       </p:sp>
       <p:sp>
         <p:nvSpPr>
-          <p:cNvPr id="7" name="Text 181"/>
+          <p:cNvPr id="7" name="Text 182"/>
           <p:cNvSpPr txBox="1"/>
           <p:nvPr/>
         </p:nvSpPr>
@@ -5260,7 +5260,7 @@
       </p:sp>
       <p:sp>
         <p:nvSpPr>
-          <p:cNvPr id="8" name="Card 182"/>
+          <p:cNvPr id="8" name="Card 183"/>
           <p:cNvSpPr/>
           <p:nvPr/>
         </p:nvSpPr>
@@ -5287,7 +5287,7 @@
       </p:sp>
       <p:sp>
         <p:nvSpPr>
-          <p:cNvPr id="9" name="Badge 183"/>
+          <p:cNvPr id="9" name="Badge 184"/>
           <p:cNvSpPr/>
           <p:nvPr/>
         </p:nvSpPr>
@@ -5329,7 +5329,7 @@
       </p:sp>
       <p:sp>
         <p:nvSpPr>
-          <p:cNvPr id="10" name="Text 184"/>
+          <p:cNvPr id="10" name="Text 185"/>
           <p:cNvSpPr txBox="1"/>
           <p:nvPr/>
         </p:nvSpPr>
@@ -5365,7 +5365,7 @@
       </p:sp>
       <p:sp>
         <p:nvSpPr>
-          <p:cNvPr id="11" name="Text 185"/>
+          <p:cNvPr id="11" name="Text 186"/>
           <p:cNvSpPr txBox="1"/>
           <p:nvPr/>
         </p:nvSpPr>
@@ -5401,7 +5401,7 @@
       </p:sp>
       <p:sp>
         <p:nvSpPr>
-          <p:cNvPr id="12" name="Card 186"/>
+          <p:cNvPr id="12" name="Card 187"/>
           <p:cNvSpPr/>
           <p:nvPr/>
         </p:nvSpPr>
@@ -5428,7 +5428,7 @@
       </p:sp>
       <p:sp>
         <p:nvSpPr>
-          <p:cNvPr id="13" name="Badge 187"/>
+          <p:cNvPr id="13" name="Badge 188"/>
           <p:cNvSpPr/>
           <p:nvPr/>
         </p:nvSpPr>
@@ -5470,7 +5470,7 @@
       </p:sp>
       <p:sp>
         <p:nvSpPr>
-          <p:cNvPr id="14" name="Text 188"/>
+          <p:cNvPr id="14" name="Text 189"/>
           <p:cNvSpPr txBox="1"/>
           <p:nvPr/>
         </p:nvSpPr>
@@ -5506,7 +5506,7 @@
       </p:sp>
       <p:sp>
         <p:nvSpPr>
-          <p:cNvPr id="15" name="Text 189"/>
+          <p:cNvPr id="15" name="Text 190"/>
           <p:cNvSpPr txBox="1"/>
           <p:nvPr/>
         </p:nvSpPr>
@@ -5542,7 +5542,7 @@
       </p:sp>
       <p:sp>
         <p:nvSpPr>
-          <p:cNvPr id="16" name="Card 190"/>
+          <p:cNvPr id="16" name="Card 191"/>
           <p:cNvSpPr/>
           <p:nvPr/>
         </p:nvSpPr>
@@ -5569,7 +5569,7 @@
       </p:sp>
       <p:sp>
         <p:nvSpPr>
-          <p:cNvPr id="17" name="Text 191"/>
+          <p:cNvPr id="17" name="Text 192"/>
           <p:cNvSpPr txBox="1"/>
           <p:nvPr/>
         </p:nvSpPr>
@@ -5724,7 +5724,7 @@
       </p:sp>
       <p:sp>
         <p:nvSpPr>
-          <p:cNvPr id="3" name="Badge 192"/>
+          <p:cNvPr id="3" name="Badge 193"/>
           <p:cNvSpPr/>
           <p:nvPr/>
         </p:nvSpPr>
@@ -5766,7 +5766,7 @@
       </p:sp>
       <p:sp>
         <p:nvSpPr>
-          <p:cNvPr id="4" name="Text 193"/>
+          <p:cNvPr id="4" name="Text 194"/>
           <p:cNvSpPr txBox="1"/>
           <p:nvPr/>
         </p:nvSpPr>
@@ -5802,7 +5802,7 @@
       </p:sp>
       <p:sp>
         <p:nvSpPr>
-          <p:cNvPr id="5" name="Badge 194"/>
+          <p:cNvPr id="5" name="Badge 195"/>
           <p:cNvSpPr/>
           <p:nvPr/>
         </p:nvSpPr>
@@ -5844,7 +5844,7 @@
       </p:sp>
       <p:sp>
         <p:nvSpPr>
-          <p:cNvPr id="6" name="Text 195"/>
+          <p:cNvPr id="6" name="Text 196"/>
           <p:cNvSpPr txBox="1"/>
           <p:nvPr/>
         </p:nvSpPr>
@@ -5880,7 +5880,7 @@
       </p:sp>
       <p:sp>
         <p:nvSpPr>
-          <p:cNvPr id="7" name="Badge 196"/>
+          <p:cNvPr id="7" name="Badge 197"/>
           <p:cNvSpPr/>
           <p:nvPr/>
         </p:nvSpPr>
@@ -5922,7 +5922,7 @@
       </p:sp>
       <p:sp>
         <p:nvSpPr>
-          <p:cNvPr id="8" name="Text 197"/>
+          <p:cNvPr id="8" name="Text 198"/>
           <p:cNvSpPr txBox="1"/>
           <p:nvPr/>
         </p:nvSpPr>
@@ -5958,7 +5958,7 @@
       </p:sp>
       <p:sp>
         <p:nvSpPr>
-          <p:cNvPr id="9" name="Text 198"/>
+          <p:cNvPr id="9" name="Text 199"/>
           <p:cNvSpPr txBox="1"/>
           <p:nvPr/>
         </p:nvSpPr>
@@ -6008,7 +6008,7 @@
       </p:sp>
       <p:sp>
         <p:nvSpPr>
-          <p:cNvPr id="10" name="Card 199"/>
+          <p:cNvPr id="10" name="Card 200"/>
           <p:cNvSpPr/>
           <p:nvPr/>
         </p:nvSpPr>
@@ -6039,7 +6039,7 @@
       </p:sp>
       <p:sp>
         <p:nvSpPr>
-          <p:cNvPr id="11" name="Text 200"/>
+          <p:cNvPr id="11" name="Text 201"/>
           <p:cNvSpPr txBox="1"/>
           <p:nvPr/>
         </p:nvSpPr>
@@ -6075,7 +6075,7 @@
       </p:sp>
       <p:sp>
         <p:nvSpPr>
-          <p:cNvPr id="12" name="Text 201"/>
+          <p:cNvPr id="12" name="Text 202"/>
           <p:cNvSpPr txBox="1"/>
           <p:nvPr/>
         </p:nvSpPr>
@@ -6111,7 +6111,7 @@
       </p:sp>
       <p:sp>
         <p:nvSpPr>
-          <p:cNvPr id="13" name="Dot 202"/>
+          <p:cNvPr id="13" name="Dot 203"/>
           <p:cNvSpPr/>
           <p:nvPr/>
         </p:nvSpPr>
@@ -6136,7 +6136,7 @@
       </p:sp>
       <p:sp>
         <p:nvSpPr>
-          <p:cNvPr id="14" name="Dot 203"/>
+          <p:cNvPr id="14" name="Dot 204"/>
           <p:cNvSpPr/>
           <p:nvPr/>
         </p:nvSpPr>
@@ -6161,7 +6161,7 @@
       </p:sp>
       <p:sp>
         <p:nvSpPr>
-          <p:cNvPr id="15" name="Dot 204"/>
+          <p:cNvPr id="15" name="Dot 205"/>
           <p:cNvSpPr/>
           <p:nvPr/>
         </p:nvSpPr>
@@ -6186,7 +6186,7 @@
       </p:sp>
       <p:sp>
         <p:nvSpPr>
-          <p:cNvPr id="16" name="Dot 205"/>
+          <p:cNvPr id="16" name="Dot 206"/>
           <p:cNvSpPr/>
           <p:nvPr/>
         </p:nvSpPr>
@@ -6211,7 +6211,7 @@
       </p:sp>
       <p:sp>
         <p:nvSpPr>
-          <p:cNvPr id="17" name="Dot 206"/>
+          <p:cNvPr id="17" name="Dot 207"/>
           <p:cNvSpPr/>
           <p:nvPr/>
         </p:nvSpPr>
@@ -6236,7 +6236,7 @@
       </p:sp>
       <p:sp>
         <p:nvSpPr>
-          <p:cNvPr id="18" name="Dot 207"/>
+          <p:cNvPr id="18" name="Dot 208"/>
           <p:cNvSpPr/>
           <p:nvPr/>
         </p:nvSpPr>
@@ -6261,7 +6261,7 @@
       </p:sp>
       <p:sp>
         <p:nvSpPr>
-          <p:cNvPr id="19" name="Dot 208"/>
+          <p:cNvPr id="19" name="Dot 209"/>
           <p:cNvSpPr/>
           <p:nvPr/>
         </p:nvSpPr>
@@ -6286,7 +6286,7 @@
       </p:sp>
       <p:sp>
         <p:nvSpPr>
-          <p:cNvPr id="20" name="Centroid 209"/>
+          <p:cNvPr id="20" name="Centroid 210"/>
           <p:cNvSpPr/>
           <p:nvPr/>
         </p:nvSpPr>
@@ -6311,7 +6311,7 @@
       </p:sp>
       <p:sp>
         <p:nvSpPr>
-          <p:cNvPr id="21" name="Dot 210"/>
+          <p:cNvPr id="21" name="Dot 211"/>
           <p:cNvSpPr/>
           <p:nvPr/>
         </p:nvSpPr>
@@ -6336,7 +6336,7 @@
       </p:sp>
       <p:sp>
         <p:nvSpPr>
-          <p:cNvPr id="22" name="Dot 211"/>
+          <p:cNvPr id="22" name="Dot 212"/>
           <p:cNvSpPr/>
           <p:nvPr/>
         </p:nvSpPr>
@@ -6361,7 +6361,7 @@
       </p:sp>
       <p:sp>
         <p:nvSpPr>
-          <p:cNvPr id="23" name="Dot 212"/>
+          <p:cNvPr id="23" name="Dot 213"/>
           <p:cNvSpPr/>
           <p:nvPr/>
         </p:nvSpPr>
@@ -6386,7 +6386,7 @@
       </p:sp>
       <p:sp>
         <p:nvSpPr>
-          <p:cNvPr id="24" name="Dot 213"/>
+          <p:cNvPr id="24" name="Dot 214"/>
           <p:cNvSpPr/>
           <p:nvPr/>
         </p:nvSpPr>
@@ -6411,7 +6411,7 @@
       </p:sp>
       <p:sp>
         <p:nvSpPr>
-          <p:cNvPr id="25" name="Dot 214"/>
+          <p:cNvPr id="25" name="Dot 215"/>
           <p:cNvSpPr/>
           <p:nvPr/>
         </p:nvSpPr>
@@ -6436,7 +6436,7 @@
       </p:sp>
       <p:sp>
         <p:nvSpPr>
-          <p:cNvPr id="26" name="Dot 215"/>
+          <p:cNvPr id="26" name="Dot 216"/>
           <p:cNvSpPr/>
           <p:nvPr/>
         </p:nvSpPr>
@@ -6461,7 +6461,7 @@
       </p:sp>
       <p:sp>
         <p:nvSpPr>
-          <p:cNvPr id="27" name="Dot 216"/>
+          <p:cNvPr id="27" name="Dot 217"/>
           <p:cNvSpPr/>
           <p:nvPr/>
         </p:nvSpPr>
@@ -6486,7 +6486,7 @@
       </p:sp>
       <p:sp>
         <p:nvSpPr>
-          <p:cNvPr id="28" name="Centroid 217"/>
+          <p:cNvPr id="28" name="Centroid 218"/>
           <p:cNvSpPr/>
           <p:nvPr/>
         </p:nvSpPr>
@@ -6511,7 +6511,7 @@
       </p:sp>
       <p:sp>
         <p:nvSpPr>
-          <p:cNvPr id="29" name="Dot 218"/>
+          <p:cNvPr id="29" name="Dot 219"/>
           <p:cNvSpPr/>
           <p:nvPr/>
         </p:nvSpPr>
@@ -6536,7 +6536,7 @@
       </p:sp>
       <p:sp>
         <p:nvSpPr>
-          <p:cNvPr id="30" name="Dot 219"/>
+          <p:cNvPr id="30" name="Dot 220"/>
           <p:cNvSpPr/>
           <p:nvPr/>
         </p:nvSpPr>
@@ -6561,7 +6561,7 @@
       </p:sp>
       <p:sp>
         <p:nvSpPr>
-          <p:cNvPr id="31" name="Dot 220"/>
+          <p:cNvPr id="31" name="Dot 221"/>
           <p:cNvSpPr/>
           <p:nvPr/>
         </p:nvSpPr>
@@ -6586,7 +6586,7 @@
       </p:sp>
       <p:sp>
         <p:nvSpPr>
-          <p:cNvPr id="32" name="Dot 221"/>
+          <p:cNvPr id="32" name="Dot 222"/>
           <p:cNvSpPr/>
           <p:nvPr/>
         </p:nvSpPr>
@@ -6611,7 +6611,7 @@
       </p:sp>
       <p:sp>
         <p:nvSpPr>
-          <p:cNvPr id="33" name="Dot 222"/>
+          <p:cNvPr id="33" name="Dot 223"/>
           <p:cNvSpPr/>
           <p:nvPr/>
         </p:nvSpPr>
@@ -6636,7 +6636,7 @@
       </p:sp>
       <p:sp>
         <p:nvSpPr>
-          <p:cNvPr id="34" name="Dot 223"/>
+          <p:cNvPr id="34" name="Dot 224"/>
           <p:cNvSpPr/>
           <p:nvPr/>
         </p:nvSpPr>
@@ -6661,7 +6661,7 @@
       </p:sp>
       <p:sp>
         <p:nvSpPr>
-          <p:cNvPr id="35" name="Dot 224"/>
+          <p:cNvPr id="35" name="Dot 225"/>
           <p:cNvSpPr/>
           <p:nvPr/>
         </p:nvSpPr>
@@ -6686,7 +6686,7 @@
       </p:sp>
       <p:sp>
         <p:nvSpPr>
-          <p:cNvPr id="36" name="Centroid 225"/>
+          <p:cNvPr id="36" name="Centroid 226"/>
           <p:cNvSpPr/>
           <p:nvPr/>
         </p:nvSpPr>
@@ -13927,7 +13927,72 @@
       </p:sp>
       <p:sp>
         <p:nvSpPr>
-          <p:cNvPr id="8" name="Badge 151"/>
+          <p:cNvPr id="8" name="Text 151"/>
+          <p:cNvSpPr txBox="1"/>
+          <p:nvPr/>
+        </p:nvSpPr>
+        <p:spPr>
+          <a:xfrm>
+            <a:off x="457200" y="4407408"/>
+            <a:ext cx="4846320" cy="256032"/>
+          </a:xfrm>
+          <a:prstGeom prst="rect">
+            <a:avLst/>
+          </a:prstGeom>
+          <a:noFill/>
+          <a:ln/>
+        </p:spPr>
+        <p:txBody>
+          <a:bodyPr wrap="square" lIns="0" tIns="0" rIns="0" bIns="0" rtlCol="0" anchor="ctr"/>
+          <a:lstStyle/>
+          <a:p>
+            <a:pPr algn="l" indent="0" marL="0">
+              <a:buNone/>
+            </a:pPr>
+            <a:r>
+              <a:rPr lang="en-US" sz="1100" dirty="0">
+                <a:solidFill>
+                  <a:schemeClr val="accent5"/>
+                </a:solidFill>
+              </a:rPr>
+              <a:t>Source: </a:t>
+            </a:r>
+            <a:pPr algn="l" indent="0" marL="0">
+              <a:buNone/>
+            </a:pPr>
+            <a:r>
+              <a:rPr lang="en-US" sz="1100" b="1" u="sng" dirty="0">
+                <a:solidFill>
+                  <a:schemeClr val="tx2"/>
+                </a:solidFill>
+                <a:hlinkClick r:id="rId1" invalidUrl="" action="" tgtFrame="" tooltip="Brazilian E-Commerce Public Dataset by Olist" history="1" highlightClick="0" endSnd="0">
+                  <a:extLst>
+                    <a:ext uri="{A12FA001-AC4F-418D-AE19-62706E023703}">
+                      <ahyp:hlinkClr xmlns:ahyp="http://schemas.microsoft.com/office/drawing/2018/hyperlinkcolor" val="tx"/>
+                    </a:ext>
+                  </a:extLst>
+                </a:hlinkClick>
+              </a:rPr>
+              <a:t>github.com/olist/work-at-olist-data</a:t>
+            </a:r>
+            <a:pPr algn="l" indent="0" marL="0">
+              <a:buNone/>
+            </a:pPr>
+            <a:r>
+              <a:rPr lang="en-US" sz="1100" dirty="0">
+                <a:solidFill>
+                  <a:schemeClr val="accent5"/>
+                </a:solidFill>
+              </a:rPr>
+              <a:t>  (Olist, MIT licence)</a:t>
+            </a:r>
+            <a:endParaRPr lang="en-US" sz="1100" dirty="0"/>
+          </a:p>
+        </p:txBody>
+      </p:sp>
+      <p:sp>
+        <p:nvSpPr>
+          <p:cNvPr id="9" name="Badge 152"/>
           <p:cNvSpPr/>
           <p:nvPr/>
         </p:nvSpPr>
@@ -13969,7 +14034,7 @@
       </p:sp>
       <p:sp>
         <p:nvSpPr>
-          <p:cNvPr id="9" name="Text 152"/>
+          <p:cNvPr id="10" name="Text 153"/>
           <p:cNvSpPr txBox="1"/>
           <p:nvPr/>
         </p:nvSpPr>
@@ -14005,7 +14070,7 @@
       </p:sp>
       <p:sp>
         <p:nvSpPr>
-          <p:cNvPr id="10" name="Text 153"/>
+          <p:cNvPr id="11" name="Text 154"/>
           <p:cNvSpPr txBox="1"/>
           <p:nvPr/>
         </p:nvSpPr>
@@ -14041,7 +14106,7 @@
       </p:sp>
       <p:sp>
         <p:nvSpPr>
-          <p:cNvPr id="11" name="Badge 154"/>
+          <p:cNvPr id="12" name="Badge 155"/>
           <p:cNvSpPr/>
           <p:nvPr/>
         </p:nvSpPr>
@@ -14083,7 +14148,7 @@
       </p:sp>
       <p:sp>
         <p:nvSpPr>
-          <p:cNvPr id="12" name="Text 155"/>
+          <p:cNvPr id="13" name="Text 156"/>
           <p:cNvSpPr txBox="1"/>
           <p:nvPr/>
         </p:nvSpPr>
@@ -14119,7 +14184,7 @@
       </p:sp>
       <p:sp>
         <p:nvSpPr>
-          <p:cNvPr id="13" name="Text 156"/>
+          <p:cNvPr id="14" name="Text 157"/>
           <p:cNvSpPr txBox="1"/>
           <p:nvPr/>
         </p:nvSpPr>
@@ -14155,7 +14220,7 @@
       </p:sp>
       <p:sp>
         <p:nvSpPr>
-          <p:cNvPr id="14" name="Badge 157"/>
+          <p:cNvPr id="15" name="Badge 158"/>
           <p:cNvSpPr/>
           <p:nvPr/>
         </p:nvSpPr>
@@ -14197,7 +14262,7 @@
       </p:sp>
       <p:sp>
         <p:nvSpPr>
-          <p:cNvPr id="15" name="Text 158"/>
+          <p:cNvPr id="16" name="Text 159"/>
           <p:cNvSpPr txBox="1"/>
           <p:nvPr/>
         </p:nvSpPr>
@@ -14233,7 +14298,7 @@
       </p:sp>
       <p:sp>
         <p:nvSpPr>
-          <p:cNvPr id="16" name="Text 159"/>
+          <p:cNvPr id="17" name="Text 160"/>
           <p:cNvSpPr txBox="1"/>
           <p:nvPr/>
         </p:nvSpPr>
@@ -14393,7 +14458,7 @@
       </p:graphicFrame>
       <p:sp>
         <p:nvSpPr>
-          <p:cNvPr id="5" name="Badge 160"/>
+          <p:cNvPr id="5" name="Badge 161"/>
           <p:cNvSpPr/>
           <p:nvPr/>
         </p:nvSpPr>
@@ -14435,7 +14500,7 @@
       </p:sp>
       <p:sp>
         <p:nvSpPr>
-          <p:cNvPr id="6" name="Text 161"/>
+          <p:cNvPr id="6" name="Text 162"/>
           <p:cNvSpPr txBox="1"/>
           <p:nvPr/>
         </p:nvSpPr>
@@ -14471,7 +14536,7 @@
       </p:sp>
       <p:sp>
         <p:nvSpPr>
-          <p:cNvPr id="7" name="Text 162"/>
+          <p:cNvPr id="7" name="Text 163"/>
           <p:cNvSpPr txBox="1"/>
           <p:nvPr/>
         </p:nvSpPr>
@@ -14507,7 +14572,7 @@
       </p:sp>
       <p:sp>
         <p:nvSpPr>
-          <p:cNvPr id="8" name="Badge 163"/>
+          <p:cNvPr id="8" name="Badge 164"/>
           <p:cNvSpPr/>
           <p:nvPr/>
         </p:nvSpPr>
@@ -14549,7 +14614,7 @@
       </p:sp>
       <p:sp>
         <p:nvSpPr>
-          <p:cNvPr id="9" name="Text 164"/>
+          <p:cNvPr id="9" name="Text 165"/>
           <p:cNvSpPr txBox="1"/>
           <p:nvPr/>
         </p:nvSpPr>
@@ -14585,7 +14650,7 @@
       </p:sp>
       <p:sp>
         <p:nvSpPr>
-          <p:cNvPr id="10" name="Text 165"/>
+          <p:cNvPr id="10" name="Text 166"/>
           <p:cNvSpPr txBox="1"/>
           <p:nvPr/>
         </p:nvSpPr>
@@ -14621,7 +14686,7 @@
       </p:sp>
       <p:sp>
         <p:nvSpPr>
-          <p:cNvPr id="11" name="Badge 166"/>
+          <p:cNvPr id="11" name="Badge 167"/>
           <p:cNvSpPr/>
           <p:nvPr/>
         </p:nvSpPr>
@@ -14663,7 +14728,7 @@
       </p:sp>
       <p:sp>
         <p:nvSpPr>
-          <p:cNvPr id="12" name="Text 167"/>
+          <p:cNvPr id="12" name="Text 168"/>
           <p:cNvSpPr txBox="1"/>
           <p:nvPr/>
         </p:nvSpPr>
@@ -14699,7 +14764,7 @@
       </p:sp>
       <p:sp>
         <p:nvSpPr>
-          <p:cNvPr id="13" name="Text 168"/>
+          <p:cNvPr id="13" name="Text 169"/>
           <p:cNvSpPr txBox="1"/>
           <p:nvPr/>
         </p:nvSpPr>
@@ -14735,7 +14800,7 @@
       </p:sp>
       <p:sp>
         <p:nvSpPr>
-          <p:cNvPr id="14" name="Pill 169"/>
+          <p:cNvPr id="14" name="Pill 170"/>
           <p:cNvSpPr/>
           <p:nvPr/>
         </p:nvSpPr>

</xml_diff>

<commit_message>
The slide's elbow values are the notebook's own
The notebook was run end to end with scikit-learn and matplotlib on the Olist
files. Its four clusters, their averages and the walking figures equal the
slides and the page; k = 7 on the elbow differed in the first decimal (412.4,
not 410.9), so the slide and results.json now carry the notebook's value, and
results.json also records the silhouette scores.
</commit_message>
<xml_diff>
--- a/slides/kmeans-sku-clustering.pptx
+++ b/slides/kmeans-sku-clustering.pptx
@@ -118,21 +118,21 @@
   <p:extLst>
     <p:ext uri="{521415D9-36F7-43E2-AB2F-B90AF26B5E84}">
       <p14:sectionLst xmlns:p14="http://schemas.microsoft.com/office/powerpoint/2010/main">
-        <p14:section name="Problem" id="{972b2275-318b-cda7-86fb-2958f33539de}">
+        <p14:section name="Problem" id="{099f2497-b5f5-05c0-974a-785f22f931ad}">
           <p14:sldIdLst>
             <p14:sldId id="256"/>
             <p14:sldId id="257"/>
             <p14:sldId id="258"/>
           </p14:sldIdLst>
         </p14:section>
-        <p14:section name="Choosing the solution" id="{1073c501-4c5e-6d78-c32c-4d206b7d0dad}">
+        <p14:section name="Choosing the solution" id="{0bf23e29-e3f3-9ec0-318f-3c9eb4770178}">
           <p14:sldIdLst>
             <p14:sldId id="259"/>
             <p14:sldId id="260"/>
             <p14:sldId id="261"/>
           </p14:sldIdLst>
         </p14:section>
-        <p14:section name="Applying K-Means" id="{ece8b786-5d4f-4b9f-a280-8bf513cabadc}">
+        <p14:section name="Applying K-Means" id="{feefb918-403d-9ace-d26d-aa9d6701d430}">
           <p14:sldIdLst>
             <p14:sldId id="262"/>
             <p14:sldId id="263"/>
@@ -140,7 +140,7 @@
             <p14:sldId id="265"/>
           </p14:sldIdLst>
         </p14:section>
-        <p14:section name="Conclusion" id="{9cfa82c8-0779-bf8d-bc23-3a152d7bc9c6}">
+        <p14:section name="Conclusion" id="{5389a795-8b1b-6e0c-0cfb-3a87d976be45}">
           <p14:sldIdLst>
             <p14:sldId id="266"/>
             <p14:sldId id="267"/>
@@ -322,7 +322,7 @@
                   <c:v>453.9</c:v>
                 </c:pt>
                 <c:pt idx="6">
-                  <c:v>410.9</c:v>
+                  <c:v>412.4</c:v>
                 </c:pt>
                 <c:pt idx="7">
                   <c:v>368.2</c:v>

</xml_diff>

<commit_message>
The slides' graphs are pictures, so they show in every viewer
The graphs were chart objects, which PowerPoint and LibreOffice draw and a
preview pane does not: opened in a previewer, six slides showed text around an
empty space. Each graph is now drawn as a picture from the same numbers and
placed where the chart was. A PDF of the slides is added for viewers that do
not open PowerPoint files at all.
</commit_message>
<xml_diff>
--- a/slides/kmeans-sku-clustering.pptx
+++ b/slides/kmeans-sku-clustering.pptx
@@ -124,21 +124,21 @@
   <p:extLst>
     <p:ext uri="{521415D9-36F7-43E2-AB2F-B90AF26B5E84}">
       <p14:sectionLst xmlns:p14="http://schemas.microsoft.com/office/powerpoint/2010/main">
-        <p14:section name="Problem" id="{dfd8c3b2-d5b0-4dcf-2132-3a25657c9196}">
+        <p14:section name="Problem" id="{ac1aaaca-68fd-3637-aa4f-15ff21859010}">
           <p14:sldIdLst>
             <p14:sldId id="256"/>
             <p14:sldId id="257"/>
             <p14:sldId id="258"/>
           </p14:sldIdLst>
         </p14:section>
-        <p14:section name="Choosing the solution" id="{77378515-c681-f7d0-09c5-db7e48e1fa29}">
+        <p14:section name="Choosing the solution" id="{80383ef3-e3ba-93ee-fdda-51ed4c78ddc7}">
           <p14:sldIdLst>
             <p14:sldId id="259"/>
             <p14:sldId id="260"/>
             <p14:sldId id="261"/>
           </p14:sldIdLst>
         </p14:section>
-        <p14:section name="Applying K-Means" id="{8e67a60f-7d24-8f16-8bbe-848f3d9fcfe2}">
+        <p14:section name="Applying K-Means" id="{e4171355-c9ec-1ccd-dc0b-46eb96e1eb36}">
           <p14:sldIdLst>
             <p14:sldId id="262"/>
             <p14:sldId id="263"/>
@@ -151,7 +151,7 @@
             <p14:sldId id="270"/>
           </p14:sldIdLst>
         </p14:section>
-        <p14:section name="Conclusion" id="{f47e0da4-6146-37a7-a7de-b2421f47b790}">
+        <p14:section name="Conclusion" id="{f8b81953-df68-4b25-4b59-4f341399e03c}">
           <p14:sldIdLst>
             <p14:sldId id="271"/>
             <p14:sldId id="272"/>
@@ -165,3251 +165,6 @@
     </p:ext>
   </p:extLst>
 </p:presentation>
-</file>
-
-<file path=ppt/charts/chart1.xml><?xml version="1.0" encoding="utf-8"?>
-<c:chartSpace xmlns:c="http://schemas.openxmlformats.org/drawingml/2006/chart" xmlns:a="http://schemas.openxmlformats.org/drawingml/2006/main" xmlns:r="http://schemas.openxmlformats.org/officeDocument/2006/relationships">
-  <c:date1904 val="0"/>
-  <c:roundedCorners val="1"/>
-  <c:chart>
-    <c:title>
-      <c:tx>
-        <c:rich>
-          <a:bodyPr/>
-          <a:lstStyle/>
-          <a:p>
-            <a:pPr>
-              <a:defRPr sz="1200" b="0" i="0" u="none" strike="noStrike">
-                <a:solidFill>
-                  <a:srgbClr val="0F4C5C"/>
-                </a:solidFill>
-                <a:latin typeface="+mn-lt"/>
-              </a:defRPr>
-            </a:pPr>
-            <a:r>
-              <a:rPr sz="1200" b="0" i="0" u="none" strike="noStrike">
-                <a:solidFill>
-                  <a:srgbClr val="0F4C5C"/>
-                </a:solidFill>
-                <a:latin typeface="+mn-lt"/>
-              </a:rPr>
-              <a:t>Orders placed in each month</a:t>
-            </a:r>
-          </a:p>
-        </c:rich>
-      </c:tx>
-      <c:layout/>
-      <c:overlay val="0"/>
-    </c:title>
-    <c:autoTitleDeleted val="0"/>
-    <c:plotArea>
-      <c:layout/>
-      <c:barChart>
-        <c:barDir val="col"/>
-        <c:grouping val="clustered"/>
-        <c:varyColors val="0"/>
-        <c:ser>
-          <c:idx val="0"/>
-          <c:order val="0"/>
-          <c:tx>
-            <c:strRef>
-              <c:f>Sheet1!$B$1</c:f>
-              <c:strCache>
-                <c:ptCount val="1"/>
-                <c:pt idx="0">
-                  <c:v>Orders</c:v>
-                </c:pt>
-              </c:strCache>
-            </c:strRef>
-          </c:tx>
-          <c:spPr>
-            <a:solidFill>
-              <a:srgbClr val="2A78D6"/>
-            </a:solidFill>
-            <a:effectLst/>
-          </c:spPr>
-          <c:invertIfNegative val="0"/>
-          <c:dLbls>
-            <c:numFmt formatCode="#,##0" sourceLinked="0"/>
-            <c:txPr>
-              <a:bodyPr/>
-              <a:lstStyle/>
-              <a:p>
-                <a:pPr>
-                  <a:defRPr b="0" i="0" strike="noStrike" sz="1200" u="none">
-                    <a:solidFill>
-                      <a:srgbClr val="000000"/>
-                    </a:solidFill>
-                    <a:latin typeface="+mn-lt"/>
-                  </a:defRPr>
-                </a:pPr>
-              </a:p>
-            </c:txPr>
-            <c:showLegendKey val="0"/>
-            <c:showVal val="0"/>
-            <c:showCatName val="0"/>
-            <c:showSerName val="0"/>
-            <c:showPercent val="0"/>
-            <c:showBubbleSize val="0"/>
-            <c:showLeaderLines val="0"/>
-          </c:dLbls>
-          <c:cat>
-            <c:multiLvlStrRef>
-              <c:f>Sheet1!$A$2:$A$22</c:f>
-              <c:multiLvlStrCache>
-                <c:ptCount val="21"/>
-                <c:lvl>
-                  <c:pt idx="0">
-                    <c:v>2016-10</c:v>
-                  </c:pt>
-                  <c:pt idx="1">
-                    <c:v>2017-01</c:v>
-                  </c:pt>
-                  <c:pt idx="2">
-                    <c:v>2017-02</c:v>
-                  </c:pt>
-                  <c:pt idx="3">
-                    <c:v>2017-03</c:v>
-                  </c:pt>
-                  <c:pt idx="4">
-                    <c:v>2017-04</c:v>
-                  </c:pt>
-                  <c:pt idx="5">
-                    <c:v>2017-05</c:v>
-                  </c:pt>
-                  <c:pt idx="6">
-                    <c:v>2017-06</c:v>
-                  </c:pt>
-                  <c:pt idx="7">
-                    <c:v>2017-07</c:v>
-                  </c:pt>
-                  <c:pt idx="8">
-                    <c:v>2017-08</c:v>
-                  </c:pt>
-                  <c:pt idx="9">
-                    <c:v>2017-09</c:v>
-                  </c:pt>
-                  <c:pt idx="10">
-                    <c:v>2017-10</c:v>
-                  </c:pt>
-                  <c:pt idx="11">
-                    <c:v>2017-11</c:v>
-                  </c:pt>
-                  <c:pt idx="12">
-                    <c:v>2017-12</c:v>
-                  </c:pt>
-                  <c:pt idx="13">
-                    <c:v>2018-01</c:v>
-                  </c:pt>
-                  <c:pt idx="14">
-                    <c:v>2018-02</c:v>
-                  </c:pt>
-                  <c:pt idx="15">
-                    <c:v>2018-03</c:v>
-                  </c:pt>
-                  <c:pt idx="16">
-                    <c:v>2018-04</c:v>
-                  </c:pt>
-                  <c:pt idx="17">
-                    <c:v>2018-05</c:v>
-                  </c:pt>
-                  <c:pt idx="18">
-                    <c:v>2018-06</c:v>
-                  </c:pt>
-                  <c:pt idx="19">
-                    <c:v>2018-07</c:v>
-                  </c:pt>
-                  <c:pt idx="20">
-                    <c:v>2018-08</c:v>
-                  </c:pt>
-                </c:lvl>
-              </c:multiLvlStrCache>
-            </c:multiLvlStrRef>
-          </c:cat>
-          <c:val>
-            <c:numRef>
-              <c:f>Sheet1!$B$2:$B$22</c:f>
-              <c:numCache>
-                <c:formatCode>General</c:formatCode>
-                <c:ptCount val="21"/>
-                <c:pt idx="0">
-                  <c:v>324</c:v>
-                </c:pt>
-                <c:pt idx="1">
-                  <c:v>800</c:v>
-                </c:pt>
-                <c:pt idx="2">
-                  <c:v>1780</c:v>
-                </c:pt>
-                <c:pt idx="3">
-                  <c:v>2682</c:v>
-                </c:pt>
-                <c:pt idx="4">
-                  <c:v>2404</c:v>
-                </c:pt>
-                <c:pt idx="5">
-                  <c:v>3700</c:v>
-                </c:pt>
-                <c:pt idx="6">
-                  <c:v>3245</c:v>
-                </c:pt>
-                <c:pt idx="7">
-                  <c:v>4026</c:v>
-                </c:pt>
-                <c:pt idx="8">
-                  <c:v>4331</c:v>
-                </c:pt>
-                <c:pt idx="9">
-                  <c:v>4285</c:v>
-                </c:pt>
-                <c:pt idx="10">
-                  <c:v>4631</c:v>
-                </c:pt>
-                <c:pt idx="11">
-                  <c:v>7544</c:v>
-                </c:pt>
-                <c:pt idx="12">
-                  <c:v>5673</c:v>
-                </c:pt>
-                <c:pt idx="13">
-                  <c:v>7269</c:v>
-                </c:pt>
-                <c:pt idx="14">
-                  <c:v>6728</c:v>
-                </c:pt>
-                <c:pt idx="15">
-                  <c:v>7211</c:v>
-                </c:pt>
-                <c:pt idx="16">
-                  <c:v>6939</c:v>
-                </c:pt>
-                <c:pt idx="17">
-                  <c:v>6873</c:v>
-                </c:pt>
-                <c:pt idx="18">
-                  <c:v>6167</c:v>
-                </c:pt>
-                <c:pt idx="19">
-                  <c:v>6292</c:v>
-                </c:pt>
-                <c:pt idx="20">
-                  <c:v>6512</c:v>
-                </c:pt>
-              </c:numCache>
-            </c:numRef>
-          </c:val>
-        </c:ser>
-        <c:dLbls>
-          <c:numFmt formatCode="#,##0" sourceLinked="0"/>
-          <c:txPr>
-            <a:bodyPr/>
-            <a:lstStyle/>
-            <a:p>
-              <a:pPr>
-                <a:defRPr b="0" i="0" strike="noStrike" sz="1200" u="none">
-                  <a:solidFill>
-                    <a:srgbClr val="000000"/>
-                  </a:solidFill>
-                  <a:latin typeface="+mn-lt"/>
-                </a:defRPr>
-              </a:pPr>
-            </a:p>
-          </c:txPr>
-          <c:showLegendKey val="0"/>
-          <c:showVal val="0"/>
-          <c:showCatName val="0"/>
-          <c:showSerName val="0"/>
-          <c:showPercent val="0"/>
-          <c:showBubbleSize val="0"/>
-          <c:showLeaderLines val="0"/>
-        </c:dLbls>
-        <c:gapWidth val="40"/>
-        <c:overlap val="0"/>
-        <c:axId val="2094734554"/>
-        <c:axId val="2094734552"/>
-        <c:axId val="2094734556"/>
-      </c:barChart>
-      <c:catAx>
-        <c:axId val="2094734554"/>
-        <c:scaling>
-          <c:orientation val="minMax"/>
-        </c:scaling>
-        <c:delete val="0"/>
-        <c:axPos val="b"/>
-        <c:numFmt formatCode="General" sourceLinked="1"/>
-        <c:majorTickMark val="out"/>
-        <c:minorTickMark val="none"/>
-        <c:tickLblPos val="low"/>
-        <c:spPr>
-          <a:ln w="12700" cap="flat">
-            <a:solidFill>
-              <a:srgbClr val="888888"/>
-            </a:solidFill>
-            <a:prstDash val="solid"/>
-            <a:round/>
-          </a:ln>
-        </c:spPr>
-        <c:txPr>
-          <a:bodyPr rot="16200000"/>
-          <a:lstStyle/>
-          <a:p>
-            <a:pPr>
-              <a:defRPr sz="900" b="0" i="0" u="none" strike="noStrike">
-                <a:solidFill>
-                  <a:srgbClr val="5F7180"/>
-                </a:solidFill>
-                <a:latin typeface="+mn-lt"/>
-              </a:defRPr>
-            </a:pPr>
-            <a:endParaRPr lang="en-US"/>
-          </a:p>
-        </c:txPr>
-        <c:crossAx val="2094734552"/>
-        <c:crosses val="autoZero"/>
-        <c:auto val="1"/>
-        <c:lblAlgn val="ctr"/>
-        <c:noMultiLvlLbl val="1"/>
-      </c:catAx>
-      <c:valAx>
-        <c:axId val="2094734552"/>
-        <c:scaling>
-          <c:orientation val="minMax"/>
-        </c:scaling>
-        <c:delete val="0"/>
-        <c:axPos val="l"/>
-        <c:majorGridlines>
-          <c:spPr>
-            <a:ln w="9525" cap="flat">
-              <a:solidFill>
-                <a:srgbClr val="EAF2F3"/>
-              </a:solidFill>
-              <a:prstDash val="solid"/>
-              <a:round/>
-            </a:ln>
-          </c:spPr>
-        </c:majorGridlines>
-        <c:numFmt formatCode="#,##0" sourceLinked="0"/>
-        <c:majorTickMark val="out"/>
-        <c:minorTickMark val="none"/>
-        <c:tickLblPos val="nextTo"/>
-        <c:spPr>
-          <a:ln w="12700" cap="flat">
-            <a:solidFill>
-              <a:srgbClr val="888888"/>
-            </a:solidFill>
-            <a:prstDash val="solid"/>
-            <a:round/>
-          </a:ln>
-        </c:spPr>
-        <c:txPr>
-          <a:bodyPr/>
-          <a:lstStyle/>
-          <a:p>
-            <a:pPr>
-              <a:defRPr sz="1100" b="0" i="0" u="none" strike="noStrike">
-                <a:solidFill>
-                  <a:srgbClr val="5F7180"/>
-                </a:solidFill>
-                <a:latin typeface="+mn-lt"/>
-              </a:defRPr>
-            </a:pPr>
-            <a:endParaRPr lang="en-US"/>
-          </a:p>
-        </c:txPr>
-        <c:crossAx val="2094734554"/>
-        <c:crosses val="autoZero"/>
-        <c:crossBetween val="between"/>
-      </c:valAx>
-      <c:spPr>
-        <a:noFill/>
-        <a:ln>
-          <a:noFill/>
-        </a:ln>
-        <a:effectLst/>
-      </c:spPr>
-    </c:plotArea>
-    <c:plotVisOnly val="1"/>
-    <c:dispBlanksAs val="span"/>
-  </c:chart>
-  <c:spPr>
-    <a:noFill/>
-    <a:ln>
-      <a:noFill/>
-    </a:ln>
-    <a:effectLst/>
-  </c:spPr>
-  <c:externalData r:id="rId1">
-    <c:autoUpdate val="0"/>
-  </c:externalData>
-</c:chartSpace>
-</file>
-
-<file path=ppt/charts/chart2.xml><?xml version="1.0" encoding="utf-8"?>
-<c:chartSpace xmlns:c="http://schemas.openxmlformats.org/drawingml/2006/chart" xmlns:a="http://schemas.openxmlformats.org/drawingml/2006/main" xmlns:r="http://schemas.openxmlformats.org/officeDocument/2006/relationships">
-  <c:date1904 val="0"/>
-  <c:roundedCorners val="1"/>
-  <c:chart>
-    <c:title>
-      <c:tx>
-        <c:rich>
-          <a:bodyPr/>
-          <a:lstStyle/>
-          <a:p>
-            <a:pPr>
-              <a:defRPr sz="1200" b="0" i="0" u="none" strike="noStrike">
-                <a:solidFill>
-                  <a:srgbClr val="0F4C5C"/>
-                </a:solidFill>
-                <a:latin typeface="+mn-lt"/>
-              </a:defRPr>
-            </a:pPr>
-            <a:r>
-              <a:rPr sz="1200" b="0" i="0" u="none" strike="noStrike">
-                <a:solidFill>
-                  <a:srgbClr val="0F4C5C"/>
-                </a:solidFill>
-                <a:latin typeface="+mn-lt"/>
-              </a:rPr>
-              <a:t>Elbow curve on the real data (383 SKUs)</a:t>
-            </a:r>
-          </a:p>
-        </c:rich>
-      </c:tx>
-      <c:layout/>
-      <c:overlay val="0"/>
-    </c:title>
-    <c:autoTitleDeleted val="0"/>
-    <c:plotArea>
-      <c:layout/>
-      <c:lineChart>
-        <c:varyColors val="0"/>
-        <c:ser>
-          <c:idx val="0"/>
-          <c:order val="0"/>
-          <c:tx>
-            <c:strRef>
-              <c:f>Sheet1!$B$1</c:f>
-              <c:strCache>
-                <c:ptCount val="1"/>
-                <c:pt idx="0">
-                  <c:v>Within-cluster variance</c:v>
-                </c:pt>
-              </c:strCache>
-            </c:strRef>
-          </c:tx>
-          <c:spPr>
-            <a:solidFill>
-              <a:srgbClr val="F28C28"/>
-            </a:solidFill>
-            <a:ln w="38100" cap="flat">
-              <a:solidFill>
-                <a:srgbClr val="F28C28"/>
-              </a:solidFill>
-              <a:prstDash val="solid"/>
-              <a:round/>
-            </a:ln>
-            <a:effectLst/>
-          </c:spPr>
-          <c:invertIfNegative val="0"/>
-          <c:dLbls>
-            <c:numFmt formatCode="#,##0" sourceLinked="0"/>
-            <c:txPr>
-              <a:bodyPr/>
-              <a:lstStyle/>
-              <a:p>
-                <a:pPr>
-                  <a:defRPr b="0" i="0" strike="noStrike" sz="1200" u="none">
-                    <a:solidFill>
-                      <a:srgbClr val="000000"/>
-                    </a:solidFill>
-                    <a:latin typeface="Arial"/>
-                  </a:defRPr>
-                </a:pPr>
-              </a:p>
-            </c:txPr>
-            <c:showLegendKey val="0"/>
-            <c:showVal val="0"/>
-            <c:showCatName val="0"/>
-            <c:showSerName val="0"/>
-            <c:showPercent val="0"/>
-            <c:showBubbleSize val="0"/>
-            <c:showLeaderLines val="0"/>
-          </c:dLbls>
-          <c:marker>
-            <c:symbol val="circle"/>
-            <c:size val="8"/>
-            <c:spPr>
-              <a:solidFill>
-                <a:srgbClr val="F28C28"/>
-              </a:solidFill>
-              <a:ln w="9525" cap="flat">
-                <a:solidFill>
-                  <a:srgbClr val="F28C28"/>
-                </a:solidFill>
-                <a:prstDash val="solid"/>
-                <a:round/>
-              </a:ln>
-              <a:effectLst/>
-            </c:spPr>
-          </c:marker>
-          <c:cat>
-            <c:multiLvlStrRef>
-              <c:f>Sheet1!$A$2:$A$9</c:f>
-              <c:multiLvlStrCache>
-                <c:ptCount val="8"/>
-                <c:lvl>
-                  <c:pt idx="0">
-                    <c:v>1</c:v>
-                  </c:pt>
-                  <c:pt idx="1">
-                    <c:v>2</c:v>
-                  </c:pt>
-                  <c:pt idx="2">
-                    <c:v>3</c:v>
-                  </c:pt>
-                  <c:pt idx="3">
-                    <c:v>4</c:v>
-                  </c:pt>
-                  <c:pt idx="4">
-                    <c:v>5</c:v>
-                  </c:pt>
-                  <c:pt idx="5">
-                    <c:v>6</c:v>
-                  </c:pt>
-                  <c:pt idx="6">
-                    <c:v>7</c:v>
-                  </c:pt>
-                  <c:pt idx="7">
-                    <c:v>8</c:v>
-                  </c:pt>
-                </c:lvl>
-              </c:multiLvlStrCache>
-            </c:multiLvlStrRef>
-          </c:cat>
-          <c:val>
-            <c:numRef>
-              <c:f>Sheet1!$B$2:$B$9</c:f>
-              <c:numCache>
-                <c:formatCode>General</c:formatCode>
-                <c:ptCount val="8"/>
-                <c:pt idx="0">
-                  <c:v>1532</c:v>
-                </c:pt>
-                <c:pt idx="1">
-                  <c:v>1025.2</c:v>
-                </c:pt>
-                <c:pt idx="2">
-                  <c:v>772.5</c:v>
-                </c:pt>
-                <c:pt idx="3">
-                  <c:v>600.1</c:v>
-                </c:pt>
-                <c:pt idx="4">
-                  <c:v>511</c:v>
-                </c:pt>
-                <c:pt idx="5">
-                  <c:v>453.9</c:v>
-                </c:pt>
-                <c:pt idx="6">
-                  <c:v>412.4</c:v>
-                </c:pt>
-                <c:pt idx="7">
-                  <c:v>368.2</c:v>
-                </c:pt>
-              </c:numCache>
-            </c:numRef>
-          </c:val>
-          <c:smooth val="0"/>
-        </c:ser>
-        <c:dLbls>
-          <c:numFmt formatCode="#,##0" sourceLinked="0"/>
-          <c:txPr>
-            <a:bodyPr/>
-            <a:lstStyle/>
-            <a:p>
-              <a:pPr>
-                <a:defRPr b="0" i="0" strike="noStrike" sz="1200" u="none">
-                  <a:solidFill>
-                    <a:srgbClr val="000000"/>
-                  </a:solidFill>
-                  <a:latin typeface="Arial"/>
-                </a:defRPr>
-              </a:pPr>
-            </a:p>
-          </c:txPr>
-          <c:showLegendKey val="0"/>
-          <c:showVal val="0"/>
-          <c:showCatName val="0"/>
-          <c:showSerName val="0"/>
-          <c:showPercent val="0"/>
-          <c:showBubbleSize val="0"/>
-          <c:showLeaderLines val="0"/>
-        </c:dLbls>
-        <c:marker val="1"/>
-        <c:axId val="2094734554"/>
-        <c:axId val="2094734552"/>
-        <c:axId val="2094734556"/>
-      </c:lineChart>
-      <c:catAx>
-        <c:axId val="2094734554"/>
-        <c:scaling>
-          <c:orientation val="minMax"/>
-        </c:scaling>
-        <c:delete val="0"/>
-        <c:axPos val="b"/>
-        <c:title>
-          <c:tx>
-            <c:rich>
-              <a:bodyPr/>
-              <a:lstStyle/>
-              <a:p>
-                <a:pPr>
-                  <a:defRPr sz="1100" b="0" i="0" u="none" strike="noStrike">
-                    <a:solidFill>
-                      <a:srgbClr val="5F7180"/>
-                    </a:solidFill>
-                    <a:latin typeface="+mn-lt"/>
-                  </a:defRPr>
-                </a:pPr>
-                <a:r>
-                  <a:rPr sz="1100" b="0" i="0" u="none" strike="noStrike">
-                    <a:solidFill>
-                      <a:srgbClr val="5F7180"/>
-                    </a:solidFill>
-                    <a:latin typeface="+mn-lt"/>
-                  </a:rPr>
-                  <a:t>Number of clusters (k)</a:t>
-                </a:r>
-              </a:p>
-            </c:rich>
-          </c:tx>
-          <c:layout/>
-          <c:overlay val="0"/>
-        </c:title>
-        <c:numFmt formatCode="General" sourceLinked="1"/>
-        <c:majorTickMark val="out"/>
-        <c:minorTickMark val="none"/>
-        <c:tickLblPos val="low"/>
-        <c:spPr>
-          <a:ln w="12700" cap="flat">
-            <a:solidFill>
-              <a:srgbClr val="888888"/>
-            </a:solidFill>
-            <a:prstDash val="solid"/>
-            <a:round/>
-          </a:ln>
-        </c:spPr>
-        <c:txPr>
-          <a:bodyPr/>
-          <a:lstStyle/>
-          <a:p>
-            <a:pPr>
-              <a:defRPr sz="1100" b="0" i="0" u="none" strike="noStrike">
-                <a:solidFill>
-                  <a:srgbClr val="5F7180"/>
-                </a:solidFill>
-                <a:latin typeface="+mn-lt"/>
-              </a:defRPr>
-            </a:pPr>
-            <a:endParaRPr lang="en-US"/>
-          </a:p>
-        </c:txPr>
-        <c:crossAx val="2094734552"/>
-        <c:crosses val="autoZero"/>
-        <c:auto val="1"/>
-        <c:lblAlgn val="ctr"/>
-        <c:noMultiLvlLbl val="1"/>
-      </c:catAx>
-      <c:valAx>
-        <c:axId val="2094734552"/>
-        <c:scaling>
-          <c:orientation val="minMax"/>
-          <c:min val="0"/>
-        </c:scaling>
-        <c:delete val="0"/>
-        <c:axPos val="l"/>
-        <c:majorGridlines>
-          <c:spPr>
-            <a:ln w="9525" cap="flat">
-              <a:solidFill>
-                <a:srgbClr val="EAF2F3"/>
-              </a:solidFill>
-              <a:prstDash val="solid"/>
-              <a:round/>
-            </a:ln>
-          </c:spPr>
-        </c:majorGridlines>
-        <c:title>
-          <c:tx>
-            <c:rich>
-              <a:bodyPr/>
-              <a:lstStyle/>
-              <a:p>
-                <a:pPr>
-                  <a:defRPr sz="1100" b="0" i="0" u="none" strike="noStrike">
-                    <a:solidFill>
-                      <a:srgbClr val="5F7180"/>
-                    </a:solidFill>
-                    <a:latin typeface="+mn-lt"/>
-                  </a:defRPr>
-                </a:pPr>
-                <a:r>
-                  <a:rPr sz="1100" b="0" i="0" u="none" strike="noStrike">
-                    <a:solidFill>
-                      <a:srgbClr val="5F7180"/>
-                    </a:solidFill>
-                    <a:latin typeface="+mn-lt"/>
-                  </a:rPr>
-                  <a:t>Within-cluster variance</a:t>
-                </a:r>
-              </a:p>
-            </c:rich>
-          </c:tx>
-          <c:layout/>
-          <c:overlay val="0"/>
-        </c:title>
-        <c:numFmt formatCode="General" sourceLinked="0"/>
-        <c:majorTickMark val="out"/>
-        <c:minorTickMark val="none"/>
-        <c:tickLblPos val="nextTo"/>
-        <c:spPr>
-          <a:ln w="12700" cap="flat">
-            <a:solidFill>
-              <a:srgbClr val="888888"/>
-            </a:solidFill>
-            <a:prstDash val="solid"/>
-            <a:round/>
-          </a:ln>
-        </c:spPr>
-        <c:txPr>
-          <a:bodyPr/>
-          <a:lstStyle/>
-          <a:p>
-            <a:pPr>
-              <a:defRPr sz="1100" b="0" i="0" u="none" strike="noStrike">
-                <a:solidFill>
-                  <a:srgbClr val="5F7180"/>
-                </a:solidFill>
-                <a:latin typeface="+mn-lt"/>
-              </a:defRPr>
-            </a:pPr>
-            <a:endParaRPr lang="en-US"/>
-          </a:p>
-        </c:txPr>
-        <c:crossAx val="2094734554"/>
-        <c:crosses val="autoZero"/>
-        <c:crossBetween val="between"/>
-      </c:valAx>
-      <c:spPr>
-        <a:noFill/>
-        <a:ln>
-          <a:noFill/>
-        </a:ln>
-        <a:effectLst/>
-      </c:spPr>
-    </c:plotArea>
-    <c:plotVisOnly val="1"/>
-    <c:dispBlanksAs val="span"/>
-  </c:chart>
-  <c:spPr>
-    <a:noFill/>
-    <a:ln>
-      <a:noFill/>
-    </a:ln>
-    <a:effectLst/>
-  </c:spPr>
-  <c:externalData r:id="rId1">
-    <c:autoUpdate val="0"/>
-  </c:externalData>
-</c:chartSpace>
-</file>
-
-<file path=ppt/charts/chart3.xml><?xml version="1.0" encoding="utf-8"?>
-<c:chartSpace xmlns:c="http://schemas.openxmlformats.org/drawingml/2006/chart" xmlns:a="http://schemas.openxmlformats.org/drawingml/2006/main" xmlns:r="http://schemas.openxmlformats.org/officeDocument/2006/relationships">
-  <c:date1904 val="0"/>
-  <c:roundedCorners val="1"/>
-  <c:chart>
-    <c:title>
-      <c:tx>
-        <c:rich>
-          <a:bodyPr/>
-          <a:lstStyle/>
-          <a:p>
-            <a:pPr>
-              <a:defRPr sz="1200" b="0" i="0" u="none" strike="noStrike">
-                <a:solidFill>
-                  <a:srgbClr val="0F4C5C"/>
-                </a:solidFill>
-                <a:latin typeface="+mn-lt"/>
-              </a:defRPr>
-            </a:pPr>
-            <a:r>
-              <a:rPr sz="1200" b="0" i="0" u="none" strike="noStrike">
-                <a:solidFill>
-                  <a:srgbClr val="0F4C5C"/>
-                </a:solidFill>
-                <a:latin typeface="+mn-lt"/>
-              </a:rPr>
-              <a:t>Silhouette score for each k (real data)</a:t>
-            </a:r>
-          </a:p>
-        </c:rich>
-      </c:tx>
-      <c:layout/>
-      <c:overlay val="0"/>
-    </c:title>
-    <c:autoTitleDeleted val="0"/>
-    <c:plotArea>
-      <c:layout/>
-      <c:barChart>
-        <c:barDir val="col"/>
-        <c:grouping val="clustered"/>
-        <c:varyColors val="0"/>
-        <c:ser>
-          <c:idx val="0"/>
-          <c:order val="0"/>
-          <c:tx>
-            <c:strRef>
-              <c:f>Sheet1!$B$1</c:f>
-              <c:strCache>
-                <c:ptCount val="1"/>
-                <c:pt idx="0">
-                  <c:v>Silhouette score</c:v>
-                </c:pt>
-              </c:strCache>
-            </c:strRef>
-          </c:tx>
-          <c:spPr>
-            <a:solidFill>
-              <a:srgbClr val="9BBBE4"/>
-            </a:solidFill>
-            <a:effectLst/>
-          </c:spPr>
-          <c:invertIfNegative val="0"/>
-          <c:dLbls>
-            <c:numFmt formatCode="0.00" sourceLinked="0"/>
-            <c:txPr>
-              <a:bodyPr/>
-              <a:lstStyle/>
-              <a:p>
-                <a:pPr>
-                  <a:defRPr b="0" i="0" strike="noStrike" sz="1100" u="none">
-                    <a:solidFill>
-                      <a:srgbClr val="16212B"/>
-                    </a:solidFill>
-                    <a:latin typeface="+mn-lt"/>
-                  </a:defRPr>
-                </a:pPr>
-              </a:p>
-            </c:txPr>
-            <c:showLegendKey val="0"/>
-            <c:showVal val="1"/>
-            <c:showCatName val="0"/>
-            <c:showSerName val="0"/>
-            <c:showPercent val="0"/>
-            <c:showBubbleSize val="0"/>
-            <c:showLeaderLines val="0"/>
-          </c:dLbls>
-          <c:dPt>
-            <c:idx val="0"/>
-            <c:invertIfNegative val="0"/>
-            <c:bubble3D val="0"/>
-            <c:spPr>
-              <a:solidFill>
-                <a:srgbClr val="9BBBE4"/>
-              </a:solidFill>
-              <a:effectLst/>
-            </c:spPr>
-          </c:dPt>
-          <c:dPt>
-            <c:idx val="1"/>
-            <c:invertIfNegative val="0"/>
-            <c:bubble3D val="0"/>
-            <c:spPr>
-              <a:solidFill>
-                <a:srgbClr val="9BBBE4"/>
-              </a:solidFill>
-              <a:effectLst/>
-            </c:spPr>
-          </c:dPt>
-          <c:dPt>
-            <c:idx val="2"/>
-            <c:invertIfNegative val="0"/>
-            <c:bubble3D val="0"/>
-            <c:spPr>
-              <a:solidFill>
-                <a:srgbClr val="EDA100"/>
-              </a:solidFill>
-              <a:effectLst/>
-            </c:spPr>
-          </c:dPt>
-          <c:dPt>
-            <c:idx val="3"/>
-            <c:invertIfNegative val="0"/>
-            <c:bubble3D val="0"/>
-            <c:spPr>
-              <a:solidFill>
-                <a:srgbClr val="9BBBE4"/>
-              </a:solidFill>
-              <a:effectLst/>
-            </c:spPr>
-          </c:dPt>
-          <c:dPt>
-            <c:idx val="4"/>
-            <c:invertIfNegative val="0"/>
-            <c:bubble3D val="0"/>
-            <c:spPr>
-              <a:solidFill>
-                <a:srgbClr val="9BBBE4"/>
-              </a:solidFill>
-              <a:effectLst/>
-            </c:spPr>
-          </c:dPt>
-          <c:dPt>
-            <c:idx val="5"/>
-            <c:invertIfNegative val="0"/>
-            <c:bubble3D val="0"/>
-            <c:spPr>
-              <a:solidFill>
-                <a:srgbClr val="9BBBE4"/>
-              </a:solidFill>
-              <a:effectLst/>
-            </c:spPr>
-          </c:dPt>
-          <c:dPt>
-            <c:idx val="6"/>
-            <c:invertIfNegative val="0"/>
-            <c:bubble3D val="0"/>
-            <c:spPr>
-              <a:solidFill>
-                <a:srgbClr val="9BBBE4"/>
-              </a:solidFill>
-              <a:effectLst/>
-            </c:spPr>
-          </c:dPt>
-          <c:cat>
-            <c:multiLvlStrRef>
-              <c:f>Sheet1!$A$2:$A$8</c:f>
-              <c:multiLvlStrCache>
-                <c:ptCount val="7"/>
-                <c:lvl>
-                  <c:pt idx="0">
-                    <c:v>2</c:v>
-                  </c:pt>
-                  <c:pt idx="1">
-                    <c:v>3</c:v>
-                  </c:pt>
-                  <c:pt idx="2">
-                    <c:v>4</c:v>
-                  </c:pt>
-                  <c:pt idx="3">
-                    <c:v>5</c:v>
-                  </c:pt>
-                  <c:pt idx="4">
-                    <c:v>6</c:v>
-                  </c:pt>
-                  <c:pt idx="5">
-                    <c:v>7</c:v>
-                  </c:pt>
-                  <c:pt idx="6">
-                    <c:v>8</c:v>
-                  </c:pt>
-                </c:lvl>
-              </c:multiLvlStrCache>
-            </c:multiLvlStrRef>
-          </c:cat>
-          <c:val>
-            <c:numRef>
-              <c:f>Sheet1!$B$2:$B$8</c:f>
-              <c:numCache>
-                <c:formatCode>General</c:formatCode>
-                <c:ptCount val="7"/>
-                <c:pt idx="0">
-                  <c:v>0.359</c:v>
-                </c:pt>
-                <c:pt idx="1">
-                  <c:v>0.342</c:v>
-                </c:pt>
-                <c:pt idx="2">
-                  <c:v>0.367</c:v>
-                </c:pt>
-                <c:pt idx="3">
-                  <c:v>0.312</c:v>
-                </c:pt>
-                <c:pt idx="4">
-                  <c:v>0.309</c:v>
-                </c:pt>
-                <c:pt idx="5">
-                  <c:v>0.273</c:v>
-                </c:pt>
-                <c:pt idx="6">
-                  <c:v>0.289</c:v>
-                </c:pt>
-              </c:numCache>
-            </c:numRef>
-          </c:val>
-        </c:ser>
-        <c:dLbls>
-          <c:numFmt formatCode="0.00" sourceLinked="0"/>
-          <c:txPr>
-            <a:bodyPr/>
-            <a:lstStyle/>
-            <a:p>
-              <a:pPr>
-                <a:defRPr b="0" i="0" strike="noStrike" sz="1100" u="none">
-                  <a:solidFill>
-                    <a:srgbClr val="16212B"/>
-                  </a:solidFill>
-                  <a:latin typeface="+mn-lt"/>
-                </a:defRPr>
-              </a:pPr>
-            </a:p>
-          </c:txPr>
-          <c:showLegendKey val="0"/>
-          <c:showVal val="1"/>
-          <c:showCatName val="0"/>
-          <c:showSerName val="0"/>
-          <c:showPercent val="0"/>
-          <c:showBubbleSize val="0"/>
-          <c:showLeaderLines val="0"/>
-        </c:dLbls>
-        <c:gapWidth val="45"/>
-        <c:overlap val="0"/>
-        <c:axId val="2094734554"/>
-        <c:axId val="2094734552"/>
-        <c:axId val="2094734556"/>
-      </c:barChart>
-      <c:catAx>
-        <c:axId val="2094734554"/>
-        <c:scaling>
-          <c:orientation val="minMax"/>
-        </c:scaling>
-        <c:delete val="0"/>
-        <c:axPos val="b"/>
-        <c:title>
-          <c:tx>
-            <c:rich>
-              <a:bodyPr/>
-              <a:lstStyle/>
-              <a:p>
-                <a:pPr>
-                  <a:defRPr sz="1100" b="0" i="0" u="none" strike="noStrike">
-                    <a:solidFill>
-                      <a:srgbClr val="5F7180"/>
-                    </a:solidFill>
-                    <a:latin typeface="+mn-lt"/>
-                  </a:defRPr>
-                </a:pPr>
-                <a:r>
-                  <a:rPr sz="1100" b="0" i="0" u="none" strike="noStrike">
-                    <a:solidFill>
-                      <a:srgbClr val="5F7180"/>
-                    </a:solidFill>
-                    <a:latin typeface="+mn-lt"/>
-                  </a:rPr>
-                  <a:t>Number of clusters (k)</a:t>
-                </a:r>
-              </a:p>
-            </c:rich>
-          </c:tx>
-          <c:layout/>
-          <c:overlay val="0"/>
-        </c:title>
-        <c:numFmt formatCode="General" sourceLinked="1"/>
-        <c:majorTickMark val="out"/>
-        <c:minorTickMark val="none"/>
-        <c:tickLblPos val="low"/>
-        <c:spPr>
-          <a:ln w="12700" cap="flat">
-            <a:solidFill>
-              <a:srgbClr val="888888"/>
-            </a:solidFill>
-            <a:prstDash val="solid"/>
-            <a:round/>
-          </a:ln>
-        </c:spPr>
-        <c:txPr>
-          <a:bodyPr/>
-          <a:lstStyle/>
-          <a:p>
-            <a:pPr>
-              <a:defRPr sz="1100" b="0" i="0" u="none" strike="noStrike">
-                <a:solidFill>
-                  <a:srgbClr val="5F7180"/>
-                </a:solidFill>
-                <a:latin typeface="+mn-lt"/>
-              </a:defRPr>
-            </a:pPr>
-            <a:endParaRPr lang="en-US"/>
-          </a:p>
-        </c:txPr>
-        <c:crossAx val="2094734552"/>
-        <c:crosses val="autoZero"/>
-        <c:auto val="1"/>
-        <c:lblAlgn val="ctr"/>
-        <c:noMultiLvlLbl val="1"/>
-      </c:catAx>
-      <c:valAx>
-        <c:axId val="2094734552"/>
-        <c:scaling>
-          <c:orientation val="minMax"/>
-          <c:max val="0.45"/>
-          <c:min val="0"/>
-        </c:scaling>
-        <c:delete val="0"/>
-        <c:axPos val="l"/>
-        <c:majorGridlines>
-          <c:spPr>
-            <a:ln w="9525" cap="flat">
-              <a:solidFill>
-                <a:srgbClr val="EAF2F3"/>
-              </a:solidFill>
-              <a:prstDash val="solid"/>
-              <a:round/>
-            </a:ln>
-          </c:spPr>
-        </c:majorGridlines>
-        <c:numFmt formatCode="0.00" sourceLinked="0"/>
-        <c:majorTickMark val="out"/>
-        <c:minorTickMark val="none"/>
-        <c:tickLblPos val="nextTo"/>
-        <c:spPr>
-          <a:ln w="12700" cap="flat">
-            <a:solidFill>
-              <a:srgbClr val="888888"/>
-            </a:solidFill>
-            <a:prstDash val="solid"/>
-            <a:round/>
-          </a:ln>
-        </c:spPr>
-        <c:txPr>
-          <a:bodyPr/>
-          <a:lstStyle/>
-          <a:p>
-            <a:pPr>
-              <a:defRPr sz="1100" b="0" i="0" u="none" strike="noStrike">
-                <a:solidFill>
-                  <a:srgbClr val="5F7180"/>
-                </a:solidFill>
-                <a:latin typeface="+mn-lt"/>
-              </a:defRPr>
-            </a:pPr>
-            <a:endParaRPr lang="en-US"/>
-          </a:p>
-        </c:txPr>
-        <c:crossAx val="2094734554"/>
-        <c:crosses val="autoZero"/>
-        <c:crossBetween val="between"/>
-      </c:valAx>
-      <c:spPr>
-        <a:noFill/>
-        <a:ln>
-          <a:noFill/>
-        </a:ln>
-        <a:effectLst/>
-      </c:spPr>
-    </c:plotArea>
-    <c:plotVisOnly val="1"/>
-    <c:dispBlanksAs val="span"/>
-  </c:chart>
-  <c:spPr>
-    <a:noFill/>
-    <a:ln>
-      <a:noFill/>
-    </a:ln>
-    <a:effectLst/>
-  </c:spPr>
-  <c:externalData r:id="rId1">
-    <c:autoUpdate val="0"/>
-  </c:externalData>
-</c:chartSpace>
-</file>
-
-<file path=ppt/charts/chart4.xml><?xml version="1.0" encoding="utf-8"?>
-<c:chartSpace xmlns:c="http://schemas.openxmlformats.org/drawingml/2006/chart" xmlns:a="http://schemas.openxmlformats.org/drawingml/2006/main" xmlns:r="http://schemas.openxmlformats.org/officeDocument/2006/relationships">
-  <c:date1904 val="0"/>
-  <c:roundedCorners val="1"/>
-  <c:chart>
-    <c:title>
-      <c:tx>
-        <c:rich>
-          <a:bodyPr/>
-          <a:lstStyle/>
-          <a:p>
-            <a:pPr>
-              <a:defRPr sz="1200" b="0" i="0" u="none" strike="noStrike">
-                <a:solidFill>
-                  <a:srgbClr val="0F4C5C"/>
-                </a:solidFill>
-                <a:latin typeface="+mn-lt"/>
-              </a:defRPr>
-            </a:pPr>
-            <a:r>
-              <a:rPr sz="1200" b="0" i="0" u="none" strike="noStrike">
-                <a:solidFill>
-                  <a:srgbClr val="0F4C5C"/>
-                </a:solidFill>
-                <a:latin typeface="+mn-lt"/>
-              </a:rPr>
-              <a:t>Average orders</a:t>
-            </a:r>
-          </a:p>
-        </c:rich>
-      </c:tx>
-      <c:layout/>
-      <c:overlay val="0"/>
-    </c:title>
-    <c:autoTitleDeleted val="0"/>
-    <c:plotArea>
-      <c:layout/>
-      <c:barChart>
-        <c:barDir val="col"/>
-        <c:grouping val="clustered"/>
-        <c:varyColors val="0"/>
-        <c:ser>
-          <c:idx val="0"/>
-          <c:order val="0"/>
-          <c:tx>
-            <c:strRef>
-              <c:f>Sheet1!$B$1</c:f>
-              <c:strCache>
-                <c:ptCount val="1"/>
-                <c:pt idx="0">
-                  <c:v>Average orders</c:v>
-                </c:pt>
-              </c:strCache>
-            </c:strRef>
-          </c:tx>
-          <c:spPr>
-            <a:solidFill>
-              <a:srgbClr val="2A78D6"/>
-            </a:solidFill>
-            <a:effectLst/>
-          </c:spPr>
-          <c:invertIfNegative val="0"/>
-          <c:dLbls>
-            <c:numFmt formatCode="0" sourceLinked="0"/>
-            <c:txPr>
-              <a:bodyPr/>
-              <a:lstStyle/>
-              <a:p>
-                <a:pPr>
-                  <a:defRPr b="0" i="0" strike="noStrike" sz="1100" u="none">
-                    <a:solidFill>
-                      <a:srgbClr val="16212B"/>
-                    </a:solidFill>
-                    <a:latin typeface="+mn-lt"/>
-                  </a:defRPr>
-                </a:pPr>
-              </a:p>
-            </c:txPr>
-            <c:showLegendKey val="0"/>
-            <c:showVal val="1"/>
-            <c:showCatName val="0"/>
-            <c:showSerName val="0"/>
-            <c:showPercent val="0"/>
-            <c:showBubbleSize val="0"/>
-            <c:showLeaderLines val="0"/>
-          </c:dLbls>
-          <c:dPt>
-            <c:idx val="0"/>
-            <c:invertIfNegative val="0"/>
-            <c:bubble3D val="0"/>
-            <c:spPr>
-              <a:solidFill>
-                <a:srgbClr val="2A78D6"/>
-              </a:solidFill>
-              <a:effectLst/>
-            </c:spPr>
-          </c:dPt>
-          <c:dPt>
-            <c:idx val="1"/>
-            <c:invertIfNegative val="0"/>
-            <c:bubble3D val="0"/>
-            <c:spPr>
-              <a:solidFill>
-                <a:srgbClr val="EDA100"/>
-              </a:solidFill>
-              <a:effectLst/>
-            </c:spPr>
-          </c:dPt>
-          <c:dPt>
-            <c:idx val="2"/>
-            <c:invertIfNegative val="0"/>
-            <c:bubble3D val="0"/>
-            <c:spPr>
-              <a:solidFill>
-                <a:srgbClr val="E87BA4"/>
-              </a:solidFill>
-              <a:effectLst/>
-            </c:spPr>
-          </c:dPt>
-          <c:dPt>
-            <c:idx val="3"/>
-            <c:invertIfNegative val="0"/>
-            <c:bubble3D val="0"/>
-            <c:spPr>
-              <a:solidFill>
-                <a:srgbClr val="008300"/>
-              </a:solidFill>
-              <a:effectLst/>
-            </c:spPr>
-          </c:dPt>
-          <c:cat>
-            <c:multiLvlStrRef>
-              <c:f>Sheet1!$A$2:$A$5</c:f>
-              <c:multiLvlStrCache>
-                <c:ptCount val="4"/>
-                <c:lvl>
-                  <c:pt idx="0">
-                    <c:v>A</c:v>
-                  </c:pt>
-                  <c:pt idx="1">
-                    <c:v>B</c:v>
-                  </c:pt>
-                  <c:pt idx="2">
-                    <c:v>C</c:v>
-                  </c:pt>
-                  <c:pt idx="3">
-                    <c:v>D</c:v>
-                  </c:pt>
-                </c:lvl>
-              </c:multiLvlStrCache>
-            </c:multiLvlStrRef>
-          </c:cat>
-          <c:val>
-            <c:numRef>
-              <c:f>Sheet1!$B$2:$B$5</c:f>
-              <c:numCache>
-                <c:formatCode>General</c:formatCode>
-                <c:ptCount val="4"/>
-                <c:pt idx="0">
-                  <c:v>160</c:v>
-                </c:pt>
-                <c:pt idx="1">
-                  <c:v>52</c:v>
-                </c:pt>
-                <c:pt idx="2">
-                  <c:v>48</c:v>
-                </c:pt>
-                <c:pt idx="3">
-                  <c:v>45</c:v>
-                </c:pt>
-              </c:numCache>
-            </c:numRef>
-          </c:val>
-        </c:ser>
-        <c:dLbls>
-          <c:numFmt formatCode="0" sourceLinked="0"/>
-          <c:txPr>
-            <a:bodyPr/>
-            <a:lstStyle/>
-            <a:p>
-              <a:pPr>
-                <a:defRPr b="0" i="0" strike="noStrike" sz="1100" u="none">
-                  <a:solidFill>
-                    <a:srgbClr val="16212B"/>
-                  </a:solidFill>
-                  <a:latin typeface="+mn-lt"/>
-                </a:defRPr>
-              </a:pPr>
-            </a:p>
-          </c:txPr>
-          <c:showLegendKey val="0"/>
-          <c:showVal val="1"/>
-          <c:showCatName val="0"/>
-          <c:showSerName val="0"/>
-          <c:showPercent val="0"/>
-          <c:showBubbleSize val="0"/>
-          <c:showLeaderLines val="0"/>
-        </c:dLbls>
-        <c:gapWidth val="45"/>
-        <c:overlap val="0"/>
-        <c:axId val="2094734554"/>
-        <c:axId val="2094734552"/>
-        <c:axId val="2094734556"/>
-      </c:barChart>
-      <c:catAx>
-        <c:axId val="2094734554"/>
-        <c:scaling>
-          <c:orientation val="minMax"/>
-        </c:scaling>
-        <c:delete val="0"/>
-        <c:axPos val="b"/>
-        <c:numFmt formatCode="General" sourceLinked="1"/>
-        <c:majorTickMark val="out"/>
-        <c:minorTickMark val="none"/>
-        <c:tickLblPos val="low"/>
-        <c:spPr>
-          <a:ln w="12700" cap="flat">
-            <a:solidFill>
-              <a:srgbClr val="888888"/>
-            </a:solidFill>
-            <a:prstDash val="solid"/>
-            <a:round/>
-          </a:ln>
-        </c:spPr>
-        <c:txPr>
-          <a:bodyPr/>
-          <a:lstStyle/>
-          <a:p>
-            <a:pPr>
-              <a:defRPr sz="1100" b="0" i="0" u="none" strike="noStrike">
-                <a:solidFill>
-                  <a:srgbClr val="5F7180"/>
-                </a:solidFill>
-                <a:latin typeface="+mn-lt"/>
-              </a:defRPr>
-            </a:pPr>
-            <a:endParaRPr lang="en-US"/>
-          </a:p>
-        </c:txPr>
-        <c:crossAx val="2094734552"/>
-        <c:crosses val="autoZero"/>
-        <c:auto val="1"/>
-        <c:lblAlgn val="ctr"/>
-        <c:noMultiLvlLbl val="1"/>
-      </c:catAx>
-      <c:valAx>
-        <c:axId val="2094734552"/>
-        <c:scaling>
-          <c:orientation val="minMax"/>
-          <c:min val="0"/>
-        </c:scaling>
-        <c:delete val="1"/>
-        <c:axPos val="l"/>
-        <c:numFmt formatCode="General" sourceLinked="0"/>
-        <c:majorTickMark val="out"/>
-        <c:minorTickMark val="none"/>
-        <c:tickLblPos val="nextTo"/>
-        <c:spPr>
-          <a:ln w="12700" cap="flat">
-            <a:solidFill>
-              <a:srgbClr val="888888"/>
-            </a:solidFill>
-            <a:prstDash val="solid"/>
-            <a:round/>
-          </a:ln>
-        </c:spPr>
-        <c:txPr>
-          <a:bodyPr/>
-          <a:lstStyle/>
-          <a:p>
-            <a:pPr>
-              <a:defRPr sz="1100" b="0" i="0" u="none" strike="noStrike">
-                <a:solidFill>
-                  <a:srgbClr val="5F7180"/>
-                </a:solidFill>
-                <a:latin typeface="+mn-lt"/>
-              </a:defRPr>
-            </a:pPr>
-            <a:endParaRPr lang="en-US"/>
-          </a:p>
-        </c:txPr>
-        <c:crossAx val="2094734554"/>
-        <c:crosses val="autoZero"/>
-        <c:crossBetween val="between"/>
-      </c:valAx>
-      <c:spPr>
-        <a:noFill/>
-        <a:ln>
-          <a:noFill/>
-        </a:ln>
-        <a:effectLst/>
-      </c:spPr>
-    </c:plotArea>
-    <c:plotVisOnly val="1"/>
-    <c:dispBlanksAs val="span"/>
-  </c:chart>
-  <c:spPr>
-    <a:noFill/>
-    <a:ln>
-      <a:noFill/>
-    </a:ln>
-    <a:effectLst/>
-  </c:spPr>
-  <c:externalData r:id="rId1">
-    <c:autoUpdate val="0"/>
-  </c:externalData>
-</c:chartSpace>
-</file>
-
-<file path=ppt/charts/chart5.xml><?xml version="1.0" encoding="utf-8"?>
-<c:chartSpace xmlns:c="http://schemas.openxmlformats.org/drawingml/2006/chart" xmlns:a="http://schemas.openxmlformats.org/drawingml/2006/main" xmlns:r="http://schemas.openxmlformats.org/officeDocument/2006/relationships">
-  <c:date1904 val="0"/>
-  <c:roundedCorners val="1"/>
-  <c:chart>
-    <c:title>
-      <c:tx>
-        <c:rich>
-          <a:bodyPr/>
-          <a:lstStyle/>
-          <a:p>
-            <a:pPr>
-              <a:defRPr sz="1200" b="0" i="0" u="none" strike="noStrike">
-                <a:solidFill>
-                  <a:srgbClr val="0F4C5C"/>
-                </a:solidFill>
-                <a:latin typeface="+mn-lt"/>
-              </a:defRPr>
-            </a:pPr>
-            <a:r>
-              <a:rPr sz="1200" b="0" i="0" u="none" strike="noStrike">
-                <a:solidFill>
-                  <a:srgbClr val="0F4C5C"/>
-                </a:solidFill>
-                <a:latin typeface="+mn-lt"/>
-              </a:rPr>
-              <a:t>Season index</a:t>
-            </a:r>
-          </a:p>
-        </c:rich>
-      </c:tx>
-      <c:layout/>
-      <c:overlay val="0"/>
-    </c:title>
-    <c:autoTitleDeleted val="0"/>
-    <c:plotArea>
-      <c:layout/>
-      <c:barChart>
-        <c:barDir val="col"/>
-        <c:grouping val="clustered"/>
-        <c:varyColors val="0"/>
-        <c:ser>
-          <c:idx val="0"/>
-          <c:order val="0"/>
-          <c:tx>
-            <c:strRef>
-              <c:f>Sheet1!$B$1</c:f>
-              <c:strCache>
-                <c:ptCount val="1"/>
-                <c:pt idx="0">
-                  <c:v>Season index</c:v>
-                </c:pt>
-              </c:strCache>
-            </c:strRef>
-          </c:tx>
-          <c:spPr>
-            <a:solidFill>
-              <a:srgbClr val="2A78D6"/>
-            </a:solidFill>
-            <a:effectLst/>
-          </c:spPr>
-          <c:invertIfNegative val="0"/>
-          <c:dLbls>
-            <c:numFmt formatCode="0.0" sourceLinked="0"/>
-            <c:txPr>
-              <a:bodyPr/>
-              <a:lstStyle/>
-              <a:p>
-                <a:pPr>
-                  <a:defRPr b="0" i="0" strike="noStrike" sz="1100" u="none">
-                    <a:solidFill>
-                      <a:srgbClr val="16212B"/>
-                    </a:solidFill>
-                    <a:latin typeface="+mn-lt"/>
-                  </a:defRPr>
-                </a:pPr>
-              </a:p>
-            </c:txPr>
-            <c:showLegendKey val="0"/>
-            <c:showVal val="1"/>
-            <c:showCatName val="0"/>
-            <c:showSerName val="0"/>
-            <c:showPercent val="0"/>
-            <c:showBubbleSize val="0"/>
-            <c:showLeaderLines val="0"/>
-          </c:dLbls>
-          <c:dPt>
-            <c:idx val="0"/>
-            <c:invertIfNegative val="0"/>
-            <c:bubble3D val="0"/>
-            <c:spPr>
-              <a:solidFill>
-                <a:srgbClr val="2A78D6"/>
-              </a:solidFill>
-              <a:effectLst/>
-            </c:spPr>
-          </c:dPt>
-          <c:dPt>
-            <c:idx val="1"/>
-            <c:invertIfNegative val="0"/>
-            <c:bubble3D val="0"/>
-            <c:spPr>
-              <a:solidFill>
-                <a:srgbClr val="EDA100"/>
-              </a:solidFill>
-              <a:effectLst/>
-            </c:spPr>
-          </c:dPt>
-          <c:dPt>
-            <c:idx val="2"/>
-            <c:invertIfNegative val="0"/>
-            <c:bubble3D val="0"/>
-            <c:spPr>
-              <a:solidFill>
-                <a:srgbClr val="E87BA4"/>
-              </a:solidFill>
-              <a:effectLst/>
-            </c:spPr>
-          </c:dPt>
-          <c:dPt>
-            <c:idx val="3"/>
-            <c:invertIfNegative val="0"/>
-            <c:bubble3D val="0"/>
-            <c:spPr>
-              <a:solidFill>
-                <a:srgbClr val="008300"/>
-              </a:solidFill>
-              <a:effectLst/>
-            </c:spPr>
-          </c:dPt>
-          <c:cat>
-            <c:multiLvlStrRef>
-              <c:f>Sheet1!$A$2:$A$5</c:f>
-              <c:multiLvlStrCache>
-                <c:ptCount val="4"/>
-                <c:lvl>
-                  <c:pt idx="0">
-                    <c:v>A</c:v>
-                  </c:pt>
-                  <c:pt idx="1">
-                    <c:v>B</c:v>
-                  </c:pt>
-                  <c:pt idx="2">
-                    <c:v>C</c:v>
-                  </c:pt>
-                  <c:pt idx="3">
-                    <c:v>D</c:v>
-                  </c:pt>
-                </c:lvl>
-              </c:multiLvlStrCache>
-            </c:multiLvlStrRef>
-          </c:cat>
-          <c:val>
-            <c:numRef>
-              <c:f>Sheet1!$B$2:$B$5</c:f>
-              <c:numCache>
-                <c:formatCode>General</c:formatCode>
-                <c:ptCount val="4"/>
-                <c:pt idx="0">
-                  <c:v>2.6</c:v>
-                </c:pt>
-                <c:pt idx="1">
-                  <c:v>3.5</c:v>
-                </c:pt>
-                <c:pt idx="2">
-                  <c:v>7.4</c:v>
-                </c:pt>
-                <c:pt idx="3">
-                  <c:v>3.2</c:v>
-                </c:pt>
-              </c:numCache>
-            </c:numRef>
-          </c:val>
-        </c:ser>
-        <c:dLbls>
-          <c:numFmt formatCode="0.0" sourceLinked="0"/>
-          <c:txPr>
-            <a:bodyPr/>
-            <a:lstStyle/>
-            <a:p>
-              <a:pPr>
-                <a:defRPr b="0" i="0" strike="noStrike" sz="1100" u="none">
-                  <a:solidFill>
-                    <a:srgbClr val="16212B"/>
-                  </a:solidFill>
-                  <a:latin typeface="+mn-lt"/>
-                </a:defRPr>
-              </a:pPr>
-            </a:p>
-          </c:txPr>
-          <c:showLegendKey val="0"/>
-          <c:showVal val="1"/>
-          <c:showCatName val="0"/>
-          <c:showSerName val="0"/>
-          <c:showPercent val="0"/>
-          <c:showBubbleSize val="0"/>
-          <c:showLeaderLines val="0"/>
-        </c:dLbls>
-        <c:gapWidth val="45"/>
-        <c:overlap val="0"/>
-        <c:axId val="2094734554"/>
-        <c:axId val="2094734552"/>
-        <c:axId val="2094734556"/>
-      </c:barChart>
-      <c:catAx>
-        <c:axId val="2094734554"/>
-        <c:scaling>
-          <c:orientation val="minMax"/>
-        </c:scaling>
-        <c:delete val="0"/>
-        <c:axPos val="b"/>
-        <c:numFmt formatCode="General" sourceLinked="1"/>
-        <c:majorTickMark val="out"/>
-        <c:minorTickMark val="none"/>
-        <c:tickLblPos val="low"/>
-        <c:spPr>
-          <a:ln w="12700" cap="flat">
-            <a:solidFill>
-              <a:srgbClr val="888888"/>
-            </a:solidFill>
-            <a:prstDash val="solid"/>
-            <a:round/>
-          </a:ln>
-        </c:spPr>
-        <c:txPr>
-          <a:bodyPr/>
-          <a:lstStyle/>
-          <a:p>
-            <a:pPr>
-              <a:defRPr sz="1100" b="0" i="0" u="none" strike="noStrike">
-                <a:solidFill>
-                  <a:srgbClr val="5F7180"/>
-                </a:solidFill>
-                <a:latin typeface="+mn-lt"/>
-              </a:defRPr>
-            </a:pPr>
-            <a:endParaRPr lang="en-US"/>
-          </a:p>
-        </c:txPr>
-        <c:crossAx val="2094734552"/>
-        <c:crosses val="autoZero"/>
-        <c:auto val="1"/>
-        <c:lblAlgn val="ctr"/>
-        <c:noMultiLvlLbl val="1"/>
-      </c:catAx>
-      <c:valAx>
-        <c:axId val="2094734552"/>
-        <c:scaling>
-          <c:orientation val="minMax"/>
-          <c:min val="0"/>
-        </c:scaling>
-        <c:delete val="1"/>
-        <c:axPos val="l"/>
-        <c:numFmt formatCode="General" sourceLinked="0"/>
-        <c:majorTickMark val="out"/>
-        <c:minorTickMark val="none"/>
-        <c:tickLblPos val="nextTo"/>
-        <c:spPr>
-          <a:ln w="12700" cap="flat">
-            <a:solidFill>
-              <a:srgbClr val="888888"/>
-            </a:solidFill>
-            <a:prstDash val="solid"/>
-            <a:round/>
-          </a:ln>
-        </c:spPr>
-        <c:txPr>
-          <a:bodyPr/>
-          <a:lstStyle/>
-          <a:p>
-            <a:pPr>
-              <a:defRPr sz="1100" b="0" i="0" u="none" strike="noStrike">
-                <a:solidFill>
-                  <a:srgbClr val="5F7180"/>
-                </a:solidFill>
-                <a:latin typeface="+mn-lt"/>
-              </a:defRPr>
-            </a:pPr>
-            <a:endParaRPr lang="en-US"/>
-          </a:p>
-        </c:txPr>
-        <c:crossAx val="2094734554"/>
-        <c:crosses val="autoZero"/>
-        <c:crossBetween val="between"/>
-      </c:valAx>
-      <c:spPr>
-        <a:noFill/>
-        <a:ln>
-          <a:noFill/>
-        </a:ln>
-        <a:effectLst/>
-      </c:spPr>
-    </c:plotArea>
-    <c:plotVisOnly val="1"/>
-    <c:dispBlanksAs val="span"/>
-  </c:chart>
-  <c:spPr>
-    <a:noFill/>
-    <a:ln>
-      <a:noFill/>
-    </a:ln>
-    <a:effectLst/>
-  </c:spPr>
-  <c:externalData r:id="rId1">
-    <c:autoUpdate val="0"/>
-  </c:externalData>
-</c:chartSpace>
-</file>
-
-<file path=ppt/charts/chart6.xml><?xml version="1.0" encoding="utf-8"?>
-<c:chartSpace xmlns:c="http://schemas.openxmlformats.org/drawingml/2006/chart" xmlns:a="http://schemas.openxmlformats.org/drawingml/2006/main" xmlns:r="http://schemas.openxmlformats.org/officeDocument/2006/relationships">
-  <c:date1904 val="0"/>
-  <c:roundedCorners val="1"/>
-  <c:chart>
-    <c:title>
-      <c:tx>
-        <c:rich>
-          <a:bodyPr/>
-          <a:lstStyle/>
-          <a:p>
-            <a:pPr>
-              <a:defRPr sz="1200" b="0" i="0" u="none" strike="noStrike">
-                <a:solidFill>
-                  <a:srgbClr val="0F4C5C"/>
-                </a:solidFill>
-                <a:latin typeface="+mn-lt"/>
-              </a:defRPr>
-            </a:pPr>
-            <a:r>
-              <a:rPr sz="1200" b="0" i="0" u="none" strike="noStrike">
-                <a:solidFill>
-                  <a:srgbClr val="0F4C5C"/>
-                </a:solidFill>
-                <a:latin typeface="+mn-lt"/>
-              </a:rPr>
-              <a:t>Average volume (L)</a:t>
-            </a:r>
-          </a:p>
-        </c:rich>
-      </c:tx>
-      <c:layout/>
-      <c:overlay val="0"/>
-    </c:title>
-    <c:autoTitleDeleted val="0"/>
-    <c:plotArea>
-      <c:layout/>
-      <c:barChart>
-        <c:barDir val="col"/>
-        <c:grouping val="clustered"/>
-        <c:varyColors val="0"/>
-        <c:ser>
-          <c:idx val="0"/>
-          <c:order val="0"/>
-          <c:tx>
-            <c:strRef>
-              <c:f>Sheet1!$B$1</c:f>
-              <c:strCache>
-                <c:ptCount val="1"/>
-                <c:pt idx="0">
-                  <c:v>Average volume (L)</c:v>
-                </c:pt>
-              </c:strCache>
-            </c:strRef>
-          </c:tx>
-          <c:spPr>
-            <a:solidFill>
-              <a:srgbClr val="2A78D6"/>
-            </a:solidFill>
-            <a:effectLst/>
-          </c:spPr>
-          <c:invertIfNegative val="0"/>
-          <c:dLbls>
-            <c:numFmt formatCode="0.0" sourceLinked="0"/>
-            <c:txPr>
-              <a:bodyPr/>
-              <a:lstStyle/>
-              <a:p>
-                <a:pPr>
-                  <a:defRPr b="0" i="0" strike="noStrike" sz="1100" u="none">
-                    <a:solidFill>
-                      <a:srgbClr val="16212B"/>
-                    </a:solidFill>
-                    <a:latin typeface="+mn-lt"/>
-                  </a:defRPr>
-                </a:pPr>
-              </a:p>
-            </c:txPr>
-            <c:showLegendKey val="0"/>
-            <c:showVal val="1"/>
-            <c:showCatName val="0"/>
-            <c:showSerName val="0"/>
-            <c:showPercent val="0"/>
-            <c:showBubbleSize val="0"/>
-            <c:showLeaderLines val="0"/>
-          </c:dLbls>
-          <c:dPt>
-            <c:idx val="0"/>
-            <c:invertIfNegative val="0"/>
-            <c:bubble3D val="0"/>
-            <c:spPr>
-              <a:solidFill>
-                <a:srgbClr val="2A78D6"/>
-              </a:solidFill>
-              <a:effectLst/>
-            </c:spPr>
-          </c:dPt>
-          <c:dPt>
-            <c:idx val="1"/>
-            <c:invertIfNegative val="0"/>
-            <c:bubble3D val="0"/>
-            <c:spPr>
-              <a:solidFill>
-                <a:srgbClr val="EDA100"/>
-              </a:solidFill>
-              <a:effectLst/>
-            </c:spPr>
-          </c:dPt>
-          <c:dPt>
-            <c:idx val="2"/>
-            <c:invertIfNegative val="0"/>
-            <c:bubble3D val="0"/>
-            <c:spPr>
-              <a:solidFill>
-                <a:srgbClr val="E87BA4"/>
-              </a:solidFill>
-              <a:effectLst/>
-            </c:spPr>
-          </c:dPt>
-          <c:dPt>
-            <c:idx val="3"/>
-            <c:invertIfNegative val="0"/>
-            <c:bubble3D val="0"/>
-            <c:spPr>
-              <a:solidFill>
-                <a:srgbClr val="008300"/>
-              </a:solidFill>
-              <a:effectLst/>
-            </c:spPr>
-          </c:dPt>
-          <c:cat>
-            <c:multiLvlStrRef>
-              <c:f>Sheet1!$A$2:$A$5</c:f>
-              <c:multiLvlStrCache>
-                <c:ptCount val="4"/>
-                <c:lvl>
-                  <c:pt idx="0">
-                    <c:v>A</c:v>
-                  </c:pt>
-                  <c:pt idx="1">
-                    <c:v>B</c:v>
-                  </c:pt>
-                  <c:pt idx="2">
-                    <c:v>C</c:v>
-                  </c:pt>
-                  <c:pt idx="3">
-                    <c:v>D</c:v>
-                  </c:pt>
-                </c:lvl>
-              </c:multiLvlStrCache>
-            </c:multiLvlStrRef>
-          </c:cat>
-          <c:val>
-            <c:numRef>
-              <c:f>Sheet1!$B$2:$B$5</c:f>
-              <c:numCache>
-                <c:formatCode>General</c:formatCode>
-                <c:ptCount val="4"/>
-                <c:pt idx="0">
-                  <c:v>9.2</c:v>
-                </c:pt>
-                <c:pt idx="1">
-                  <c:v>47.1</c:v>
-                </c:pt>
-                <c:pt idx="2">
-                  <c:v>12.9</c:v>
-                </c:pt>
-                <c:pt idx="3">
-                  <c:v>5.1</c:v>
-                </c:pt>
-              </c:numCache>
-            </c:numRef>
-          </c:val>
-        </c:ser>
-        <c:dLbls>
-          <c:numFmt formatCode="0.0" sourceLinked="0"/>
-          <c:txPr>
-            <a:bodyPr/>
-            <a:lstStyle/>
-            <a:p>
-              <a:pPr>
-                <a:defRPr b="0" i="0" strike="noStrike" sz="1100" u="none">
-                  <a:solidFill>
-                    <a:srgbClr val="16212B"/>
-                  </a:solidFill>
-                  <a:latin typeface="+mn-lt"/>
-                </a:defRPr>
-              </a:pPr>
-            </a:p>
-          </c:txPr>
-          <c:showLegendKey val="0"/>
-          <c:showVal val="1"/>
-          <c:showCatName val="0"/>
-          <c:showSerName val="0"/>
-          <c:showPercent val="0"/>
-          <c:showBubbleSize val="0"/>
-          <c:showLeaderLines val="0"/>
-        </c:dLbls>
-        <c:gapWidth val="45"/>
-        <c:overlap val="0"/>
-        <c:axId val="2094734554"/>
-        <c:axId val="2094734552"/>
-        <c:axId val="2094734556"/>
-      </c:barChart>
-      <c:catAx>
-        <c:axId val="2094734554"/>
-        <c:scaling>
-          <c:orientation val="minMax"/>
-        </c:scaling>
-        <c:delete val="0"/>
-        <c:axPos val="b"/>
-        <c:numFmt formatCode="General" sourceLinked="1"/>
-        <c:majorTickMark val="out"/>
-        <c:minorTickMark val="none"/>
-        <c:tickLblPos val="low"/>
-        <c:spPr>
-          <a:ln w="12700" cap="flat">
-            <a:solidFill>
-              <a:srgbClr val="888888"/>
-            </a:solidFill>
-            <a:prstDash val="solid"/>
-            <a:round/>
-          </a:ln>
-        </c:spPr>
-        <c:txPr>
-          <a:bodyPr/>
-          <a:lstStyle/>
-          <a:p>
-            <a:pPr>
-              <a:defRPr sz="1100" b="0" i="0" u="none" strike="noStrike">
-                <a:solidFill>
-                  <a:srgbClr val="5F7180"/>
-                </a:solidFill>
-                <a:latin typeface="+mn-lt"/>
-              </a:defRPr>
-            </a:pPr>
-            <a:endParaRPr lang="en-US"/>
-          </a:p>
-        </c:txPr>
-        <c:crossAx val="2094734552"/>
-        <c:crosses val="autoZero"/>
-        <c:auto val="1"/>
-        <c:lblAlgn val="ctr"/>
-        <c:noMultiLvlLbl val="1"/>
-      </c:catAx>
-      <c:valAx>
-        <c:axId val="2094734552"/>
-        <c:scaling>
-          <c:orientation val="minMax"/>
-          <c:min val="0"/>
-        </c:scaling>
-        <c:delete val="1"/>
-        <c:axPos val="l"/>
-        <c:numFmt formatCode="General" sourceLinked="0"/>
-        <c:majorTickMark val="out"/>
-        <c:minorTickMark val="none"/>
-        <c:tickLblPos val="nextTo"/>
-        <c:spPr>
-          <a:ln w="12700" cap="flat">
-            <a:solidFill>
-              <a:srgbClr val="888888"/>
-            </a:solidFill>
-            <a:prstDash val="solid"/>
-            <a:round/>
-          </a:ln>
-        </c:spPr>
-        <c:txPr>
-          <a:bodyPr/>
-          <a:lstStyle/>
-          <a:p>
-            <a:pPr>
-              <a:defRPr sz="1100" b="0" i="0" u="none" strike="noStrike">
-                <a:solidFill>
-                  <a:srgbClr val="5F7180"/>
-                </a:solidFill>
-                <a:latin typeface="+mn-lt"/>
-              </a:defRPr>
-            </a:pPr>
-            <a:endParaRPr lang="en-US"/>
-          </a:p>
-        </c:txPr>
-        <c:crossAx val="2094734554"/>
-        <c:crosses val="autoZero"/>
-        <c:crossBetween val="between"/>
-      </c:valAx>
-      <c:spPr>
-        <a:noFill/>
-        <a:ln>
-          <a:noFill/>
-        </a:ln>
-        <a:effectLst/>
-      </c:spPr>
-    </c:plotArea>
-    <c:plotVisOnly val="1"/>
-    <c:dispBlanksAs val="span"/>
-  </c:chart>
-  <c:spPr>
-    <a:noFill/>
-    <a:ln>
-      <a:noFill/>
-    </a:ln>
-    <a:effectLst/>
-  </c:spPr>
-  <c:externalData r:id="rId1">
-    <c:autoUpdate val="0"/>
-  </c:externalData>
-</c:chartSpace>
-</file>
-
-<file path=ppt/charts/chart7.xml><?xml version="1.0" encoding="utf-8"?>
-<c:chartSpace xmlns:c="http://schemas.openxmlformats.org/drawingml/2006/chart" xmlns:a="http://schemas.openxmlformats.org/drawingml/2006/main" xmlns:r="http://schemas.openxmlformats.org/officeDocument/2006/relationships">
-  <c:date1904 val="0"/>
-  <c:roundedCorners val="1"/>
-  <c:chart>
-    <c:title>
-      <c:tx>
-        <c:rich>
-          <a:bodyPr/>
-          <a:lstStyle/>
-          <a:p>
-            <a:pPr>
-              <a:defRPr sz="1200" b="0" i="0" u="none" strike="noStrike">
-                <a:solidFill>
-                  <a:srgbClr val="0F4C5C"/>
-                </a:solidFill>
-                <a:latin typeface="+mn-lt"/>
-              </a:defRPr>
-            </a:pPr>
-            <a:r>
-              <a:rPr sz="1200" b="0" i="0" u="none" strike="noStrike">
-                <a:solidFill>
-                  <a:srgbClr val="0F4C5C"/>
-                </a:solidFill>
-                <a:latin typeface="+mn-lt"/>
-              </a:rPr>
-              <a:t>Average weight (kg)</a:t>
-            </a:r>
-          </a:p>
-        </c:rich>
-      </c:tx>
-      <c:layout/>
-      <c:overlay val="0"/>
-    </c:title>
-    <c:autoTitleDeleted val="0"/>
-    <c:plotArea>
-      <c:layout/>
-      <c:barChart>
-        <c:barDir val="col"/>
-        <c:grouping val="clustered"/>
-        <c:varyColors val="0"/>
-        <c:ser>
-          <c:idx val="0"/>
-          <c:order val="0"/>
-          <c:tx>
-            <c:strRef>
-              <c:f>Sheet1!$B$1</c:f>
-              <c:strCache>
-                <c:ptCount val="1"/>
-                <c:pt idx="0">
-                  <c:v>Average weight (kg)</c:v>
-                </c:pt>
-              </c:strCache>
-            </c:strRef>
-          </c:tx>
-          <c:spPr>
-            <a:solidFill>
-              <a:srgbClr val="2A78D6"/>
-            </a:solidFill>
-            <a:effectLst/>
-          </c:spPr>
-          <c:invertIfNegative val="0"/>
-          <c:dLbls>
-            <c:numFmt formatCode="0.0" sourceLinked="0"/>
-            <c:txPr>
-              <a:bodyPr/>
-              <a:lstStyle/>
-              <a:p>
-                <a:pPr>
-                  <a:defRPr b="0" i="0" strike="noStrike" sz="1100" u="none">
-                    <a:solidFill>
-                      <a:srgbClr val="16212B"/>
-                    </a:solidFill>
-                    <a:latin typeface="+mn-lt"/>
-                  </a:defRPr>
-                </a:pPr>
-              </a:p>
-            </c:txPr>
-            <c:showLegendKey val="0"/>
-            <c:showVal val="1"/>
-            <c:showCatName val="0"/>
-            <c:showSerName val="0"/>
-            <c:showPercent val="0"/>
-            <c:showBubbleSize val="0"/>
-            <c:showLeaderLines val="0"/>
-          </c:dLbls>
-          <c:dPt>
-            <c:idx val="0"/>
-            <c:invertIfNegative val="0"/>
-            <c:bubble3D val="0"/>
-            <c:spPr>
-              <a:solidFill>
-                <a:srgbClr val="2A78D6"/>
-              </a:solidFill>
-              <a:effectLst/>
-            </c:spPr>
-          </c:dPt>
-          <c:dPt>
-            <c:idx val="1"/>
-            <c:invertIfNegative val="0"/>
-            <c:bubble3D val="0"/>
-            <c:spPr>
-              <a:solidFill>
-                <a:srgbClr val="EDA100"/>
-              </a:solidFill>
-              <a:effectLst/>
-            </c:spPr>
-          </c:dPt>
-          <c:dPt>
-            <c:idx val="2"/>
-            <c:invertIfNegative val="0"/>
-            <c:bubble3D val="0"/>
-            <c:spPr>
-              <a:solidFill>
-                <a:srgbClr val="E87BA4"/>
-              </a:solidFill>
-              <a:effectLst/>
-            </c:spPr>
-          </c:dPt>
-          <c:dPt>
-            <c:idx val="3"/>
-            <c:invertIfNegative val="0"/>
-            <c:bubble3D val="0"/>
-            <c:spPr>
-              <a:solidFill>
-                <a:srgbClr val="008300"/>
-              </a:solidFill>
-              <a:effectLst/>
-            </c:spPr>
-          </c:dPt>
-          <c:cat>
-            <c:multiLvlStrRef>
-              <c:f>Sheet1!$A$2:$A$5</c:f>
-              <c:multiLvlStrCache>
-                <c:ptCount val="4"/>
-                <c:lvl>
-                  <c:pt idx="0">
-                    <c:v>A</c:v>
-                  </c:pt>
-                  <c:pt idx="1">
-                    <c:v>B</c:v>
-                  </c:pt>
-                  <c:pt idx="2">
-                    <c:v>C</c:v>
-                  </c:pt>
-                  <c:pt idx="3">
-                    <c:v>D</c:v>
-                  </c:pt>
-                </c:lvl>
-              </c:multiLvlStrCache>
-            </c:multiLvlStrRef>
-          </c:cat>
-          <c:val>
-            <c:numRef>
-              <c:f>Sheet1!$B$2:$B$5</c:f>
-              <c:numCache>
-                <c:formatCode>General</c:formatCode>
-                <c:ptCount val="4"/>
-                <c:pt idx="0">
-                  <c:v>1.1</c:v>
-                </c:pt>
-                <c:pt idx="1">
-                  <c:v>7.6</c:v>
-                </c:pt>
-                <c:pt idx="2">
-                  <c:v>1.1</c:v>
-                </c:pt>
-                <c:pt idx="3">
-                  <c:v>0.6</c:v>
-                </c:pt>
-              </c:numCache>
-            </c:numRef>
-          </c:val>
-        </c:ser>
-        <c:dLbls>
-          <c:numFmt formatCode="0.0" sourceLinked="0"/>
-          <c:txPr>
-            <a:bodyPr/>
-            <a:lstStyle/>
-            <a:p>
-              <a:pPr>
-                <a:defRPr b="0" i="0" strike="noStrike" sz="1100" u="none">
-                  <a:solidFill>
-                    <a:srgbClr val="16212B"/>
-                  </a:solidFill>
-                  <a:latin typeface="+mn-lt"/>
-                </a:defRPr>
-              </a:pPr>
-            </a:p>
-          </c:txPr>
-          <c:showLegendKey val="0"/>
-          <c:showVal val="1"/>
-          <c:showCatName val="0"/>
-          <c:showSerName val="0"/>
-          <c:showPercent val="0"/>
-          <c:showBubbleSize val="0"/>
-          <c:showLeaderLines val="0"/>
-        </c:dLbls>
-        <c:gapWidth val="45"/>
-        <c:overlap val="0"/>
-        <c:axId val="2094734554"/>
-        <c:axId val="2094734552"/>
-        <c:axId val="2094734556"/>
-      </c:barChart>
-      <c:catAx>
-        <c:axId val="2094734554"/>
-        <c:scaling>
-          <c:orientation val="minMax"/>
-        </c:scaling>
-        <c:delete val="0"/>
-        <c:axPos val="b"/>
-        <c:numFmt formatCode="General" sourceLinked="1"/>
-        <c:majorTickMark val="out"/>
-        <c:minorTickMark val="none"/>
-        <c:tickLblPos val="low"/>
-        <c:spPr>
-          <a:ln w="12700" cap="flat">
-            <a:solidFill>
-              <a:srgbClr val="888888"/>
-            </a:solidFill>
-            <a:prstDash val="solid"/>
-            <a:round/>
-          </a:ln>
-        </c:spPr>
-        <c:txPr>
-          <a:bodyPr/>
-          <a:lstStyle/>
-          <a:p>
-            <a:pPr>
-              <a:defRPr sz="1100" b="0" i="0" u="none" strike="noStrike">
-                <a:solidFill>
-                  <a:srgbClr val="5F7180"/>
-                </a:solidFill>
-                <a:latin typeface="+mn-lt"/>
-              </a:defRPr>
-            </a:pPr>
-            <a:endParaRPr lang="en-US"/>
-          </a:p>
-        </c:txPr>
-        <c:crossAx val="2094734552"/>
-        <c:crosses val="autoZero"/>
-        <c:auto val="1"/>
-        <c:lblAlgn val="ctr"/>
-        <c:noMultiLvlLbl val="1"/>
-      </c:catAx>
-      <c:valAx>
-        <c:axId val="2094734552"/>
-        <c:scaling>
-          <c:orientation val="minMax"/>
-          <c:min val="0"/>
-        </c:scaling>
-        <c:delete val="1"/>
-        <c:axPos val="l"/>
-        <c:numFmt formatCode="General" sourceLinked="0"/>
-        <c:majorTickMark val="out"/>
-        <c:minorTickMark val="none"/>
-        <c:tickLblPos val="nextTo"/>
-        <c:spPr>
-          <a:ln w="12700" cap="flat">
-            <a:solidFill>
-              <a:srgbClr val="888888"/>
-            </a:solidFill>
-            <a:prstDash val="solid"/>
-            <a:round/>
-          </a:ln>
-        </c:spPr>
-        <c:txPr>
-          <a:bodyPr/>
-          <a:lstStyle/>
-          <a:p>
-            <a:pPr>
-              <a:defRPr sz="1100" b="0" i="0" u="none" strike="noStrike">
-                <a:solidFill>
-                  <a:srgbClr val="5F7180"/>
-                </a:solidFill>
-                <a:latin typeface="+mn-lt"/>
-              </a:defRPr>
-            </a:pPr>
-            <a:endParaRPr lang="en-US"/>
-          </a:p>
-        </c:txPr>
-        <c:crossAx val="2094734554"/>
-        <c:crosses val="autoZero"/>
-        <c:crossBetween val="between"/>
-      </c:valAx>
-      <c:spPr>
-        <a:noFill/>
-        <a:ln>
-          <a:noFill/>
-        </a:ln>
-        <a:effectLst/>
-      </c:spPr>
-    </c:plotArea>
-    <c:plotVisOnly val="1"/>
-    <c:dispBlanksAs val="span"/>
-  </c:chart>
-  <c:spPr>
-    <a:noFill/>
-    <a:ln>
-      <a:noFill/>
-    </a:ln>
-    <a:effectLst/>
-  </c:spPr>
-  <c:externalData r:id="rId1">
-    <c:autoUpdate val="0"/>
-  </c:externalData>
-</c:chartSpace>
-</file>
-
-<file path=ppt/charts/chart8.xml><?xml version="1.0" encoding="utf-8"?>
-<c:chartSpace xmlns:c="http://schemas.openxmlformats.org/drawingml/2006/chart" xmlns:a="http://schemas.openxmlformats.org/drawingml/2006/main" xmlns:r="http://schemas.openxmlformats.org/officeDocument/2006/relationships">
-  <c:date1904 val="0"/>
-  <c:roundedCorners val="1"/>
-  <c:chart>
-    <c:title>
-      <c:tx>
-        <c:rich>
-          <a:bodyPr/>
-          <a:lstStyle/>
-          <a:p>
-            <a:pPr>
-              <a:defRPr sz="1200" b="0" i="0" u="none" strike="noStrike">
-                <a:solidFill>
-                  <a:srgbClr val="0F4C5C"/>
-                </a:solidFill>
-                <a:latin typeface="+mn-lt"/>
-              </a:defRPr>
-            </a:pPr>
-            <a:r>
-              <a:rPr sz="1200" b="0" i="0" u="none" strike="noStrike">
-                <a:solidFill>
-                  <a:srgbClr val="0F4C5C"/>
-                </a:solidFill>
-                <a:latin typeface="+mn-lt"/>
-              </a:rPr>
-              <a:t>Orders in each month, two real SKUs</a:t>
-            </a:r>
-          </a:p>
-        </c:rich>
-      </c:tx>
-      <c:layout/>
-      <c:overlay val="0"/>
-    </c:title>
-    <c:autoTitleDeleted val="0"/>
-    <c:plotArea>
-      <c:layout/>
-      <c:lineChart>
-        <c:varyColors val="0"/>
-        <c:ser>
-          <c:idx val="0"/>
-          <c:order val="0"/>
-          <c:tx>
-            <c:strRef>
-              <c:f>Sheet1!$B$1</c:f>
-              <c:strCache>
-                <c:ptCount val="1"/>
-                <c:pt idx="0">
-                  <c:v>Seasonal SKU (114 orders)</c:v>
-                </c:pt>
-              </c:strCache>
-            </c:strRef>
-          </c:tx>
-          <c:spPr>
-            <a:solidFill>
-              <a:srgbClr val="E87BA4"/>
-            </a:solidFill>
-            <a:ln w="38100" cap="flat">
-              <a:solidFill>
-                <a:srgbClr val="E87BA4"/>
-              </a:solidFill>
-              <a:prstDash val="solid"/>
-              <a:round/>
-            </a:ln>
-            <a:effectLst/>
-          </c:spPr>
-          <c:invertIfNegative val="0"/>
-          <c:dLbls>
-            <c:numFmt formatCode="#,##0" sourceLinked="0"/>
-            <c:txPr>
-              <a:bodyPr/>
-              <a:lstStyle/>
-              <a:p>
-                <a:pPr>
-                  <a:defRPr b="0" i="0" strike="noStrike" sz="1200" u="none">
-                    <a:solidFill>
-                      <a:srgbClr val="000000"/>
-                    </a:solidFill>
-                    <a:latin typeface="+mn-lt"/>
-                  </a:defRPr>
-                </a:pPr>
-              </a:p>
-            </c:txPr>
-            <c:showLegendKey val="0"/>
-            <c:showVal val="0"/>
-            <c:showCatName val="0"/>
-            <c:showSerName val="0"/>
-            <c:showPercent val="0"/>
-            <c:showBubbleSize val="0"/>
-            <c:showLeaderLines val="0"/>
-          </c:dLbls>
-          <c:marker>
-            <c:symbol val="circle"/>
-            <c:size val="7"/>
-            <c:spPr>
-              <a:solidFill>
-                <a:srgbClr val="E87BA4"/>
-              </a:solidFill>
-              <a:ln w="9525" cap="flat">
-                <a:solidFill>
-                  <a:srgbClr val="E87BA4"/>
-                </a:solidFill>
-                <a:prstDash val="solid"/>
-                <a:round/>
-              </a:ln>
-              <a:effectLst/>
-            </c:spPr>
-          </c:marker>
-          <c:cat>
-            <c:multiLvlStrRef>
-              <c:f>Sheet1!$A$2:$A$16</c:f>
-              <c:multiLvlStrCache>
-                <c:ptCount val="15"/>
-                <c:lvl>
-                  <c:pt idx="0">
-                    <c:v>2017-06</c:v>
-                  </c:pt>
-                  <c:pt idx="1">
-                    <c:v>2017-07</c:v>
-                  </c:pt>
-                  <c:pt idx="2">
-                    <c:v>2017-08</c:v>
-                  </c:pt>
-                  <c:pt idx="3">
-                    <c:v>2017-09</c:v>
-                  </c:pt>
-                  <c:pt idx="4">
-                    <c:v>2017-10</c:v>
-                  </c:pt>
-                  <c:pt idx="5">
-                    <c:v>2017-11</c:v>
-                  </c:pt>
-                  <c:pt idx="6">
-                    <c:v>2017-12</c:v>
-                  </c:pt>
-                  <c:pt idx="7">
-                    <c:v>2018-01</c:v>
-                  </c:pt>
-                  <c:pt idx="8">
-                    <c:v>2018-02</c:v>
-                  </c:pt>
-                  <c:pt idx="9">
-                    <c:v>2018-03</c:v>
-                  </c:pt>
-                  <c:pt idx="10">
-                    <c:v>2018-04</c:v>
-                  </c:pt>
-                  <c:pt idx="11">
-                    <c:v>2018-05</c:v>
-                  </c:pt>
-                  <c:pt idx="12">
-                    <c:v>2018-06</c:v>
-                  </c:pt>
-                  <c:pt idx="13">
-                    <c:v>2018-07</c:v>
-                  </c:pt>
-                  <c:pt idx="14">
-                    <c:v>2018-08</c:v>
-                  </c:pt>
-                </c:lvl>
-              </c:multiLvlStrCache>
-            </c:multiLvlStrRef>
-          </c:cat>
-          <c:val>
-            <c:numRef>
-              <c:f>Sheet1!$B$2:$B$16</c:f>
-              <c:numCache>
-                <c:formatCode>General</c:formatCode>
-                <c:ptCount val="15"/>
-                <c:pt idx="0">
-                  <c:v>0</c:v>
-                </c:pt>
-                <c:pt idx="1">
-                  <c:v>0</c:v>
-                </c:pt>
-                <c:pt idx="2">
-                  <c:v>0</c:v>
-                </c:pt>
-                <c:pt idx="3">
-                  <c:v>1</c:v>
-                </c:pt>
-                <c:pt idx="4">
-                  <c:v>0</c:v>
-                </c:pt>
-                <c:pt idx="5">
-                  <c:v>0</c:v>
-                </c:pt>
-                <c:pt idx="6">
-                  <c:v>0</c:v>
-                </c:pt>
-                <c:pt idx="7">
-                  <c:v>76</c:v>
-                </c:pt>
-                <c:pt idx="8">
-                  <c:v>0</c:v>
-                </c:pt>
-                <c:pt idx="9">
-                  <c:v>26</c:v>
-                </c:pt>
-                <c:pt idx="10">
-                  <c:v>4</c:v>
-                </c:pt>
-                <c:pt idx="11">
-                  <c:v>4</c:v>
-                </c:pt>
-                <c:pt idx="12">
-                  <c:v>2</c:v>
-                </c:pt>
-                <c:pt idx="13">
-                  <c:v>0</c:v>
-                </c:pt>
-                <c:pt idx="14">
-                  <c:v>1</c:v>
-                </c:pt>
-              </c:numCache>
-            </c:numRef>
-          </c:val>
-          <c:smooth val="0"/>
-        </c:ser>
-        <c:ser>
-          <c:idx val="1"/>
-          <c:order val="1"/>
-          <c:tx>
-            <c:strRef>
-              <c:f>Sheet1!$C$1</c:f>
-              <c:strCache>
-                <c:ptCount val="1"/>
-                <c:pt idx="0">
-                  <c:v>Fast mover (527 orders)</c:v>
-                </c:pt>
-              </c:strCache>
-            </c:strRef>
-          </c:tx>
-          <c:spPr>
-            <a:solidFill>
-              <a:srgbClr val="2A78D6"/>
-            </a:solidFill>
-            <a:ln w="38100" cap="flat">
-              <a:solidFill>
-                <a:srgbClr val="2A78D6"/>
-              </a:solidFill>
-              <a:prstDash val="solid"/>
-              <a:round/>
-            </a:ln>
-            <a:effectLst/>
-          </c:spPr>
-          <c:invertIfNegative val="0"/>
-          <c:dLbls>
-            <c:numFmt formatCode="#,##0" sourceLinked="0"/>
-            <c:txPr>
-              <a:bodyPr/>
-              <a:lstStyle/>
-              <a:p>
-                <a:pPr>
-                  <a:defRPr b="0" i="0" strike="noStrike" sz="1200" u="none">
-                    <a:solidFill>
-                      <a:srgbClr val="000000"/>
-                    </a:solidFill>
-                    <a:latin typeface="+mn-lt"/>
-                  </a:defRPr>
-                </a:pPr>
-              </a:p>
-            </c:txPr>
-            <c:showLegendKey val="0"/>
-            <c:showVal val="0"/>
-            <c:showCatName val="0"/>
-            <c:showSerName val="0"/>
-            <c:showPercent val="0"/>
-            <c:showBubbleSize val="0"/>
-            <c:showLeaderLines val="0"/>
-          </c:dLbls>
-          <c:marker>
-            <c:symbol val="circle"/>
-            <c:size val="7"/>
-            <c:spPr>
-              <a:solidFill>
-                <a:srgbClr val="2A78D6"/>
-              </a:solidFill>
-              <a:ln w="9525" cap="flat">
-                <a:solidFill>
-                  <a:srgbClr val="2A78D6"/>
-                </a:solidFill>
-                <a:prstDash val="solid"/>
-                <a:round/>
-              </a:ln>
-              <a:effectLst/>
-            </c:spPr>
-          </c:marker>
-          <c:cat>
-            <c:multiLvlStrRef>
-              <c:f>Sheet1!$A$2:$A$16</c:f>
-              <c:multiLvlStrCache>
-                <c:ptCount val="15"/>
-                <c:lvl>
-                  <c:pt idx="0">
-                    <c:v>2017-06</c:v>
-                  </c:pt>
-                  <c:pt idx="1">
-                    <c:v>2017-07</c:v>
-                  </c:pt>
-                  <c:pt idx="2">
-                    <c:v>2017-08</c:v>
-                  </c:pt>
-                  <c:pt idx="3">
-                    <c:v>2017-09</c:v>
-                  </c:pt>
-                  <c:pt idx="4">
-                    <c:v>2017-10</c:v>
-                  </c:pt>
-                  <c:pt idx="5">
-                    <c:v>2017-11</c:v>
-                  </c:pt>
-                  <c:pt idx="6">
-                    <c:v>2017-12</c:v>
-                  </c:pt>
-                  <c:pt idx="7">
-                    <c:v>2018-01</c:v>
-                  </c:pt>
-                  <c:pt idx="8">
-                    <c:v>2018-02</c:v>
-                  </c:pt>
-                  <c:pt idx="9">
-                    <c:v>2018-03</c:v>
-                  </c:pt>
-                  <c:pt idx="10">
-                    <c:v>2018-04</c:v>
-                  </c:pt>
-                  <c:pt idx="11">
-                    <c:v>2018-05</c:v>
-                  </c:pt>
-                  <c:pt idx="12">
-                    <c:v>2018-06</c:v>
-                  </c:pt>
-                  <c:pt idx="13">
-                    <c:v>2018-07</c:v>
-                  </c:pt>
-                  <c:pt idx="14">
-                    <c:v>2018-08</c:v>
-                  </c:pt>
-                </c:lvl>
-              </c:multiLvlStrCache>
-            </c:multiLvlStrRef>
-          </c:cat>
-          <c:val>
-            <c:numRef>
-              <c:f>Sheet1!$C$2:$C$16</c:f>
-              <c:numCache>
-                <c:formatCode>General</c:formatCode>
-                <c:ptCount val="15"/>
-                <c:pt idx="0">
-                  <c:v>0</c:v>
-                </c:pt>
-                <c:pt idx="1">
-                  <c:v>5</c:v>
-                </c:pt>
-                <c:pt idx="2">
-                  <c:v>13</c:v>
-                </c:pt>
-                <c:pt idx="3">
-                  <c:v>0</c:v>
-                </c:pt>
-                <c:pt idx="4">
-                  <c:v>5</c:v>
-                </c:pt>
-                <c:pt idx="5">
-                  <c:v>44</c:v>
-                </c:pt>
-                <c:pt idx="6">
-                  <c:v>47</c:v>
-                </c:pt>
-                <c:pt idx="7">
-                  <c:v>122</c:v>
-                </c:pt>
-                <c:pt idx="8">
-                  <c:v>44</c:v>
-                </c:pt>
-                <c:pt idx="9">
-                  <c:v>65</c:v>
-                </c:pt>
-                <c:pt idx="10">
-                  <c:v>83</c:v>
-                </c:pt>
-                <c:pt idx="11">
-                  <c:v>92</c:v>
-                </c:pt>
-                <c:pt idx="12">
-                  <c:v>2</c:v>
-                </c:pt>
-                <c:pt idx="13">
-                  <c:v>2</c:v>
-                </c:pt>
-                <c:pt idx="14">
-                  <c:v>3</c:v>
-                </c:pt>
-              </c:numCache>
-            </c:numRef>
-          </c:val>
-          <c:smooth val="0"/>
-        </c:ser>
-        <c:dLbls>
-          <c:numFmt formatCode="#,##0" sourceLinked="0"/>
-          <c:txPr>
-            <a:bodyPr/>
-            <a:lstStyle/>
-            <a:p>
-              <a:pPr>
-                <a:defRPr b="0" i="0" strike="noStrike" sz="1200" u="none">
-                  <a:solidFill>
-                    <a:srgbClr val="000000"/>
-                  </a:solidFill>
-                  <a:latin typeface="+mn-lt"/>
-                </a:defRPr>
-              </a:pPr>
-            </a:p>
-          </c:txPr>
-          <c:showLegendKey val="0"/>
-          <c:showVal val="0"/>
-          <c:showCatName val="0"/>
-          <c:showSerName val="0"/>
-          <c:showPercent val="0"/>
-          <c:showBubbleSize val="0"/>
-          <c:showLeaderLines val="0"/>
-        </c:dLbls>
-        <c:marker val="1"/>
-        <c:axId val="2094734554"/>
-        <c:axId val="2094734552"/>
-        <c:axId val="2094734556"/>
-      </c:lineChart>
-      <c:catAx>
-        <c:axId val="2094734554"/>
-        <c:scaling>
-          <c:orientation val="minMax"/>
-        </c:scaling>
-        <c:delete val="0"/>
-        <c:axPos val="b"/>
-        <c:numFmt formatCode="General" sourceLinked="1"/>
-        <c:majorTickMark val="out"/>
-        <c:minorTickMark val="none"/>
-        <c:tickLblPos val="low"/>
-        <c:spPr>
-          <a:ln w="12700" cap="flat">
-            <a:solidFill>
-              <a:srgbClr val="888888"/>
-            </a:solidFill>
-            <a:prstDash val="solid"/>
-            <a:round/>
-          </a:ln>
-        </c:spPr>
-        <c:txPr>
-          <a:bodyPr rot="16200000"/>
-          <a:lstStyle/>
-          <a:p>
-            <a:pPr>
-              <a:defRPr sz="900" b="0" i="0" u="none" strike="noStrike">
-                <a:solidFill>
-                  <a:srgbClr val="5F7180"/>
-                </a:solidFill>
-                <a:latin typeface="+mn-lt"/>
-              </a:defRPr>
-            </a:pPr>
-            <a:endParaRPr lang="en-US"/>
-          </a:p>
-        </c:txPr>
-        <c:crossAx val="2094734552"/>
-        <c:crosses val="autoZero"/>
-        <c:auto val="1"/>
-        <c:lblAlgn val="ctr"/>
-        <c:noMultiLvlLbl val="1"/>
-      </c:catAx>
-      <c:valAx>
-        <c:axId val="2094734552"/>
-        <c:scaling>
-          <c:orientation val="minMax"/>
-          <c:min val="0"/>
-        </c:scaling>
-        <c:delete val="0"/>
-        <c:axPos val="l"/>
-        <c:majorGridlines>
-          <c:spPr>
-            <a:ln w="9525" cap="flat">
-              <a:solidFill>
-                <a:srgbClr val="EAF2F3"/>
-              </a:solidFill>
-              <a:prstDash val="solid"/>
-              <a:round/>
-            </a:ln>
-          </c:spPr>
-        </c:majorGridlines>
-        <c:numFmt formatCode="General" sourceLinked="0"/>
-        <c:majorTickMark val="out"/>
-        <c:minorTickMark val="none"/>
-        <c:tickLblPos val="nextTo"/>
-        <c:spPr>
-          <a:ln w="12700" cap="flat">
-            <a:solidFill>
-              <a:srgbClr val="888888"/>
-            </a:solidFill>
-            <a:prstDash val="solid"/>
-            <a:round/>
-          </a:ln>
-        </c:spPr>
-        <c:txPr>
-          <a:bodyPr/>
-          <a:lstStyle/>
-          <a:p>
-            <a:pPr>
-              <a:defRPr sz="1100" b="0" i="0" u="none" strike="noStrike">
-                <a:solidFill>
-                  <a:srgbClr val="5F7180"/>
-                </a:solidFill>
-                <a:latin typeface="+mn-lt"/>
-              </a:defRPr>
-            </a:pPr>
-            <a:endParaRPr lang="en-US"/>
-          </a:p>
-        </c:txPr>
-        <c:crossAx val="2094734554"/>
-        <c:crosses val="autoZero"/>
-        <c:crossBetween val="between"/>
-      </c:valAx>
-      <c:spPr>
-        <a:noFill/>
-        <a:ln>
-          <a:noFill/>
-        </a:ln>
-        <a:effectLst/>
-      </c:spPr>
-    </c:plotArea>
-    <c:legend>
-      <c:legendPos val="b"/>
-      <c:overlay val="0"/>
-      <c:txPr>
-        <a:bodyPr/>
-        <a:lstStyle/>
-        <a:p>
-          <a:pPr>
-            <a:defRPr sz="1100">
-              <a:solidFill>
-                <a:srgbClr val="16212B"/>
-              </a:solidFill>
-              <a:latin typeface="+mn-lt"/>
-              <a:cs typeface="+mn-lt"/>
-            </a:defRPr>
-          </a:pPr>
-          <a:endParaRPr lang="en-US"/>
-        </a:p>
-      </c:txPr>
-    </c:legend>
-    <c:plotVisOnly val="1"/>
-    <c:dispBlanksAs val="span"/>
-  </c:chart>
-  <c:spPr>
-    <a:noFill/>
-    <a:ln>
-      <a:noFill/>
-    </a:ln>
-    <a:effectLst/>
-  </c:spPr>
-  <c:externalData r:id="rId1">
-    <c:autoUpdate val="0"/>
-  </c:externalData>
-</c:chartSpace>
-</file>
-
-<file path=ppt/charts/chart9.xml><?xml version="1.0" encoding="utf-8"?>
-<c:chartSpace xmlns:c="http://schemas.openxmlformats.org/drawingml/2006/chart" xmlns:a="http://schemas.openxmlformats.org/drawingml/2006/main" xmlns:r="http://schemas.openxmlformats.org/officeDocument/2006/relationships">
-  <c:date1904 val="0"/>
-  <c:roundedCorners val="1"/>
-  <c:chart>
-    <c:title>
-      <c:tx>
-        <c:rich>
-          <a:bodyPr/>
-          <a:lstStyle/>
-          <a:p>
-            <a:pPr>
-              <a:defRPr sz="1200" b="0" i="0" u="none" strike="noStrike">
-                <a:solidFill>
-                  <a:srgbClr val="0F4C5C"/>
-                </a:solidFill>
-                <a:latin typeface="+mn-lt"/>
-              </a:defRPr>
-            </a:pPr>
-            <a:r>
-              <a:rPr sz="1200" b="0" i="0" u="none" strike="noStrike">
-                <a:solidFill>
-                  <a:srgbClr val="0F4C5C"/>
-                </a:solidFill>
-                <a:latin typeface="+mn-lt"/>
-              </a:rPr>
-              <a:t>Walk per pick in the model (metres)</a:t>
-            </a:r>
-          </a:p>
-        </c:rich>
-      </c:tx>
-      <c:layout/>
-      <c:overlay val="0"/>
-    </c:title>
-    <c:autoTitleDeleted val="0"/>
-    <c:plotArea>
-      <c:layout/>
-      <c:barChart>
-        <c:barDir val="bar"/>
-        <c:grouping val="clustered"/>
-        <c:varyColors val="0"/>
-        <c:ser>
-          <c:idx val="0"/>
-          <c:order val="0"/>
-          <c:tx>
-            <c:strRef>
-              <c:f>Sheet1!$B$1</c:f>
-              <c:strCache>
-                <c:ptCount val="1"/>
-                <c:pt idx="0">
-                  <c:v>Walk per pick (m)</c:v>
-                </c:pt>
-              </c:strCache>
-            </c:strRef>
-          </c:tx>
-          <c:spPr>
-            <a:solidFill>
-              <a:srgbClr val="008300"/>
-            </a:solidFill>
-            <a:effectLst/>
-          </c:spPr>
-          <c:invertIfNegative val="0"/>
-          <c:dLbls>
-            <c:numFmt formatCode="0.0&quot; m&quot;" sourceLinked="0"/>
-            <c:txPr>
-              <a:bodyPr/>
-              <a:lstStyle/>
-              <a:p>
-                <a:pPr>
-                  <a:defRPr b="0" i="0" strike="noStrike" sz="1200" u="none">
-                    <a:solidFill>
-                      <a:srgbClr val="16212B"/>
-                    </a:solidFill>
-                    <a:latin typeface="+mn-lt"/>
-                  </a:defRPr>
-                </a:pPr>
-              </a:p>
-            </c:txPr>
-            <c:showLegendKey val="0"/>
-            <c:showVal val="1"/>
-            <c:showCatName val="0"/>
-            <c:showSerName val="0"/>
-            <c:showPercent val="0"/>
-            <c:showBubbleSize val="0"/>
-            <c:showLeaderLines val="0"/>
-          </c:dLbls>
-          <c:dPt>
-            <c:idx val="0"/>
-            <c:invertIfNegative val="0"/>
-            <c:bubble3D val="0"/>
-            <c:spPr>
-              <a:solidFill>
-                <a:srgbClr val="008300"/>
-              </a:solidFill>
-              <a:effectLst/>
-            </c:spPr>
-          </c:dPt>
-          <c:dPt>
-            <c:idx val="1"/>
-            <c:invertIfNegative val="0"/>
-            <c:bubble3D val="0"/>
-            <c:spPr>
-              <a:solidFill>
-                <a:srgbClr val="9BBBE4"/>
-              </a:solidFill>
-              <a:effectLst/>
-            </c:spPr>
-          </c:dPt>
-          <c:cat>
-            <c:multiLvlStrRef>
-              <c:f>Sheet1!$A$2:$A$3</c:f>
-              <c:multiLvlStrCache>
-                <c:ptCount val="2"/>
-                <c:lvl>
-                  <c:pt idx="0">
-                    <c:v>K-Means zones</c:v>
-                  </c:pt>
-                  <c:pt idx="1">
-                    <c:v>No grouping</c:v>
-                  </c:pt>
-                </c:lvl>
-              </c:multiLvlStrCache>
-            </c:multiLvlStrRef>
-          </c:cat>
-          <c:val>
-            <c:numRef>
-              <c:f>Sheet1!$B$2:$B$3</c:f>
-              <c:numCache>
-                <c:formatCode>General</c:formatCode>
-                <c:ptCount val="2"/>
-                <c:pt idx="0">
-                  <c:v>46.5</c:v>
-                </c:pt>
-                <c:pt idx="1">
-                  <c:v>63.8</c:v>
-                </c:pt>
-              </c:numCache>
-            </c:numRef>
-          </c:val>
-        </c:ser>
-        <c:dLbls>
-          <c:numFmt formatCode="0.0&quot; m&quot;" sourceLinked="0"/>
-          <c:txPr>
-            <a:bodyPr/>
-            <a:lstStyle/>
-            <a:p>
-              <a:pPr>
-                <a:defRPr b="0" i="0" strike="noStrike" sz="1200" u="none">
-                  <a:solidFill>
-                    <a:srgbClr val="16212B"/>
-                  </a:solidFill>
-                  <a:latin typeface="+mn-lt"/>
-                </a:defRPr>
-              </a:pPr>
-            </a:p>
-          </c:txPr>
-          <c:showLegendKey val="0"/>
-          <c:showVal val="1"/>
-          <c:showCatName val="0"/>
-          <c:showSerName val="0"/>
-          <c:showPercent val="0"/>
-          <c:showBubbleSize val="0"/>
-          <c:showLeaderLines val="0"/>
-        </c:dLbls>
-        <c:gapWidth val="45"/>
-        <c:overlap val="0"/>
-        <c:axId val="2094734554"/>
-        <c:axId val="2094734552"/>
-        <c:axId val="2094734556"/>
-      </c:barChart>
-      <c:catAx>
-        <c:axId val="2094734554"/>
-        <c:scaling>
-          <c:orientation val="minMax"/>
-        </c:scaling>
-        <c:delete val="0"/>
-        <c:axPos val="l"/>
-        <c:numFmt formatCode="General" sourceLinked="1"/>
-        <c:majorTickMark val="out"/>
-        <c:minorTickMark val="none"/>
-        <c:tickLblPos val="nextTo"/>
-        <c:spPr>
-          <a:ln w="12700" cap="flat">
-            <a:solidFill>
-              <a:srgbClr val="888888"/>
-            </a:solidFill>
-            <a:prstDash val="solid"/>
-            <a:round/>
-          </a:ln>
-        </c:spPr>
-        <c:txPr>
-          <a:bodyPr/>
-          <a:lstStyle/>
-          <a:p>
-            <a:pPr>
-              <a:defRPr sz="1100" b="0" i="0" u="none" strike="noStrike">
-                <a:solidFill>
-                  <a:srgbClr val="5F7180"/>
-                </a:solidFill>
-                <a:latin typeface="+mn-lt"/>
-              </a:defRPr>
-            </a:pPr>
-            <a:endParaRPr lang="en-US"/>
-          </a:p>
-        </c:txPr>
-        <c:crossAx val="2094734552"/>
-        <c:crosses val="autoZero"/>
-        <c:auto val="1"/>
-        <c:lblAlgn val="ctr"/>
-        <c:noMultiLvlLbl val="1"/>
-      </c:catAx>
-      <c:valAx>
-        <c:axId val="2094734552"/>
-        <c:scaling>
-          <c:orientation val="minMax"/>
-          <c:max val="80"/>
-          <c:min val="0"/>
-        </c:scaling>
-        <c:delete val="0"/>
-        <c:axPos val="b"/>
-        <c:majorGridlines>
-          <c:spPr>
-            <a:ln w="9525" cap="flat">
-              <a:solidFill>
-                <a:srgbClr val="EAF2F3"/>
-              </a:solidFill>
-              <a:prstDash val="solid"/>
-              <a:round/>
-            </a:ln>
-          </c:spPr>
-        </c:majorGridlines>
-        <c:numFmt formatCode="0" sourceLinked="0"/>
-        <c:majorTickMark val="out"/>
-        <c:minorTickMark val="none"/>
-        <c:tickLblPos val="low"/>
-        <c:spPr>
-          <a:ln w="12700" cap="flat">
-            <a:solidFill>
-              <a:srgbClr val="888888"/>
-            </a:solidFill>
-            <a:prstDash val="solid"/>
-            <a:round/>
-          </a:ln>
-        </c:spPr>
-        <c:txPr>
-          <a:bodyPr/>
-          <a:lstStyle/>
-          <a:p>
-            <a:pPr>
-              <a:defRPr sz="1100" b="0" i="0" u="none" strike="noStrike">
-                <a:solidFill>
-                  <a:srgbClr val="5F7180"/>
-                </a:solidFill>
-                <a:latin typeface="+mn-lt"/>
-              </a:defRPr>
-            </a:pPr>
-            <a:endParaRPr lang="en-US"/>
-          </a:p>
-        </c:txPr>
-        <c:crossAx val="2094734554"/>
-        <c:crosses val="autoZero"/>
-        <c:crossBetween val="between"/>
-      </c:valAx>
-      <c:spPr>
-        <a:noFill/>
-        <a:ln>
-          <a:noFill/>
-        </a:ln>
-        <a:effectLst/>
-      </c:spPr>
-    </c:plotArea>
-    <c:plotVisOnly val="1"/>
-    <c:dispBlanksAs val="span"/>
-  </c:chart>
-  <c:spPr>
-    <a:noFill/>
-    <a:ln>
-      <a:noFill/>
-    </a:ln>
-    <a:effectLst/>
-  </c:spPr>
-  <c:externalData r:id="rId1">
-    <c:autoUpdate val="0"/>
-  </c:externalData>
-</c:chartSpace>
 </file>
 
 <file path=ppt/notesMasters/notesMaster1.xml><?xml version="1.0" encoding="utf-8"?>
@@ -7119,22 +3874,30 @@
           </a:p>
         </p:txBody>
       </p:sp>
-      <p:graphicFrame>
-        <p:nvGraphicFramePr>
-          <p:cNvPr id="4" name="Elbow chart" descr=""/>
-          <p:cNvGraphicFramePr/>
-          <p:nvPr/>
-        </p:nvGraphicFramePr>
-        <p:xfrm>
-          <a:off x="457200" y="1188720"/>
-          <a:ext cx="4754880" cy="3246120"/>
-        </p:xfrm>
-        <a:graphic xmlns:a="http://schemas.openxmlformats.org/drawingml/2006/main">
-          <a:graphicData uri="http://schemas.openxmlformats.org/drawingml/2006/chart">
-            <c:chart xmlns:c="http://schemas.openxmlformats.org/drawingml/2006/chart" r:id="rId1"/>
-          </a:graphicData>
-        </a:graphic>
-      </p:graphicFrame>
+      <p:pic>
+        <p:nvPicPr>
+          <p:cNvPr id="4" name="Elbow chart" descr="Elbow curve: within-cluster variance for k from 1 to 8, bending at k equal to 4">    </p:cNvPr>
+          <p:cNvPicPr>
+            <a:picLocks noChangeAspect="1"/>
+          </p:cNvPicPr>
+          <p:nvPr/>
+        </p:nvPicPr>
+        <p:blipFill>
+          <a:blip r:embed="rId1"/>
+          <a:stretch>
+            <a:fillRect/>
+          </a:stretch>
+        </p:blipFill>
+        <p:spPr>
+          <a:xfrm>
+            <a:off x="457200" y="1188720"/>
+            <a:ext cx="4754880" cy="3246120"/>
+          </a:xfrm>
+          <a:prstGeom prst="rect">
+            <a:avLst/>
+          </a:prstGeom>
+        </p:spPr>
+      </p:pic>
       <p:sp>
         <p:nvSpPr>
           <p:cNvPr id="5" name="Badge 170"/>
@@ -7629,22 +4392,30 @@
           </a:p>
         </p:txBody>
       </p:sp>
-      <p:graphicFrame>
-        <p:nvGraphicFramePr>
-          <p:cNvPr id="4" name="Silhouette chart" descr=""/>
-          <p:cNvGraphicFramePr/>
-          <p:nvPr/>
-        </p:nvGraphicFramePr>
-        <p:xfrm>
-          <a:off x="457200" y="1188720"/>
-          <a:ext cx="4754880" cy="3246120"/>
-        </p:xfrm>
-        <a:graphic xmlns:a="http://schemas.openxmlformats.org/drawingml/2006/main">
-          <a:graphicData uri="http://schemas.openxmlformats.org/drawingml/2006/chart">
-            <c:chart xmlns:c="http://schemas.openxmlformats.org/drawingml/2006/chart" r:id="rId1"/>
-          </a:graphicData>
-        </a:graphic>
-      </p:graphicFrame>
+      <p:pic>
+        <p:nvPicPr>
+          <p:cNvPr id="4" name="Silhouette chart" descr="Bar graph of the silhouette score for k from 2 to 8, highest at k equal to 4">    </p:cNvPr>
+          <p:cNvPicPr>
+            <a:picLocks noChangeAspect="1"/>
+          </p:cNvPicPr>
+          <p:nvPr/>
+        </p:nvPicPr>
+        <p:blipFill>
+          <a:blip r:embed="rId1"/>
+          <a:stretch>
+            <a:fillRect/>
+          </a:stretch>
+        </p:blipFill>
+        <p:spPr>
+          <a:xfrm>
+            <a:off x="457200" y="1188720"/>
+            <a:ext cx="4754880" cy="3246120"/>
+          </a:xfrm>
+          <a:prstGeom prst="rect">
+            <a:avLst/>
+          </a:prstGeom>
+        </p:spPr>
+      </p:pic>
       <p:sp>
         <p:nvSpPr>
           <p:cNvPr id="5" name="Badge 180"/>
@@ -20770,73 +17541,33 @@
           </a:p>
         </p:txBody>
       </p:sp>
-      <p:graphicFrame>
-        <p:nvGraphicFramePr>
-          <p:cNvPr id="4" name="Average orders" descr=""/>
-          <p:cNvGraphicFramePr/>
-          <p:nvPr/>
-        </p:nvGraphicFramePr>
-        <p:xfrm>
-          <a:off x="457200" y="1188720"/>
-          <a:ext cx="2011680" cy="2514600"/>
-        </p:xfrm>
-        <a:graphic xmlns:a="http://schemas.openxmlformats.org/drawingml/2006/main">
-          <a:graphicData uri="http://schemas.openxmlformats.org/drawingml/2006/chart">
-            <c:chart xmlns:c="http://schemas.openxmlformats.org/drawingml/2006/chart" r:id="rId1"/>
-          </a:graphicData>
-        </a:graphic>
-      </p:graphicFrame>
-      <p:graphicFrame>
-        <p:nvGraphicFramePr>
-          <p:cNvPr id="5" name="Season index" descr=""/>
-          <p:cNvGraphicFramePr/>
-          <p:nvPr/>
-        </p:nvGraphicFramePr>
-        <p:xfrm>
-          <a:off x="2532888" y="1188720"/>
-          <a:ext cx="2011680" cy="2514600"/>
-        </p:xfrm>
-        <a:graphic xmlns:a="http://schemas.openxmlformats.org/drawingml/2006/main">
-          <a:graphicData uri="http://schemas.openxmlformats.org/drawingml/2006/chart">
-            <c:chart xmlns:c="http://schemas.openxmlformats.org/drawingml/2006/chart" r:id="rId2"/>
-          </a:graphicData>
-        </a:graphic>
-      </p:graphicFrame>
-      <p:graphicFrame>
-        <p:nvGraphicFramePr>
-          <p:cNvPr id="6" name="Average volume (L)" descr=""/>
-          <p:cNvGraphicFramePr/>
-          <p:nvPr/>
-        </p:nvGraphicFramePr>
-        <p:xfrm>
-          <a:off x="4608576" y="1188720"/>
-          <a:ext cx="2011680" cy="2514600"/>
-        </p:xfrm>
-        <a:graphic xmlns:a="http://schemas.openxmlformats.org/drawingml/2006/main">
-          <a:graphicData uri="http://schemas.openxmlformats.org/drawingml/2006/chart">
-            <c:chart xmlns:c="http://schemas.openxmlformats.org/drawingml/2006/chart" r:id="rId3"/>
-          </a:graphicData>
-        </a:graphic>
-      </p:graphicFrame>
-      <p:graphicFrame>
-        <p:nvGraphicFramePr>
-          <p:cNvPr id="7" name="Average weight (kg)" descr=""/>
-          <p:cNvGraphicFramePr/>
-          <p:nvPr/>
-        </p:nvGraphicFramePr>
-        <p:xfrm>
-          <a:off x="6684264" y="1188720"/>
-          <a:ext cx="2011680" cy="2514600"/>
-        </p:xfrm>
-        <a:graphic xmlns:a="http://schemas.openxmlformats.org/drawingml/2006/main">
-          <a:graphicData uri="http://schemas.openxmlformats.org/drawingml/2006/chart">
-            <c:chart xmlns:c="http://schemas.openxmlformats.org/drawingml/2006/chart" r:id="rId4"/>
-          </a:graphicData>
-        </a:graphic>
-      </p:graphicFrame>
-      <p:sp>
-        <p:nvSpPr>
-          <p:cNvPr id="8" name="Key 602"/>
+      <p:pic>
+        <p:nvPicPr>
+          <p:cNvPr id="4" name="Cluster averages" descr="Four bar graphs: average orders, season index, volume and weight for clusters A, B, C and D">    </p:cNvPr>
+          <p:cNvPicPr>
+            <a:picLocks noChangeAspect="1"/>
+          </p:cNvPicPr>
+          <p:nvPr/>
+        </p:nvPicPr>
+        <p:blipFill>
+          <a:blip r:embed="rId1"/>
+          <a:stretch>
+            <a:fillRect/>
+          </a:stretch>
+        </p:blipFill>
+        <p:spPr>
+          <a:xfrm>
+            <a:off x="457200" y="1188720"/>
+            <a:ext cx="8229600" cy="2514600"/>
+          </a:xfrm>
+          <a:prstGeom prst="rect">
+            <a:avLst/>
+          </a:prstGeom>
+        </p:spPr>
+      </p:pic>
+      <p:sp>
+        <p:nvSpPr>
+          <p:cNvPr id="5" name="Key 602"/>
           <p:cNvSpPr/>
           <p:nvPr/>
         </p:nvSpPr>
@@ -20861,7 +17592,7 @@
       </p:sp>
       <p:sp>
         <p:nvSpPr>
-          <p:cNvPr id="9" name="Text 603"/>
+          <p:cNvPr id="6" name="Text 603"/>
           <p:cNvSpPr txBox="1"/>
           <p:nvPr/>
         </p:nvSpPr>
@@ -20897,7 +17628,7 @@
       </p:sp>
       <p:sp>
         <p:nvSpPr>
-          <p:cNvPr id="10" name="Key 604"/>
+          <p:cNvPr id="7" name="Key 604"/>
           <p:cNvSpPr/>
           <p:nvPr/>
         </p:nvSpPr>
@@ -20922,7 +17653,7 @@
       </p:sp>
       <p:sp>
         <p:nvSpPr>
-          <p:cNvPr id="11" name="Text 605"/>
+          <p:cNvPr id="8" name="Text 605"/>
           <p:cNvSpPr txBox="1"/>
           <p:nvPr/>
         </p:nvSpPr>
@@ -20958,7 +17689,7 @@
       </p:sp>
       <p:sp>
         <p:nvSpPr>
-          <p:cNvPr id="12" name="Key 606"/>
+          <p:cNvPr id="9" name="Key 606"/>
           <p:cNvSpPr/>
           <p:nvPr/>
         </p:nvSpPr>
@@ -20983,7 +17714,7 @@
       </p:sp>
       <p:sp>
         <p:nvSpPr>
-          <p:cNvPr id="13" name="Text 607"/>
+          <p:cNvPr id="10" name="Text 607"/>
           <p:cNvSpPr txBox="1"/>
           <p:nvPr/>
         </p:nvSpPr>
@@ -21019,7 +17750,7 @@
       </p:sp>
       <p:sp>
         <p:nvSpPr>
-          <p:cNvPr id="14" name="Key 608"/>
+          <p:cNvPr id="11" name="Key 608"/>
           <p:cNvSpPr/>
           <p:nvPr/>
         </p:nvSpPr>
@@ -21044,7 +17775,7 @@
       </p:sp>
       <p:sp>
         <p:nvSpPr>
-          <p:cNvPr id="15" name="Text 609"/>
+          <p:cNvPr id="12" name="Text 609"/>
           <p:cNvSpPr txBox="1"/>
           <p:nvPr/>
         </p:nvSpPr>
@@ -21080,7 +17811,7 @@
       </p:sp>
       <p:sp>
         <p:nvSpPr>
-          <p:cNvPr id="16" name="Card 610"/>
+          <p:cNvPr id="13" name="Card 610"/>
           <p:cNvSpPr/>
           <p:nvPr/>
         </p:nvSpPr>
@@ -21107,7 +17838,7 @@
       </p:sp>
       <p:sp>
         <p:nvSpPr>
-          <p:cNvPr id="17" name="Text 611"/>
+          <p:cNvPr id="14" name="Text 611"/>
           <p:cNvSpPr txBox="1"/>
           <p:nvPr/>
         </p:nvSpPr>
@@ -21249,22 +17980,30 @@
           </a:p>
         </p:txBody>
       </p:sp>
-      <p:graphicFrame>
-        <p:nvGraphicFramePr>
-          <p:cNvPr id="4" name="Seasonal against fast mover" descr=""/>
-          <p:cNvGraphicFramePr/>
-          <p:nvPr/>
-        </p:nvGraphicFramePr>
-        <p:xfrm>
-          <a:off x="457200" y="1188720"/>
-          <a:ext cx="5486400" cy="3246120"/>
-        </p:xfrm>
-        <a:graphic xmlns:a="http://schemas.openxmlformats.org/drawingml/2006/main">
-          <a:graphicData uri="http://schemas.openxmlformats.org/drawingml/2006/chart">
-            <c:chart xmlns:c="http://schemas.openxmlformats.org/drawingml/2006/chart" r:id="rId1"/>
-          </a:graphicData>
-        </a:graphic>
-      </p:graphicFrame>
+      <p:pic>
+        <p:nvPicPr>
+          <p:cNvPr id="4" name="Seasonal against fast mover" descr="Line graph of monthly orders for one seasonal SKU and one fast mover">    </p:cNvPr>
+          <p:cNvPicPr>
+            <a:picLocks noChangeAspect="1"/>
+          </p:cNvPicPr>
+          <p:nvPr/>
+        </p:nvPicPr>
+        <p:blipFill>
+          <a:blip r:embed="rId1"/>
+          <a:stretch>
+            <a:fillRect/>
+          </a:stretch>
+        </p:blipFill>
+        <p:spPr>
+          <a:xfrm>
+            <a:off x="457200" y="1188720"/>
+            <a:ext cx="5486400" cy="3246120"/>
+          </a:xfrm>
+          <a:prstGeom prst="rect">
+            <a:avLst/>
+          </a:prstGeom>
+        </p:spPr>
+      </p:pic>
       <p:sp>
         <p:nvSpPr>
           <p:cNvPr id="5" name="Badge 612"/>
@@ -22824,22 +19563,30 @@
           </a:p>
         </p:txBody>
       </p:sp>
-      <p:graphicFrame>
-        <p:nvGraphicFramePr>
-          <p:cNvPr id="17" name="Walk per pick" descr=""/>
-          <p:cNvGraphicFramePr/>
-          <p:nvPr/>
-        </p:nvGraphicFramePr>
-        <p:xfrm>
-          <a:off x="457200" y="2697480"/>
-          <a:ext cx="5394960" cy="1783080"/>
-        </p:xfrm>
-        <a:graphic xmlns:a="http://schemas.openxmlformats.org/drawingml/2006/main">
-          <a:graphicData uri="http://schemas.openxmlformats.org/drawingml/2006/chart">
-            <c:chart xmlns:c="http://schemas.openxmlformats.org/drawingml/2006/chart" r:id="rId1"/>
-          </a:graphicData>
-        </a:graphic>
-      </p:graphicFrame>
+      <p:pic>
+        <p:nvPicPr>
+          <p:cNvPr id="17" name="Walk per pick" descr="Bar graph: walk per pick is 63.8 metres with no grouping and 46.5 metres with K-Means zones">    </p:cNvPr>
+          <p:cNvPicPr>
+            <a:picLocks noChangeAspect="1"/>
+          </p:cNvPicPr>
+          <p:nvPr/>
+        </p:nvPicPr>
+        <p:blipFill>
+          <a:blip r:embed="rId1"/>
+          <a:stretch>
+            <a:fillRect/>
+          </a:stretch>
+        </p:blipFill>
+        <p:spPr>
+          <a:xfrm>
+            <a:off x="457200" y="2697480"/>
+            <a:ext cx="5394960" cy="1783080"/>
+          </a:xfrm>
+          <a:prstGeom prst="rect">
+            <a:avLst/>
+          </a:prstGeom>
+        </p:spPr>
+      </p:pic>
       <p:sp>
         <p:nvSpPr>
           <p:cNvPr id="18" name="Card 648"/>
@@ -32098,22 +28845,30 @@
           </a:p>
         </p:txBody>
       </p:sp>
-      <p:graphicFrame>
-        <p:nvGraphicFramePr>
-          <p:cNvPr id="13" name="Orders by month" descr=""/>
-          <p:cNvGraphicFramePr/>
-          <p:nvPr/>
-        </p:nvGraphicFramePr>
-        <p:xfrm>
-          <a:off x="457200" y="2194560"/>
-          <a:ext cx="8229600" cy="2377440"/>
-        </p:xfrm>
-        <a:graphic xmlns:a="http://schemas.openxmlformats.org/drawingml/2006/main">
-          <a:graphicData uri="http://schemas.openxmlformats.org/drawingml/2006/chart">
-            <c:chart xmlns:c="http://schemas.openxmlformats.org/drawingml/2006/chart" r:id="rId1"/>
-          </a:graphicData>
-        </a:graphic>
-      </p:graphicFrame>
+      <p:pic>
+        <p:nvPicPr>
+          <p:cNvPr id="13" name="Orders by month" descr="Bar graph of orders placed in each month, rising through 2017 and highest in November 2017">    </p:cNvPr>
+          <p:cNvPicPr>
+            <a:picLocks noChangeAspect="1"/>
+          </p:cNvPicPr>
+          <p:nvPr/>
+        </p:nvPicPr>
+        <p:blipFill>
+          <a:blip r:embed="rId1"/>
+          <a:stretch>
+            <a:fillRect/>
+          </a:stretch>
+        </p:blipFill>
+        <p:spPr>
+          <a:xfrm>
+            <a:off x="457200" y="2194560"/>
+            <a:ext cx="8229600" cy="2377440"/>
+          </a:xfrm>
+          <a:prstGeom prst="rect">
+            <a:avLst/>
+          </a:prstGeom>
+        </p:spPr>
+      </p:pic>
       <p:sp>
         <p:nvSpPr>
           <p:cNvPr id="25" name="Slide Number Placeholder 0"/>

</xml_diff>